<commit_message>
Sunum: gorsel formuller, net hipotez, acik topoloji slayti, tam IEEE kaynakca
- Tum formuller matplotlib ile LaTeX kalitesinde GORSEL olarak gomuldu
- Hipotez sade ve anlasilir yeniden yazildi
- Topolojiler tek slaytta tek tek aciklandi (pasif, Sallen-Key, MFB, KHN, Tow-Thomas, akim-modlu)
- Sonda 2 slaytlik tam IEEE kaynakca (20 kaynak)

https://claude.ai/code/session_012Z6u7LYkVNiDoU5RtS1RWf
</commit_message>
<xml_diff>
--- a/analog-filtre-tez/EEM537_Sunum_SelinACAR.pptx
+++ b/analog-filtre-tez/EEM537_Sunum_SelinACAR.pptx
@@ -32,6 +32,7 @@
     <p:sldId id="280" r:id="rId31"/>
     <p:sldId id="281" r:id="rId32"/>
     <p:sldId id="282" r:id="rId33"/>
+    <p:sldId id="283" r:id="rId34"/>
   </p:sldIdLst>
   <p:sldSz cx="12191695" cy="6858000" type="screen4x3"/>
   <p:notesSz cx="6858000" cy="9144000"/>
@@ -4405,18 +4406,18 @@
         </p:nvSpPr>
         <p:spPr>
           <a:xfrm>
-            <a:off x="731520" y="1417320"/>
-            <a:ext cx="10698480" cy="1005840"/>
+            <a:off x="1112367" y="1261872"/>
+            <a:ext cx="9966960" cy="2407964"/>
           </a:xfrm>
           <a:prstGeom prst="rect">
             <a:avLst/>
           </a:prstGeom>
           <a:solidFill>
-            <a:srgbClr val="F4F4F4"/>
+            <a:srgbClr val="F7F9FF"/>
           </a:solidFill>
-          <a:ln w="9525">
+          <a:ln w="12700">
             <a:solidFill>
-              <a:srgbClr val="CCCCCC"/>
+              <a:srgbClr val="D3DEF2"/>
             </a:solidFill>
           </a:ln>
           <a:effectLst/>
@@ -4436,43 +4437,47 @@
           </a:fontRef>
         </p:style>
         <p:txBody>
-          <a:bodyPr rtlCol="0" anchor="ctr" wrap="square" lIns="182880" tIns="73152"/>
+          <a:bodyPr rtlCol="0" anchor="ctr"/>
           <a:lstStyle/>
           <a:p>
             <a:pPr algn="ctr"/>
-            <a:r>
-              <a:rPr sz="1700" b="1">
-                <a:solidFill>
-                  <a:srgbClr val="1A1A6A"/>
-                </a:solidFill>
-                <a:latin typeface="Consolas"/>
-              </a:rPr>
-              <a:t>H(s) = N(s) / D(s)</a:t>
-            </a:r>
-          </a:p>
-          <a:p>
-            <a:r>
-              <a:rPr sz="1700" b="1">
-                <a:solidFill>
-                  <a:srgbClr val="1A1A6A"/>
-                </a:solidFill>
-                <a:latin typeface="Consolas"/>
-              </a:rPr>
-              <a:t>      = (b_m s^m + ... + b_0) / (a_n s^n + ... + a_0)</a:t>
-            </a:r>
-          </a:p>
-        </p:txBody>
-      </p:sp>
-      <p:sp>
-        <p:nvSpPr>
-          <p:cNvPr id="7" name="TextBox 6"/>
+          </a:p>
+        </p:txBody>
+      </p:sp>
+      <p:pic>
+        <p:nvPicPr>
+          <p:cNvPr id="7" name="Picture 6" descr="transfer.png"/>
+          <p:cNvPicPr>
+            <a:picLocks noChangeAspect="1"/>
+          </p:cNvPicPr>
+          <p:nvPr/>
+        </p:nvPicPr>
+        <p:blipFill>
+          <a:blip r:embed="rId2"/>
+          <a:stretch>
+            <a:fillRect/>
+          </a:stretch>
+        </p:blipFill>
+        <p:spPr>
+          <a:xfrm>
+            <a:off x="1295247" y="1371600"/>
+            <a:ext cx="9601200" cy="2188509"/>
+          </a:xfrm>
+          <a:prstGeom prst="rect">
+            <a:avLst/>
+          </a:prstGeom>
+        </p:spPr>
+      </p:pic>
+      <p:sp>
+        <p:nvSpPr>
+          <p:cNvPr id="8" name="TextBox 7"/>
           <p:cNvSpPr txBox="1"/>
           <p:nvPr/>
         </p:nvSpPr>
         <p:spPr>
           <a:xfrm>
-            <a:off x="731520" y="2743200"/>
-            <a:ext cx="10698480" cy="365760"/>
+            <a:off x="822960" y="3871004"/>
+            <a:ext cx="10515600" cy="365760"/>
           </a:xfrm>
           <a:prstGeom prst="rect">
             <a:avLst/>
@@ -4490,7 +4495,6 @@
                 <a:solidFill>
                   <a:srgbClr val="1A1A6A"/>
                 </a:solidFill>
-                <a:latin typeface="Calibri"/>
               </a:rPr>
               <a:t>Burada:</a:t>
             </a:r>
@@ -4499,14 +4503,14 @@
       </p:sp>
       <p:sp>
         <p:nvSpPr>
-          <p:cNvPr id="8" name="TextBox 7"/>
+          <p:cNvPr id="9" name="TextBox 8"/>
           <p:cNvSpPr txBox="1"/>
           <p:nvPr/>
         </p:nvSpPr>
         <p:spPr>
           <a:xfrm>
-            <a:off x="731520" y="3127248"/>
-            <a:ext cx="10698480" cy="2743200"/>
+            <a:off x="822960" y="4236764"/>
+            <a:ext cx="10515600" cy="2743200"/>
           </a:xfrm>
           <a:prstGeom prst="rect">
             <a:avLst/>
@@ -4531,7 +4535,7 @@
                 </a:solidFill>
                 <a:latin typeface="Consolas"/>
               </a:rPr>
-              <a:t>H(s) : </a:t>
+              <a:t>H(s)  :  </a:t>
             </a:r>
             <a:r>
               <a:rPr sz="1700">
@@ -4556,7 +4560,7 @@
                 </a:solidFill>
                 <a:latin typeface="Consolas"/>
               </a:rPr>
-              <a:t>s : </a:t>
+              <a:t>s  :  </a:t>
             </a:r>
             <a:r>
               <a:rPr sz="1700">
@@ -4565,7 +4569,7 @@
                 </a:solidFill>
                 <a:latin typeface="Calibri"/>
               </a:rPr>
-              <a:t>karmaşık frekans değişkeni (s = σ + jω)</a:t>
+              <a:t>karmaşık frekans (s = σ + jω)</a:t>
             </a:r>
           </a:p>
           <a:p>
@@ -4581,7 +4585,7 @@
                 </a:solidFill>
                 <a:latin typeface="Consolas"/>
               </a:rPr>
-              <a:t>N(s) : </a:t>
+              <a:t>N(s)  :  </a:t>
             </a:r>
             <a:r>
               <a:rPr sz="1700">
@@ -4606,7 +4610,7 @@
                 </a:solidFill>
                 <a:latin typeface="Consolas"/>
               </a:rPr>
-              <a:t>D(s) : </a:t>
+              <a:t>D(s)  :  </a:t>
             </a:r>
             <a:r>
               <a:rPr sz="1700">
@@ -4631,7 +4635,7 @@
                 </a:solidFill>
                 <a:latin typeface="Consolas"/>
               </a:rPr>
-              <a:t>n : </a:t>
+              <a:t>n  :  </a:t>
             </a:r>
             <a:r>
               <a:rPr sz="1700">
@@ -4641,45 +4645,6 @@
                 <a:latin typeface="Calibri"/>
               </a:rPr>
               <a:t>filtre derecesi → eğim = −20·n dB/dekad</a:t>
-            </a:r>
-          </a:p>
-        </p:txBody>
-      </p:sp>
-      <p:sp>
-        <p:nvSpPr>
-          <p:cNvPr id="9" name="TextBox 8"/>
-          <p:cNvSpPr txBox="1"/>
-          <p:nvPr/>
-        </p:nvSpPr>
-        <p:spPr>
-          <a:xfrm>
-            <a:off x="731520" y="5852160"/>
-            <a:ext cx="10698480" cy="548640"/>
-          </a:xfrm>
-          <a:prstGeom prst="rect">
-            <a:avLst/>
-          </a:prstGeom>
-          <a:noFill/>
-        </p:spPr>
-        <p:txBody>
-          <a:bodyPr wrap="square" anchor="t">
-            <a:spAutoFit/>
-          </a:bodyPr>
-          <a:lstStyle/>
-          <a:p>
-            <a:pPr algn="l">
-              <a:spcAft>
-                <a:spcPts val="500"/>
-              </a:spcAft>
-            </a:pPr>
-            <a:r>
-              <a:rPr sz="1600" b="1">
-                <a:solidFill>
-                  <a:srgbClr val="1A1A6A"/>
-                </a:solidFill>
-                <a:latin typeface="Calibri"/>
-              </a:rPr>
-              <a:t>Kutupların yeri filtrenin davranışını (kararlılık, Q, frekans) belirler.</a:t>
             </a:r>
           </a:p>
         </p:txBody>
@@ -4876,18 +4841,18 @@
         </p:nvSpPr>
         <p:spPr>
           <a:xfrm>
-            <a:off x="731520" y="1417320"/>
-            <a:ext cx="10698480" cy="1463040"/>
+            <a:off x="655167" y="1307592"/>
+            <a:ext cx="10881360" cy="1430752"/>
           </a:xfrm>
           <a:prstGeom prst="rect">
             <a:avLst/>
           </a:prstGeom>
           <a:solidFill>
-            <a:srgbClr val="F4F4F4"/>
+            <a:srgbClr val="F7F9FF"/>
           </a:solidFill>
-          <a:ln w="9525">
+          <a:ln w="12700">
             <a:solidFill>
-              <a:srgbClr val="CCCCCC"/>
+              <a:srgbClr val="D3DEF2"/>
             </a:solidFill>
           </a:ln>
           <a:effectLst/>
@@ -4907,54 +4872,47 @@
           </a:fontRef>
         </p:style>
         <p:txBody>
-          <a:bodyPr rtlCol="0" anchor="ctr" wrap="square" lIns="182880" tIns="73152"/>
+          <a:bodyPr rtlCol="0" anchor="ctr"/>
           <a:lstStyle/>
           <a:p>
             <a:pPr algn="ctr"/>
-            <a:r>
-              <a:rPr sz="1700" b="1">
-                <a:solidFill>
-                  <a:srgbClr val="1A1A6A"/>
-                </a:solidFill>
-                <a:latin typeface="Consolas"/>
-              </a:rPr>
-              <a:t>Alçak geçiren:  H(s) = wc / (s + wc)</a:t>
-            </a:r>
-          </a:p>
-          <a:p>
-            <a:r>
-              <a:rPr sz="1700" b="1">
-                <a:solidFill>
-                  <a:srgbClr val="1A1A6A"/>
-                </a:solidFill>
-                <a:latin typeface="Consolas"/>
-              </a:rPr>
-              <a:t>Yüksek geçiren: H(s) = s / (s + wc)</a:t>
-            </a:r>
-          </a:p>
-          <a:p>
-            <a:r>
-              <a:rPr sz="1700" b="1">
-                <a:solidFill>
-                  <a:srgbClr val="1A1A6A"/>
-                </a:solidFill>
-                <a:latin typeface="Consolas"/>
-              </a:rPr>
-              <a:t>wc = 1 / (R*C)</a:t>
-            </a:r>
-          </a:p>
-        </p:txBody>
-      </p:sp>
-      <p:sp>
-        <p:nvSpPr>
-          <p:cNvPr id="7" name="TextBox 6"/>
+          </a:p>
+        </p:txBody>
+      </p:sp>
+      <p:pic>
+        <p:nvPicPr>
+          <p:cNvPr id="7" name="Picture 6" descr="o1.png"/>
+          <p:cNvPicPr>
+            <a:picLocks noChangeAspect="1"/>
+          </p:cNvPicPr>
+          <p:nvPr/>
+        </p:nvPicPr>
+        <p:blipFill>
+          <a:blip r:embed="rId2"/>
+          <a:stretch>
+            <a:fillRect/>
+          </a:stretch>
+        </p:blipFill>
+        <p:spPr>
+          <a:xfrm>
+            <a:off x="838047" y="1417320"/>
+            <a:ext cx="10515600" cy="1211297"/>
+          </a:xfrm>
+          <a:prstGeom prst="rect">
+            <a:avLst/>
+          </a:prstGeom>
+        </p:spPr>
+      </p:pic>
+      <p:sp>
+        <p:nvSpPr>
+          <p:cNvPr id="8" name="TextBox 7"/>
           <p:cNvSpPr txBox="1"/>
           <p:nvPr/>
         </p:nvSpPr>
         <p:spPr>
           <a:xfrm>
-            <a:off x="731520" y="3200400"/>
-            <a:ext cx="10698480" cy="365760"/>
+            <a:off x="822960" y="2985232"/>
+            <a:ext cx="10515600" cy="365760"/>
           </a:xfrm>
           <a:prstGeom prst="rect">
             <a:avLst/>
@@ -4972,7 +4930,6 @@
                 <a:solidFill>
                   <a:srgbClr val="1A1A6A"/>
                 </a:solidFill>
-                <a:latin typeface="Calibri"/>
               </a:rPr>
               <a:t>Burada:</a:t>
             </a:r>
@@ -4981,14 +4938,14 @@
       </p:sp>
       <p:sp>
         <p:nvSpPr>
-          <p:cNvPr id="8" name="TextBox 7"/>
+          <p:cNvPr id="9" name="TextBox 8"/>
           <p:cNvSpPr txBox="1"/>
           <p:nvPr/>
         </p:nvSpPr>
         <p:spPr>
           <a:xfrm>
-            <a:off x="731520" y="3584448"/>
-            <a:ext cx="10698480" cy="2743200"/>
+            <a:off x="822960" y="3350992"/>
+            <a:ext cx="10515600" cy="2743200"/>
           </a:xfrm>
           <a:prstGeom prst="rect">
             <a:avLst/>
@@ -5013,7 +4970,7 @@
                 </a:solidFill>
                 <a:latin typeface="Consolas"/>
               </a:rPr>
-              <a:t>wc : </a:t>
+              <a:t>ω_c  :  </a:t>
             </a:r>
             <a:r>
               <a:rPr sz="1700">
@@ -5038,7 +4995,7 @@
                 </a:solidFill>
                 <a:latin typeface="Consolas"/>
               </a:rPr>
-              <a:t>R : </a:t>
+              <a:t>R  :  </a:t>
             </a:r>
             <a:r>
               <a:rPr sz="1700">
@@ -5063,7 +5020,7 @@
                 </a:solidFill>
                 <a:latin typeface="Consolas"/>
               </a:rPr>
-              <a:t>C : </a:t>
+              <a:t>C  :  </a:t>
             </a:r>
             <a:r>
               <a:rPr sz="1700">
@@ -5088,7 +5045,7 @@
                 </a:solidFill>
                 <a:latin typeface="Consolas"/>
               </a:rPr>
-              <a:t>s : </a:t>
+              <a:t>s  :  </a:t>
             </a:r>
             <a:r>
               <a:rPr sz="1700">
@@ -5104,14 +5061,14 @@
       </p:sp>
       <p:sp>
         <p:nvSpPr>
-          <p:cNvPr id="9" name="TextBox 8"/>
+          <p:cNvPr id="10" name="TextBox 9"/>
           <p:cNvSpPr txBox="1"/>
           <p:nvPr/>
         </p:nvSpPr>
         <p:spPr>
           <a:xfrm>
-            <a:off x="731520" y="5486400"/>
-            <a:ext cx="10698480" cy="822960"/>
+            <a:off x="822960" y="5303520"/>
+            <a:ext cx="10515600" cy="640080"/>
           </a:xfrm>
           <a:prstGeom prst="rect">
             <a:avLst/>
@@ -5333,18 +5290,18 @@
         </p:nvSpPr>
         <p:spPr>
           <a:xfrm>
-            <a:off x="731520" y="1371600"/>
-            <a:ext cx="10698480" cy="1097280"/>
+            <a:off x="1112367" y="1261872"/>
+            <a:ext cx="9966960" cy="2842699"/>
           </a:xfrm>
           <a:prstGeom prst="rect">
             <a:avLst/>
           </a:prstGeom>
           <a:solidFill>
-            <a:srgbClr val="F4F4F4"/>
+            <a:srgbClr val="F7F9FF"/>
           </a:solidFill>
-          <a:ln w="9525">
+          <a:ln w="12700">
             <a:solidFill>
-              <a:srgbClr val="CCCCCC"/>
+              <a:srgbClr val="D3DEF2"/>
             </a:solidFill>
           </a:ln>
           <a:effectLst/>
@@ -5364,43 +5321,47 @@
           </a:fontRef>
         </p:style>
         <p:txBody>
-          <a:bodyPr rtlCol="0" anchor="ctr" wrap="square" lIns="182880" tIns="73152"/>
+          <a:bodyPr rtlCol="0" anchor="ctr"/>
           <a:lstStyle/>
           <a:p>
             <a:pPr algn="ctr"/>
-            <a:r>
-              <a:rPr sz="1700" b="1">
-                <a:solidFill>
-                  <a:srgbClr val="1A1A6A"/>
-                </a:solidFill>
-                <a:latin typeface="Consolas"/>
-              </a:rPr>
-              <a:t>H(s) = wo^2 / ( s^2 + (wo/Q) s + wo^2 )</a:t>
-            </a:r>
-          </a:p>
-          <a:p>
-            <a:r>
-              <a:rPr sz="1700" b="1">
-                <a:solidFill>
-                  <a:srgbClr val="1A1A6A"/>
-                </a:solidFill>
-                <a:latin typeface="Consolas"/>
-              </a:rPr>
-              <a:t>zeta = 1 / (2Q)   ;   Q = 0.707 -&gt; Butterworth</a:t>
-            </a:r>
-          </a:p>
-        </p:txBody>
-      </p:sp>
-      <p:sp>
-        <p:nvSpPr>
-          <p:cNvPr id="7" name="TextBox 6"/>
+          </a:p>
+        </p:txBody>
+      </p:sp>
+      <p:pic>
+        <p:nvPicPr>
+          <p:cNvPr id="7" name="Picture 6" descr="o2.png"/>
+          <p:cNvPicPr>
+            <a:picLocks noChangeAspect="1"/>
+          </p:cNvPicPr>
+          <p:nvPr/>
+        </p:nvPicPr>
+        <p:blipFill>
+          <a:blip r:embed="rId2"/>
+          <a:stretch>
+            <a:fillRect/>
+          </a:stretch>
+        </p:blipFill>
+        <p:spPr>
+          <a:xfrm>
+            <a:off x="1295247" y="1371600"/>
+            <a:ext cx="9601200" cy="2623243"/>
+          </a:xfrm>
+          <a:prstGeom prst="rect">
+            <a:avLst/>
+          </a:prstGeom>
+        </p:spPr>
+      </p:pic>
+      <p:sp>
+        <p:nvSpPr>
+          <p:cNvPr id="8" name="TextBox 7"/>
           <p:cNvSpPr txBox="1"/>
           <p:nvPr/>
         </p:nvSpPr>
         <p:spPr>
           <a:xfrm>
-            <a:off x="731520" y="2743200"/>
-            <a:ext cx="10698480" cy="365760"/>
+            <a:off x="822960" y="4305739"/>
+            <a:ext cx="10515600" cy="365760"/>
           </a:xfrm>
           <a:prstGeom prst="rect">
             <a:avLst/>
@@ -5418,7 +5379,6 @@
                 <a:solidFill>
                   <a:srgbClr val="1A1A6A"/>
                 </a:solidFill>
-                <a:latin typeface="Calibri"/>
               </a:rPr>
               <a:t>Burada:</a:t>
             </a:r>
@@ -5427,14 +5387,14 @@
       </p:sp>
       <p:sp>
         <p:nvSpPr>
-          <p:cNvPr id="8" name="TextBox 7"/>
+          <p:cNvPr id="9" name="TextBox 8"/>
           <p:cNvSpPr txBox="1"/>
           <p:nvPr/>
         </p:nvSpPr>
         <p:spPr>
           <a:xfrm>
-            <a:off x="731520" y="3127248"/>
-            <a:ext cx="10698480" cy="2743200"/>
+            <a:off x="822960" y="4671499"/>
+            <a:ext cx="10515600" cy="2743200"/>
           </a:xfrm>
           <a:prstGeom prst="rect">
             <a:avLst/>
@@ -5459,7 +5419,7 @@
                 </a:solidFill>
                 <a:latin typeface="Consolas"/>
               </a:rPr>
-              <a:t>wo : </a:t>
+              <a:t>ω_0  :  </a:t>
             </a:r>
             <a:r>
               <a:rPr sz="1700">
@@ -5484,7 +5444,7 @@
                 </a:solidFill>
                 <a:latin typeface="Consolas"/>
               </a:rPr>
-              <a:t>Q : </a:t>
+              <a:t>Q  :  </a:t>
             </a:r>
             <a:r>
               <a:rPr sz="1700">
@@ -5509,7 +5469,7 @@
                 </a:solidFill>
                 <a:latin typeface="Consolas"/>
               </a:rPr>
-              <a:t>zeta : </a:t>
+              <a:t>ζ  :  </a:t>
             </a:r>
             <a:r>
               <a:rPr sz="1700">
@@ -5534,7 +5494,7 @@
                 </a:solidFill>
                 <a:latin typeface="Consolas"/>
               </a:rPr>
-              <a:t>s : </a:t>
+              <a:t>s  :  </a:t>
             </a:r>
             <a:r>
               <a:rPr sz="1700">
@@ -5550,14 +5510,14 @@
       </p:sp>
       <p:sp>
         <p:nvSpPr>
-          <p:cNvPr id="9" name="TextBox 8"/>
+          <p:cNvPr id="10" name="TextBox 9"/>
           <p:cNvSpPr txBox="1"/>
           <p:nvPr/>
         </p:nvSpPr>
         <p:spPr>
           <a:xfrm>
-            <a:off x="731520" y="5394960"/>
-            <a:ext cx="10698480" cy="914400"/>
+            <a:off x="822960" y="5394960"/>
+            <a:ext cx="10515600" cy="822960"/>
           </a:xfrm>
           <a:prstGeom prst="rect">
             <a:avLst/>
@@ -5598,7 +5558,7 @@
                 </a:solidFill>
                 <a:latin typeface="Calibri"/>
               </a:rPr>
-              <a:t>Yüksek dereceli filtreler bu 2. derece bloklarının kaskadıyla kurulur.</a:t>
+              <a:t>Yüksek dereceli filtreler bu 2. derece blokların kaskadıyla kurulur.</a:t>
             </a:r>
           </a:p>
         </p:txBody>
@@ -5795,18 +5755,18 @@
         </p:nvSpPr>
         <p:spPr>
           <a:xfrm>
-            <a:off x="731520" y="1417320"/>
-            <a:ext cx="10698480" cy="1188720"/>
+            <a:off x="1112367" y="1307592"/>
+            <a:ext cx="9966960" cy="3003113"/>
           </a:xfrm>
           <a:prstGeom prst="rect">
             <a:avLst/>
           </a:prstGeom>
           <a:solidFill>
-            <a:srgbClr val="F4F4F4"/>
+            <a:srgbClr val="F7F9FF"/>
           </a:solidFill>
-          <a:ln w="9525">
+          <a:ln w="12700">
             <a:solidFill>
-              <a:srgbClr val="CCCCCC"/>
+              <a:srgbClr val="D3DEF2"/>
             </a:solidFill>
           </a:ln>
           <a:effectLst/>
@@ -5826,43 +5786,47 @@
           </a:fontRef>
         </p:style>
         <p:txBody>
-          <a:bodyPr rtlCol="0" anchor="ctr" wrap="square" lIns="182880" tIns="73152"/>
+          <a:bodyPr rtlCol="0" anchor="ctr"/>
           <a:lstStyle/>
           <a:p>
             <a:pPr algn="ctr"/>
-            <a:r>
-              <a:rPr sz="1600" b="1">
-                <a:solidFill>
-                  <a:srgbClr val="1A1A6A"/>
-                </a:solidFill>
-                <a:latin typeface="Consolas"/>
-              </a:rPr>
-              <a:t>H(s) = [ wa/(s+wa) ] x [ wo^2 / (s^2 + (wo/Q)s + wo^2) ]</a:t>
-            </a:r>
-          </a:p>
-          <a:p>
-            <a:r>
-              <a:rPr sz="1600" b="1">
-                <a:solidFill>
-                  <a:srgbClr val="1A1A6A"/>
-                </a:solidFill>
-                <a:latin typeface="Consolas"/>
-              </a:rPr>
-              <a:t>Butterworth (n=3, wc=1) kutuplari: -1 , -0.5 +/- j0.866</a:t>
-            </a:r>
-          </a:p>
-        </p:txBody>
-      </p:sp>
-      <p:sp>
-        <p:nvSpPr>
-          <p:cNvPr id="7" name="TextBox 6"/>
+          </a:p>
+        </p:txBody>
+      </p:sp>
+      <p:pic>
+        <p:nvPicPr>
+          <p:cNvPr id="7" name="Picture 6" descr="o3.png"/>
+          <p:cNvPicPr>
+            <a:picLocks noChangeAspect="1"/>
+          </p:cNvPicPr>
+          <p:nvPr/>
+        </p:nvPicPr>
+        <p:blipFill>
+          <a:blip r:embed="rId2"/>
+          <a:stretch>
+            <a:fillRect/>
+          </a:stretch>
+        </p:blipFill>
+        <p:spPr>
+          <a:xfrm>
+            <a:off x="1295247" y="1417320"/>
+            <a:ext cx="9601200" cy="2783657"/>
+          </a:xfrm>
+          <a:prstGeom prst="rect">
+            <a:avLst/>
+          </a:prstGeom>
+        </p:spPr>
+      </p:pic>
+      <p:sp>
+        <p:nvSpPr>
+          <p:cNvPr id="8" name="TextBox 7"/>
           <p:cNvSpPr txBox="1"/>
           <p:nvPr/>
         </p:nvSpPr>
         <p:spPr>
           <a:xfrm>
-            <a:off x="731520" y="2926080"/>
-            <a:ext cx="10698480" cy="365760"/>
+            <a:off x="822960" y="4557593"/>
+            <a:ext cx="10515600" cy="365760"/>
           </a:xfrm>
           <a:prstGeom prst="rect">
             <a:avLst/>
@@ -5880,7 +5844,6 @@
                 <a:solidFill>
                   <a:srgbClr val="1A1A6A"/>
                 </a:solidFill>
-                <a:latin typeface="Calibri"/>
               </a:rPr>
               <a:t>Burada:</a:t>
             </a:r>
@@ -5889,14 +5852,14 @@
       </p:sp>
       <p:sp>
         <p:nvSpPr>
-          <p:cNvPr id="8" name="TextBox 7"/>
+          <p:cNvPr id="9" name="TextBox 8"/>
           <p:cNvSpPr txBox="1"/>
           <p:nvPr/>
         </p:nvSpPr>
         <p:spPr>
           <a:xfrm>
-            <a:off x="731520" y="3310128"/>
-            <a:ext cx="10698480" cy="2743200"/>
+            <a:off x="822960" y="4923353"/>
+            <a:ext cx="10515600" cy="2743200"/>
           </a:xfrm>
           <a:prstGeom prst="rect">
             <a:avLst/>
@@ -5921,7 +5884,7 @@
                 </a:solidFill>
                 <a:latin typeface="Consolas"/>
               </a:rPr>
-              <a:t>wa : </a:t>
+              <a:t>ω_a  :  </a:t>
             </a:r>
             <a:r>
               <a:rPr sz="1700">
@@ -5946,7 +5909,7 @@
                 </a:solidFill>
                 <a:latin typeface="Consolas"/>
               </a:rPr>
-              <a:t>wo, Q : </a:t>
+              <a:t>ω_0, Q  :  </a:t>
             </a:r>
             <a:r>
               <a:rPr sz="1700">
@@ -5971,7 +5934,7 @@
                 </a:solidFill>
                 <a:latin typeface="Consolas"/>
               </a:rPr>
-              <a:t>j : </a:t>
+              <a:t>j  :  </a:t>
             </a:r>
             <a:r>
               <a:rPr sz="1700">
@@ -5987,14 +5950,14 @@
       </p:sp>
       <p:sp>
         <p:nvSpPr>
-          <p:cNvPr id="9" name="TextBox 8"/>
+          <p:cNvPr id="10" name="TextBox 9"/>
           <p:cNvSpPr txBox="1"/>
           <p:nvPr/>
         </p:nvSpPr>
         <p:spPr>
           <a:xfrm>
-            <a:off x="731520" y="5120640"/>
-            <a:ext cx="10698480" cy="914400"/>
+            <a:off x="822960" y="5212080"/>
+            <a:ext cx="10515600" cy="822960"/>
           </a:xfrm>
           <a:prstGeom prst="rect">
             <a:avLst/>
@@ -6019,7 +5982,7 @@
                 </a:solidFill>
                 <a:latin typeface="Calibri"/>
               </a:rPr>
-              <a:t>1 reel kutup + 1 karmaşık kutup çifti = 3. derece, eğim −60 dB/dek.</a:t>
+              <a:t>1 reel kutup + 1 karmaşık çift = 3. derece, eğim −60 dB/dek.</a:t>
             </a:r>
           </a:p>
           <a:p>
@@ -6232,18 +6195,18 @@
         </p:nvSpPr>
         <p:spPr>
           <a:xfrm>
-            <a:off x="731520" y="1371600"/>
-            <a:ext cx="10698480" cy="1554480"/>
+            <a:off x="883767" y="1216152"/>
+            <a:ext cx="10424160" cy="5134281"/>
           </a:xfrm>
           <a:prstGeom prst="rect">
             <a:avLst/>
           </a:prstGeom>
           <a:solidFill>
-            <a:srgbClr val="F4F4F4"/>
+            <a:srgbClr val="F7F9FF"/>
           </a:solidFill>
-          <a:ln w="9525">
+          <a:ln w="12700">
             <a:solidFill>
-              <a:srgbClr val="CCCCCC"/>
+              <a:srgbClr val="D3DEF2"/>
             </a:solidFill>
           </a:ln>
           <a:effectLst/>
@@ -6263,54 +6226,47 @@
           </a:fontRef>
         </p:style>
         <p:txBody>
-          <a:bodyPr rtlCol="0" anchor="ctr" wrap="square" lIns="182880" tIns="73152"/>
+          <a:bodyPr rtlCol="0" anchor="ctr"/>
           <a:lstStyle/>
           <a:p>
             <a:pPr algn="ctr"/>
-            <a:r>
-              <a:rPr sz="1500" b="1">
-                <a:solidFill>
-                  <a:srgbClr val="1A1A6A"/>
-                </a:solidFill>
-                <a:latin typeface="Consolas"/>
-              </a:rPr>
-              <a:t>Kesirli kapasitor (CPE):  Z(s) = 1 / (C_a * s^a)   ,  faz = -a*90</a:t>
-            </a:r>
-          </a:p>
-          <a:p>
-            <a:r>
-              <a:rPr sz="1500" b="1">
-                <a:solidFill>
-                  <a:srgbClr val="1A1A6A"/>
-                </a:solidFill>
-                <a:latin typeface="Consolas"/>
-              </a:rPr>
-              <a:t>Kesirli 1. derece:  H(s) = 1 / ( tau * s^a + 1 )</a:t>
-            </a:r>
-          </a:p>
-          <a:p>
-            <a:r>
-              <a:rPr sz="1500" b="1">
-                <a:solidFill>
-                  <a:srgbClr val="1A1A6A"/>
-                </a:solidFill>
-                <a:latin typeface="Consolas"/>
-              </a:rPr>
-              <a:t>Kararlilik (Matignon):  |arg(w)| &gt; a*pi/2 ,  w = s^a</a:t>
-            </a:r>
-          </a:p>
-        </p:txBody>
-      </p:sp>
-      <p:sp>
-        <p:nvSpPr>
-          <p:cNvPr id="7" name="TextBox 6"/>
+          </a:p>
+        </p:txBody>
+      </p:sp>
+      <p:pic>
+        <p:nvPicPr>
+          <p:cNvPr id="7" name="Picture 6" descr="frac.png"/>
+          <p:cNvPicPr>
+            <a:picLocks noChangeAspect="1"/>
+          </p:cNvPicPr>
+          <p:nvPr/>
+        </p:nvPicPr>
+        <p:blipFill>
+          <a:blip r:embed="rId2"/>
+          <a:stretch>
+            <a:fillRect/>
+          </a:stretch>
+        </p:blipFill>
+        <p:spPr>
+          <a:xfrm>
+            <a:off x="1066647" y="1325880"/>
+            <a:ext cx="10058400" cy="4914826"/>
+          </a:xfrm>
+          <a:prstGeom prst="rect">
+            <a:avLst/>
+          </a:prstGeom>
+        </p:spPr>
+      </p:pic>
+      <p:sp>
+        <p:nvSpPr>
+          <p:cNvPr id="8" name="TextBox 7"/>
           <p:cNvSpPr txBox="1"/>
           <p:nvPr/>
         </p:nvSpPr>
         <p:spPr>
           <a:xfrm>
-            <a:off x="731520" y="3108960"/>
-            <a:ext cx="10698480" cy="365760"/>
+            <a:off x="822960" y="6505881"/>
+            <a:ext cx="10515600" cy="365760"/>
           </a:xfrm>
           <a:prstGeom prst="rect">
             <a:avLst/>
@@ -6324,11 +6280,10 @@
           <a:lstStyle/>
           <a:p>
             <a:r>
-              <a:rPr b="1" sz="1500">
+              <a:rPr b="1" sz="1400">
                 <a:solidFill>
                   <a:srgbClr val="1A1A6A"/>
                 </a:solidFill>
-                <a:latin typeface="Calibri"/>
               </a:rPr>
               <a:t>Burada:</a:t>
             </a:r>
@@ -6337,14 +6292,14 @@
       </p:sp>
       <p:sp>
         <p:nvSpPr>
-          <p:cNvPr id="8" name="TextBox 7"/>
+          <p:cNvPr id="9" name="TextBox 8"/>
           <p:cNvSpPr txBox="1"/>
           <p:nvPr/>
         </p:nvSpPr>
         <p:spPr>
           <a:xfrm>
-            <a:off x="731520" y="3493008"/>
-            <a:ext cx="10698480" cy="2743200"/>
+            <a:off x="822960" y="6871641"/>
+            <a:ext cx="10515600" cy="2743200"/>
           </a:xfrm>
           <a:prstGeom prst="rect">
             <a:avLst/>
@@ -6363,16 +6318,16 @@
               </a:spcAft>
             </a:pPr>
             <a:r>
-              <a:rPr b="1" sz="1500">
+              <a:rPr b="1" sz="1400">
                 <a:solidFill>
                   <a:srgbClr val="1B6B3A"/>
                 </a:solidFill>
                 <a:latin typeface="Consolas"/>
               </a:rPr>
-              <a:t>a (alfa) : </a:t>
-            </a:r>
-            <a:r>
-              <a:rPr sz="1500">
+              <a:t>α  :  </a:t>
+            </a:r>
+            <a:r>
+              <a:rPr sz="1400">
                 <a:solidFill>
                   <a:srgbClr val="333333"/>
                 </a:solidFill>
@@ -6388,22 +6343,22 @@
               </a:spcAft>
             </a:pPr>
             <a:r>
-              <a:rPr b="1" sz="1500">
+              <a:rPr b="1" sz="1400">
                 <a:solidFill>
                   <a:srgbClr val="1B6B3A"/>
                 </a:solidFill>
                 <a:latin typeface="Consolas"/>
               </a:rPr>
-              <a:t>C_a : </a:t>
-            </a:r>
-            <a:r>
-              <a:rPr sz="1500">
-                <a:solidFill>
-                  <a:srgbClr val="333333"/>
-                </a:solidFill>
-                <a:latin typeface="Calibri"/>
-              </a:rPr>
-              <a:t>kesirli kapasite / "fractance" elemanı</a:t>
+              <a:t>C_α  :  </a:t>
+            </a:r>
+            <a:r>
+              <a:rPr sz="1400">
+                <a:solidFill>
+                  <a:srgbClr val="333333"/>
+                </a:solidFill>
+                <a:latin typeface="Calibri"/>
+              </a:rPr>
+              <a:t>kesirli kapasite / "fractance"</a:t>
             </a:r>
           </a:p>
           <a:p>
@@ -6413,16 +6368,16 @@
               </a:spcAft>
             </a:pPr>
             <a:r>
-              <a:rPr b="1" sz="1500">
+              <a:rPr b="1" sz="1400">
                 <a:solidFill>
                   <a:srgbClr val="1B6B3A"/>
                 </a:solidFill>
                 <a:latin typeface="Consolas"/>
               </a:rPr>
-              <a:t>tau : </a:t>
-            </a:r>
-            <a:r>
-              <a:rPr sz="1500">
+              <a:t>τ  :  </a:t>
+            </a:r>
+            <a:r>
+              <a:rPr sz="1400">
                 <a:solidFill>
                   <a:srgbClr val="333333"/>
                 </a:solidFill>
@@ -6438,16 +6393,16 @@
               </a:spcAft>
             </a:pPr>
             <a:r>
-              <a:rPr b="1" sz="1500">
+              <a:rPr b="1" sz="1400">
                 <a:solidFill>
                   <a:srgbClr val="1B6B3A"/>
                 </a:solidFill>
                 <a:latin typeface="Consolas"/>
               </a:rPr>
-              <a:t>s^a : </a:t>
-            </a:r>
-            <a:r>
-              <a:rPr sz="1500">
+              <a:t>s^α  :  </a:t>
+            </a:r>
+            <a:r>
+              <a:rPr sz="1400">
                 <a:solidFill>
                   <a:srgbClr val="333333"/>
                 </a:solidFill>
@@ -6463,16 +6418,16 @@
               </a:spcAft>
             </a:pPr>
             <a:r>
-              <a:rPr b="1" sz="1500">
+              <a:rPr b="1" sz="1400">
                 <a:solidFill>
                   <a:srgbClr val="1B6B3A"/>
                 </a:solidFill>
                 <a:latin typeface="Consolas"/>
               </a:rPr>
-              <a:t>w : </a:t>
-            </a:r>
-            <a:r>
-              <a:rPr sz="1500">
+              <a:t>w  :  </a:t>
+            </a:r>
+            <a:r>
+              <a:rPr sz="1400">
                 <a:solidFill>
                   <a:srgbClr val="333333"/>
                 </a:solidFill>
@@ -6485,14 +6440,14 @@
       </p:sp>
       <p:sp>
         <p:nvSpPr>
-          <p:cNvPr id="9" name="TextBox 8"/>
+          <p:cNvPr id="10" name="TextBox 9"/>
           <p:cNvSpPr txBox="1"/>
           <p:nvPr/>
         </p:nvSpPr>
         <p:spPr>
           <a:xfrm>
-            <a:off x="731520" y="5943600"/>
-            <a:ext cx="10698480" cy="457200"/>
+            <a:off x="822960" y="5989320"/>
+            <a:ext cx="10515600" cy="457200"/>
           </a:xfrm>
           <a:prstGeom prst="rect">
             <a:avLst/>
@@ -6511,7 +6466,7 @@
               </a:spcAft>
             </a:pPr>
             <a:r>
-              <a:rPr sz="1500" b="1">
+              <a:rPr sz="1400" b="1">
                 <a:solidFill>
                   <a:srgbClr val="1A1A6A"/>
                 </a:solidFill>
@@ -6662,7 +6617,7 @@
                 </a:solidFill>
                 <a:latin typeface="Calibri"/>
               </a:rPr>
-              <a:t>7. Filtre Topolojileri</a:t>
+              <a:t>7. Filtre Topolojileri (Gerçekleme Yapıları)</a:t>
             </a:r>
           </a:p>
         </p:txBody>
@@ -6714,7 +6669,46 @@
         </p:nvSpPr>
         <p:spPr>
           <a:xfrm>
-            <a:off x="640080" y="1325880"/>
+            <a:off x="640080" y="1143000"/>
+            <a:ext cx="10972800" cy="457200"/>
+          </a:xfrm>
+          <a:prstGeom prst="rect">
+            <a:avLst/>
+          </a:prstGeom>
+          <a:noFill/>
+        </p:spPr>
+        <p:txBody>
+          <a:bodyPr wrap="square" anchor="t">
+            <a:spAutoFit/>
+          </a:bodyPr>
+          <a:lstStyle/>
+          <a:p>
+            <a:pPr algn="l">
+              <a:spcAft>
+                <a:spcPts val="500"/>
+              </a:spcAft>
+            </a:pPr>
+            <a:r>
+              <a:rPr sz="1700" b="1">
+                <a:solidFill>
+                  <a:srgbClr val="1A1A6A"/>
+                </a:solidFill>
+                <a:latin typeface="Calibri"/>
+              </a:rPr>
+              <a:t>Aynı transfer fonksiyonu farklı devre yapılarıyla (topoloji) kurulabilir:</a:t>
+            </a:r>
+          </a:p>
+        </p:txBody>
+      </p:sp>
+      <p:sp>
+        <p:nvSpPr>
+          <p:cNvPr id="7" name="TextBox 6"/>
+          <p:cNvSpPr txBox="1"/>
+          <p:nvPr/>
+        </p:nvSpPr>
+        <p:spPr>
+          <a:xfrm>
+            <a:off x="640080" y="1645920"/>
             <a:ext cx="10972800" cy="4846320"/>
           </a:xfrm>
           <a:prstGeom prst="rect">
@@ -6734,13 +6728,13 @@
               </a:spcAft>
             </a:pPr>
             <a:r>
-              <a:rPr sz="1900">
-                <a:solidFill>
-                  <a:srgbClr val="333333"/>
-                </a:solidFill>
-                <a:latin typeface="Calibri"/>
-              </a:rPr>
-              <a:t>•  Pasif: R, L, C — güç gerektirmez; indüktör hacmi dezavantaj.</a:t>
+              <a:rPr sz="1800">
+                <a:solidFill>
+                  <a:srgbClr val="333333"/>
+                </a:solidFill>
+                <a:latin typeface="Calibri"/>
+              </a:rPr>
+              <a:t>•  Pasif (R, L, C): dış güç yok, çok düşük gürültü; ama kazanç &lt; 1 ve bobin hacimli.</a:t>
             </a:r>
           </a:p>
           <a:p>
@@ -6750,13 +6744,77 @@
               </a:spcAft>
             </a:pPr>
             <a:r>
-              <a:rPr sz="1900">
-                <a:solidFill>
-                  <a:srgbClr val="333333"/>
-                </a:solidFill>
-                <a:latin typeface="Calibri"/>
-              </a:rPr>
-              <a:t>•  Aktif (op-amp tabanlı):</a:t>
+              <a:rPr sz="1800">
+                <a:solidFill>
+                  <a:srgbClr val="333333"/>
+                </a:solidFill>
+                <a:latin typeface="Calibri"/>
+              </a:rPr>
+              <a:t>•  Sallen-Key: tek op-amp ile 2. derece blok; kurması kolay, düşük Q için ideal.</a:t>
+            </a:r>
+          </a:p>
+          <a:p>
+            <a:pPr>
+              <a:spcAft>
+                <a:spcPts val="700"/>
+              </a:spcAft>
+            </a:pPr>
+            <a:r>
+              <a:rPr sz="1800">
+                <a:solidFill>
+                  <a:srgbClr val="333333"/>
+                </a:solidFill>
+                <a:latin typeface="Calibri"/>
+              </a:rPr>
+              <a:t>•  Çok geri beslemeli (MFB): tek op-amp, ters çevirir; yüksek frekansta daha iyi davranır.</a:t>
+            </a:r>
+          </a:p>
+          <a:p>
+            <a:pPr>
+              <a:spcAft>
+                <a:spcPts val="700"/>
+              </a:spcAft>
+            </a:pPr>
+            <a:r>
+              <a:rPr sz="1800">
+                <a:solidFill>
+                  <a:srgbClr val="333333"/>
+                </a:solidFill>
+                <a:latin typeface="Calibri"/>
+              </a:rPr>
+              <a:t>•  KHN / durum-değişkenli: 2-3 op-amp; aynı anda LPF+HPF+BPF verir, yüksek Q, DÜŞÜK duyarlılık.</a:t>
+            </a:r>
+          </a:p>
+          <a:p>
+            <a:pPr>
+              <a:spcAft>
+                <a:spcPts val="700"/>
+              </a:spcAft>
+            </a:pPr>
+            <a:r>
+              <a:rPr sz="1800">
+                <a:solidFill>
+                  <a:srgbClr val="333333"/>
+                </a:solidFill>
+                <a:latin typeface="Calibri"/>
+              </a:rPr>
+              <a:t>•  Tow-Thomas: 3 op-amp; ωₒ ve Q’yu BAĞIMSIZ ayarlama, üretime karşı sağlam.</a:t>
+            </a:r>
+          </a:p>
+          <a:p>
+            <a:pPr>
+              <a:spcAft>
+                <a:spcPts val="700"/>
+              </a:spcAft>
+            </a:pPr>
+            <a:r>
+              <a:rPr sz="1800">
+                <a:solidFill>
+                  <a:srgbClr val="333333"/>
+                </a:solidFill>
+                <a:latin typeface="Calibri"/>
+              </a:rPr>
+              <a:t>•  Akım/gerilim-modlu (OTA-C, CCII, VCII): op-amp yerine akım taşıyıcı; elektronik ayarlı,</a:t>
             </a:r>
           </a:p>
           <a:p>
@@ -6766,77 +6824,13 @@
               </a:spcAft>
             </a:pPr>
             <a:r>
-              <a:rPr sz="1700">
-                <a:solidFill>
-                  <a:srgbClr val="333333"/>
-                </a:solidFill>
-                <a:latin typeface="Calibri"/>
-              </a:rPr>
-              <a:t>–  Sallen-Key (1955): basit, düşük Q için kararlı</a:t>
-            </a:r>
-          </a:p>
-          <a:p>
-            <a:pPr lvl="1">
-              <a:spcAft>
-                <a:spcPts val="700"/>
-              </a:spcAft>
-            </a:pPr>
-            <a:r>
-              <a:rPr sz="1700">
-                <a:solidFill>
-                  <a:srgbClr val="333333"/>
-                </a:solidFill>
-                <a:latin typeface="Calibri"/>
-              </a:rPr>
-              <a:t>–  Çok geri beslemeli (MFB): düşük çıkış empedansı</a:t>
-            </a:r>
-          </a:p>
-          <a:p>
-            <a:pPr lvl="1">
-              <a:spcAft>
-                <a:spcPts val="700"/>
-              </a:spcAft>
-            </a:pPr>
-            <a:r>
-              <a:rPr sz="1700">
-                <a:solidFill>
-                  <a:srgbClr val="333333"/>
-                </a:solidFill>
-                <a:latin typeface="Calibri"/>
-              </a:rPr>
-              <a:t>–  KHN durum-değişkenli (1967): yüksek Q, DÜŞÜK DUYARLILIK</a:t>
-            </a:r>
-          </a:p>
-          <a:p>
-            <a:pPr lvl="1">
-              <a:spcAft>
-                <a:spcPts val="700"/>
-              </a:spcAft>
-            </a:pPr>
-            <a:r>
-              <a:rPr sz="1700">
-                <a:solidFill>
-                  <a:srgbClr val="333333"/>
-                </a:solidFill>
-                <a:latin typeface="Calibri"/>
-              </a:rPr>
-              <a:t>–  Tow-Thomas: sağlam Q–ωₒ ayrımı</a:t>
-            </a:r>
-          </a:p>
-          <a:p>
-            <a:pPr>
-              <a:spcAft>
-                <a:spcPts val="700"/>
-              </a:spcAft>
-            </a:pPr>
-            <a:r>
-              <a:rPr sz="1900">
-                <a:solidFill>
-                  <a:srgbClr val="333333"/>
-                </a:solidFill>
-                <a:latin typeface="Calibri"/>
-              </a:rPr>
-              <a:t>•  Akım/gerilim-modlu (kesirli için ideal): OTA-C, CCII, VCII, CFOA, FPAA.</a:t>
+              <a:rPr sz="1600">
+                <a:solidFill>
+                  <a:srgbClr val="333333"/>
+                </a:solidFill>
+                <a:latin typeface="Calibri"/>
+              </a:rPr>
+              <a:t>–  düşük güç; kesirli dereceden filtreler için en uygun yapı (Ferri ekolü).</a:t>
             </a:r>
           </a:p>
         </p:txBody>
@@ -7033,18 +7027,18 @@
         </p:nvSpPr>
         <p:spPr>
           <a:xfrm>
-            <a:off x="731520" y="1417320"/>
-            <a:ext cx="10698480" cy="731520"/>
+            <a:off x="1798167" y="1261872"/>
+            <a:ext cx="8595360" cy="2783451"/>
           </a:xfrm>
           <a:prstGeom prst="rect">
             <a:avLst/>
           </a:prstGeom>
           <a:solidFill>
-            <a:srgbClr val="F4F4F4"/>
+            <a:srgbClr val="F7F9FF"/>
           </a:solidFill>
-          <a:ln w="9525">
+          <a:ln w="12700">
             <a:solidFill>
-              <a:srgbClr val="CCCCCC"/>
+              <a:srgbClr val="D3DEF2"/>
             </a:solidFill>
           </a:ln>
           <a:effectLst/>
@@ -7064,32 +7058,47 @@
           </a:fontRef>
         </p:style>
         <p:txBody>
-          <a:bodyPr rtlCol="0" anchor="ctr" wrap="square" lIns="182880" tIns="73152"/>
+          <a:bodyPr rtlCol="0" anchor="ctr"/>
           <a:lstStyle/>
           <a:p>
             <a:pPr algn="ctr"/>
-            <a:r>
-              <a:rPr sz="1800" b="1">
-                <a:solidFill>
-                  <a:srgbClr val="1A1A6A"/>
-                </a:solidFill>
-                <a:latin typeface="Consolas"/>
-              </a:rPr>
-              <a:t>S_x^H = (x/H) * (dH/dx) = d(ln H) / d(ln x)</a:t>
-            </a:r>
-          </a:p>
-        </p:txBody>
-      </p:sp>
-      <p:sp>
-        <p:nvSpPr>
-          <p:cNvPr id="7" name="TextBox 6"/>
+          </a:p>
+        </p:txBody>
+      </p:sp>
+      <p:pic>
+        <p:nvPicPr>
+          <p:cNvPr id="7" name="Picture 6" descr="sens.png"/>
+          <p:cNvPicPr>
+            <a:picLocks noChangeAspect="1"/>
+          </p:cNvPicPr>
+          <p:nvPr/>
+        </p:nvPicPr>
+        <p:blipFill>
+          <a:blip r:embed="rId2"/>
+          <a:stretch>
+            <a:fillRect/>
+          </a:stretch>
+        </p:blipFill>
+        <p:spPr>
+          <a:xfrm>
+            <a:off x="1981047" y="1371600"/>
+            <a:ext cx="8229600" cy="2563996"/>
+          </a:xfrm>
+          <a:prstGeom prst="rect">
+            <a:avLst/>
+          </a:prstGeom>
+        </p:spPr>
+      </p:pic>
+      <p:sp>
+        <p:nvSpPr>
+          <p:cNvPr id="8" name="TextBox 7"/>
           <p:cNvSpPr txBox="1"/>
           <p:nvPr/>
         </p:nvSpPr>
         <p:spPr>
           <a:xfrm>
-            <a:off x="731520" y="2377440"/>
-            <a:ext cx="10698480" cy="365760"/>
+            <a:off x="822960" y="4246491"/>
+            <a:ext cx="10515600" cy="365760"/>
           </a:xfrm>
           <a:prstGeom prst="rect">
             <a:avLst/>
@@ -7107,7 +7116,6 @@
                 <a:solidFill>
                   <a:srgbClr val="1A1A6A"/>
                 </a:solidFill>
-                <a:latin typeface="Calibri"/>
               </a:rPr>
               <a:t>Burada:</a:t>
             </a:r>
@@ -7116,14 +7124,14 @@
       </p:sp>
       <p:sp>
         <p:nvSpPr>
-          <p:cNvPr id="8" name="TextBox 7"/>
+          <p:cNvPr id="9" name="TextBox 8"/>
           <p:cNvSpPr txBox="1"/>
           <p:nvPr/>
         </p:nvSpPr>
         <p:spPr>
           <a:xfrm>
-            <a:off x="731520" y="2761488"/>
-            <a:ext cx="10698480" cy="2743200"/>
+            <a:off x="822960" y="4612251"/>
+            <a:ext cx="10515600" cy="2743200"/>
           </a:xfrm>
           <a:prstGeom prst="rect">
             <a:avLst/>
@@ -7148,7 +7156,7 @@
                 </a:solidFill>
                 <a:latin typeface="Consolas"/>
               </a:rPr>
-              <a:t>S_x^H : </a:t>
+              <a:t>S_x^H  :  </a:t>
             </a:r>
             <a:r>
               <a:rPr sz="1700">
@@ -7157,7 +7165,7 @@
                 </a:solidFill>
                 <a:latin typeface="Calibri"/>
               </a:rPr>
-              <a:t>x bileşenindeki değişimin H’ye göreli etkisi (duyarlılık)</a:t>
+              <a:t>x bileşenindeki değişimin H’ye göreli etkisi</a:t>
             </a:r>
           </a:p>
           <a:p>
@@ -7173,7 +7181,7 @@
                 </a:solidFill>
                 <a:latin typeface="Consolas"/>
               </a:rPr>
-              <a:t>x : </a:t>
+              <a:t>x  :  </a:t>
             </a:r>
             <a:r>
               <a:rPr sz="1700">
@@ -7182,7 +7190,7 @@
                 </a:solidFill>
                 <a:latin typeface="Calibri"/>
               </a:rPr>
-              <a:t>devre elemanı (R, C, kazanç ...)</a:t>
+              <a:t>devre elemanı (R, C, kazanç…)</a:t>
             </a:r>
           </a:p>
           <a:p>
@@ -7198,7 +7206,7 @@
                 </a:solidFill>
                 <a:latin typeface="Consolas"/>
               </a:rPr>
-              <a:t>H : </a:t>
+              <a:t>H  :  </a:t>
             </a:r>
             <a:r>
               <a:rPr sz="1700">
@@ -7223,7 +7231,7 @@
                 </a:solidFill>
                 <a:latin typeface="Consolas"/>
               </a:rPr>
-              <a:t>d/dx : </a:t>
+              <a:t>∂/∂x  :  </a:t>
             </a:r>
             <a:r>
               <a:rPr sz="1700">
@@ -7239,13 +7247,13 @@
       </p:sp>
       <p:sp>
         <p:nvSpPr>
-          <p:cNvPr id="9" name="TextBox 8"/>
+          <p:cNvPr id="10" name="TextBox 9"/>
           <p:cNvSpPr txBox="1"/>
           <p:nvPr/>
         </p:nvSpPr>
         <p:spPr>
           <a:xfrm>
-            <a:off x="640080" y="4937760"/>
+            <a:off x="640080" y="5029200"/>
             <a:ext cx="10972800" cy="4846320"/>
           </a:xfrm>
           <a:prstGeom prst="rect">
@@ -7484,18 +7492,18 @@
         </p:nvSpPr>
         <p:spPr>
           <a:xfrm>
-            <a:off x="731520" y="1371600"/>
-            <a:ext cx="10698480" cy="1828800"/>
+            <a:off x="655167" y="1170432"/>
+            <a:ext cx="10881360" cy="4708186"/>
           </a:xfrm>
           <a:prstGeom prst="rect">
             <a:avLst/>
           </a:prstGeom>
           <a:solidFill>
-            <a:srgbClr val="F4F4F4"/>
+            <a:srgbClr val="F7F9FF"/>
           </a:solidFill>
-          <a:ln w="9525">
+          <a:ln w="12700">
             <a:solidFill>
-              <a:srgbClr val="CCCCCC"/>
+              <a:srgbClr val="D3DEF2"/>
             </a:solidFill>
           </a:ln>
           <a:effectLst/>
@@ -7515,65 +7523,47 @@
           </a:fontRef>
         </p:style>
         <p:txBody>
-          <a:bodyPr rtlCol="0" anchor="ctr" wrap="square" lIns="182880" tIns="73152"/>
+          <a:bodyPr rtlCol="0" anchor="ctr"/>
           <a:lstStyle/>
           <a:p>
             <a:pPr algn="ctr"/>
-            <a:r>
-              <a:rPr sz="1400" b="1">
-                <a:solidFill>
-                  <a:srgbClr val="1A1A6A"/>
-                </a:solidFill>
-                <a:latin typeface="Consolas"/>
-              </a:rPr>
-              <a:t>Termal: v_n^2 = 4kTR*df     Atis: i_n^2 = 2qI*df</a:t>
-            </a:r>
-          </a:p>
-          <a:p>
-            <a:r>
-              <a:rPr sz="1400" b="1">
-                <a:solidFill>
-                  <a:srgbClr val="1A1A6A"/>
-                </a:solidFill>
-                <a:latin typeface="Consolas"/>
-              </a:rPr>
-              <a:t>SNR = 10*log10(P_sinyal / P_gurultu)  [dB]</a:t>
-            </a:r>
-          </a:p>
-          <a:p>
-            <a:r>
-              <a:rPr sz="1400" b="1">
-                <a:solidFill>
-                  <a:srgbClr val="1A1A6A"/>
-                </a:solidFill>
-                <a:latin typeface="Consolas"/>
-              </a:rPr>
-              <a:t>NF = SNR_giris - SNR_cikis   (gurultu sekli)</a:t>
-            </a:r>
-          </a:p>
-          <a:p>
-            <a:r>
-              <a:rPr sz="1400" b="1">
-                <a:solidFill>
-                  <a:srgbClr val="1A1A6A"/>
-                </a:solidFill>
-                <a:latin typeface="Consolas"/>
-              </a:rPr>
-              <a:t>Dedektor: ENC^2 ~ a*(C^2/tau) + b*tau   -&gt; optimum tau</a:t>
-            </a:r>
-          </a:p>
-        </p:txBody>
-      </p:sp>
-      <p:sp>
-        <p:nvSpPr>
-          <p:cNvPr id="7" name="TextBox 6"/>
+          </a:p>
+        </p:txBody>
+      </p:sp>
+      <p:pic>
+        <p:nvPicPr>
+          <p:cNvPr id="7" name="Picture 6" descr="noise.png"/>
+          <p:cNvPicPr>
+            <a:picLocks noChangeAspect="1"/>
+          </p:cNvPicPr>
+          <p:nvPr/>
+        </p:nvPicPr>
+        <p:blipFill>
+          <a:blip r:embed="rId2"/>
+          <a:stretch>
+            <a:fillRect/>
+          </a:stretch>
+        </p:blipFill>
+        <p:spPr>
+          <a:xfrm>
+            <a:off x="838047" y="1280160"/>
+            <a:ext cx="10515600" cy="4488731"/>
+          </a:xfrm>
+          <a:prstGeom prst="rect">
+            <a:avLst/>
+          </a:prstGeom>
+        </p:spPr>
+      </p:pic>
+      <p:sp>
+        <p:nvSpPr>
+          <p:cNvPr id="8" name="TextBox 7"/>
           <p:cNvSpPr txBox="1"/>
           <p:nvPr/>
         </p:nvSpPr>
         <p:spPr>
           <a:xfrm>
-            <a:off x="731520" y="3383280"/>
-            <a:ext cx="10698480" cy="365760"/>
+            <a:off x="822960" y="6034066"/>
+            <a:ext cx="10515600" cy="365760"/>
           </a:xfrm>
           <a:prstGeom prst="rect">
             <a:avLst/>
@@ -7591,7 +7581,6 @@
                 <a:solidFill>
                   <a:srgbClr val="1A1A6A"/>
                 </a:solidFill>
-                <a:latin typeface="Calibri"/>
               </a:rPr>
               <a:t>Burada:</a:t>
             </a:r>
@@ -7600,14 +7589,14 @@
       </p:sp>
       <p:sp>
         <p:nvSpPr>
-          <p:cNvPr id="8" name="TextBox 7"/>
+          <p:cNvPr id="9" name="TextBox 8"/>
           <p:cNvSpPr txBox="1"/>
           <p:nvPr/>
         </p:nvSpPr>
         <p:spPr>
           <a:xfrm>
-            <a:off x="731520" y="3767328"/>
-            <a:ext cx="10698480" cy="2743200"/>
+            <a:off x="822960" y="6399826"/>
+            <a:ext cx="10515600" cy="2743200"/>
           </a:xfrm>
           <a:prstGeom prst="rect">
             <a:avLst/>
@@ -7632,7 +7621,7 @@
                 </a:solidFill>
                 <a:latin typeface="Consolas"/>
               </a:rPr>
-              <a:t>k : </a:t>
+              <a:t>k, T, R  :  </a:t>
             </a:r>
             <a:r>
               <a:rPr sz="1400">
@@ -7641,7 +7630,7 @@
                 </a:solidFill>
                 <a:latin typeface="Calibri"/>
               </a:rPr>
-              <a:t>Boltzmann sabiti (1.38e-23 J/K)</a:t>
+              <a:t>Boltzmann sabiti, sıcaklık (K), direnç</a:t>
             </a:r>
           </a:p>
           <a:p>
@@ -7657,7 +7646,7 @@
                 </a:solidFill>
                 <a:latin typeface="Consolas"/>
               </a:rPr>
-              <a:t>T : </a:t>
+              <a:t>Δf  :  </a:t>
             </a:r>
             <a:r>
               <a:rPr sz="1400">
@@ -7666,7 +7655,7 @@
                 </a:solidFill>
                 <a:latin typeface="Calibri"/>
               </a:rPr>
-              <a:t>mutlak sıcaklık (K)</a:t>
+              <a:t>bant genişliği</a:t>
             </a:r>
           </a:p>
           <a:p>
@@ -7682,7 +7671,7 @@
                 </a:solidFill>
                 <a:latin typeface="Consolas"/>
               </a:rPr>
-              <a:t>R : </a:t>
+              <a:t>q, I  :  </a:t>
             </a:r>
             <a:r>
               <a:rPr sz="1400">
@@ -7691,7 +7680,7 @@
                 </a:solidFill>
                 <a:latin typeface="Calibri"/>
               </a:rPr>
-              <a:t>direnç</a:t>
+              <a:t>elektron yükü, akım</a:t>
             </a:r>
           </a:p>
           <a:p>
@@ -7707,7 +7696,7 @@
                 </a:solidFill>
                 <a:latin typeface="Consolas"/>
               </a:rPr>
-              <a:t>df : </a:t>
+              <a:t>P_sinyal / P_n  :  </a:t>
             </a:r>
             <a:r>
               <a:rPr sz="1400">
@@ -7716,7 +7705,7 @@
                 </a:solidFill>
                 <a:latin typeface="Calibri"/>
               </a:rPr>
-              <a:t>bant genişliği</a:t>
+              <a:t>işaret / gürültü gücü</a:t>
             </a:r>
           </a:p>
           <a:p>
@@ -7732,7 +7721,7 @@
                 </a:solidFill>
                 <a:latin typeface="Consolas"/>
               </a:rPr>
-              <a:t>q : </a:t>
+              <a:t>in / out  :  </a:t>
             </a:r>
             <a:r>
               <a:rPr sz="1400">
@@ -7741,7 +7730,7 @@
                 </a:solidFill>
                 <a:latin typeface="Calibri"/>
               </a:rPr>
-              <a:t>elektron yükü</a:t>
+              <a:t>giriş / çıkış (NF için)</a:t>
             </a:r>
           </a:p>
           <a:p>
@@ -7757,7 +7746,7 @@
                 </a:solidFill>
                 <a:latin typeface="Consolas"/>
               </a:rPr>
-              <a:t>I : </a:t>
+              <a:t>τ  :  </a:t>
             </a:r>
             <a:r>
               <a:rPr sz="1400">
@@ -7766,7 +7755,7 @@
                 </a:solidFill>
                 <a:latin typeface="Calibri"/>
               </a:rPr>
-              <a:t>akım</a:t>
+              <a:t>şekillendirme zaman sabiti</a:t>
             </a:r>
           </a:p>
           <a:p>
@@ -7782,57 +7771,7 @@
                 </a:solidFill>
                 <a:latin typeface="Consolas"/>
               </a:rPr>
-              <a:t>tau : </a:t>
-            </a:r>
-            <a:r>
-              <a:rPr sz="1400">
-                <a:solidFill>
-                  <a:srgbClr val="333333"/>
-                </a:solidFill>
-                <a:latin typeface="Calibri"/>
-              </a:rPr>
-              <a:t>şekillendirme zaman sabiti</a:t>
-            </a:r>
-          </a:p>
-          <a:p>
-            <a:pPr>
-              <a:spcAft>
-                <a:spcPts val="300"/>
-              </a:spcAft>
-            </a:pPr>
-            <a:r>
-              <a:rPr b="1" sz="1400">
-                <a:solidFill>
-                  <a:srgbClr val="1B6B3A"/>
-                </a:solidFill>
-                <a:latin typeface="Consolas"/>
-              </a:rPr>
-              <a:t>C : </a:t>
-            </a:r>
-            <a:r>
-              <a:rPr sz="1400">
-                <a:solidFill>
-                  <a:srgbClr val="333333"/>
-                </a:solidFill>
-                <a:latin typeface="Calibri"/>
-              </a:rPr>
-              <a:t>toplam giriş kapasitesi</a:t>
-            </a:r>
-          </a:p>
-          <a:p>
-            <a:pPr>
-              <a:spcAft>
-                <a:spcPts val="300"/>
-              </a:spcAft>
-            </a:pPr>
-            <a:r>
-              <a:rPr b="1" sz="1400">
-                <a:solidFill>
-                  <a:srgbClr val="1B6B3A"/>
-                </a:solidFill>
-                <a:latin typeface="Consolas"/>
-              </a:rPr>
-              <a:t>ENC : </a:t>
+              <a:t>ENC  :  </a:t>
             </a:r>
             <a:r>
               <a:rPr sz="1400">
@@ -8447,7 +8386,7 @@
                 </a:solidFill>
                 <a:latin typeface="Calibri"/>
               </a:rPr>
-              <a:t>•  Topolojiler, duyarlılık ve SNR/gürültü</a:t>
+              <a:t>•  Filtre topolojileri, duyarlılık ve SNR/gürültü</a:t>
             </a:r>
           </a:p>
           <a:p>
@@ -8702,7 +8641,7 @@
                 </a:solidFill>
                 <a:latin typeface="Calibri"/>
               </a:rPr>
-              <a:t>•  Giuseppe Ferri (L’Aquila, İtalya): akım/gerilim-modlu (CCII/VCII) sensör arayüz devreleri.</a:t>
+              <a:t>•  Giuseppe Ferri (L’Aquila, İtalya): akım/gerilim-modlu (CCII/VCII) sensör arayüzleri.</a:t>
             </a:r>
           </a:p>
           <a:p>
@@ -8821,7 +8760,7 @@
                 </a:solidFill>
                 <a:latin typeface="Calibri"/>
               </a:rPr>
-              <a:t>Bu isimler "kesirli filtre + sensör/biyosinyal" kesişiminin çekirdeğini oluşturur.</a:t>
+              <a:t>Bu isimler "kesirli filtre + sensör/biyosinyal" kesişiminin çekirdeğidir.</a:t>
             </a:r>
           </a:p>
         </p:txBody>
@@ -9019,7 +8958,7 @@
         <p:spPr>
           <a:xfrm>
             <a:off x="640080" y="1280160"/>
-            <a:ext cx="10972800" cy="1280160"/>
+            <a:ext cx="10972800" cy="1097280"/>
           </a:xfrm>
           <a:prstGeom prst="rect">
             <a:avLst/>
@@ -9044,7 +8983,7 @@
                 </a:solidFill>
                 <a:latin typeface="Calibri"/>
               </a:rPr>
-              <a:t>•  Ferri’nin çizgisi: sensör işaretini AKIM alanında işle, kalibrasyonsuz/düşük-güç oku.</a:t>
+              <a:t>•  Ferri’nin çizgisi: işareti AKIM alanında işle; kalibrasyonsuz/düşük-güç oku.</a:t>
             </a:r>
           </a:p>
           <a:p>
@@ -9067,124 +9006,14 @@
       </p:sp>
       <p:sp>
         <p:nvSpPr>
-          <p:cNvPr id="7" name="Rectangle 6"/>
-          <p:cNvSpPr/>
-          <p:nvPr/>
-        </p:nvSpPr>
-        <p:spPr>
-          <a:xfrm>
-            <a:off x="731520" y="2651760"/>
-            <a:ext cx="10698480" cy="2578608"/>
-          </a:xfrm>
-          <a:prstGeom prst="rect">
-            <a:avLst/>
-          </a:prstGeom>
-          <a:solidFill>
-            <a:srgbClr val="F4F4F4"/>
-          </a:solidFill>
-          <a:ln w="9525">
-            <a:solidFill>
-              <a:srgbClr val="CCCCCC"/>
-            </a:solidFill>
-          </a:ln>
-          <a:effectLst/>
-        </p:spPr>
-        <p:style>
-          <a:lnRef idx="1">
-            <a:schemeClr val="accent1"/>
-          </a:lnRef>
-          <a:fillRef idx="3">
-            <a:schemeClr val="accent1"/>
-          </a:fillRef>
-          <a:effectRef idx="2">
-            <a:schemeClr val="accent1"/>
-          </a:effectRef>
-          <a:fontRef idx="minor">
-            <a:schemeClr val="lt1"/>
-          </a:fontRef>
-        </p:style>
-        <p:txBody>
-          <a:bodyPr rtlCol="0" anchor="ctr" wrap="square" lIns="182880" tIns="73152"/>
-          <a:lstStyle/>
-          <a:p>
-            <a:pPr algn="ctr"/>
-            <a:r>
-              <a:rPr sz="1400" b="1">
-                <a:solidFill>
-                  <a:srgbClr val="1A1A6A"/>
-                </a:solidFill>
-                <a:latin typeface="Consolas"/>
-              </a:rPr>
-              <a:t>[1] A. De Marcellis, G. Ferri et al., "Uncalibrated op-amp-based sensor</a:t>
-            </a:r>
-          </a:p>
-          <a:p>
-            <a:r>
-              <a:rPr sz="1400" b="1">
-                <a:solidFill>
-                  <a:srgbClr val="1A1A6A"/>
-                </a:solidFill>
-                <a:latin typeface="Consolas"/>
-              </a:rPr>
-              <a:t>     interface for capacitive/resistive sensors," IET CDS, 2015.</a:t>
-            </a:r>
-          </a:p>
-          <a:p>
-            <a:r>
-              <a:rPr sz="1400" b="1">
-                <a:solidFill>
-                  <a:srgbClr val="1A1A6A"/>
-                </a:solidFill>
-                <a:latin typeface="Consolas"/>
-              </a:rPr>
-              <a:t>     -&gt; empedansi PERIYODA cevirir (frekans-tabanli, kalibrasyonsuz okuma)</a:t>
-            </a:r>
-          </a:p>
-          <a:p>
-            <a:r>
-              <a:rPr sz="1400" b="1">
-                <a:solidFill>
-                  <a:srgbClr val="1A1A6A"/>
-                </a:solidFill>
-                <a:latin typeface="Consolas"/>
-              </a:rPr>
-              <a:t>[2] V. Stornelli, G. Ferri et al., "A VCII-Based Stray Insensitive Analog</a:t>
-            </a:r>
-          </a:p>
-          <a:p>
-            <a:r>
-              <a:rPr sz="1400" b="1">
-                <a:solidFill>
-                  <a:srgbClr val="1A1A6A"/>
-                </a:solidFill>
-                <a:latin typeface="Consolas"/>
-              </a:rPr>
-              <a:t>     Interface for Differential Capacitance Sensors," Sensors 19(16):3545, 2019.</a:t>
-            </a:r>
-          </a:p>
-          <a:p>
-            <a:r>
-              <a:rPr sz="1400" b="1">
-                <a:solidFill>
-                  <a:srgbClr val="1A1A6A"/>
-                </a:solidFill>
-                <a:latin typeface="Consolas"/>
-              </a:rPr>
-              <a:t>     -&gt; VCII ile kacak-bagisik, sade ve hassas sensor arayuzu</a:t>
-            </a:r>
-          </a:p>
-        </p:txBody>
-      </p:sp>
-      <p:sp>
-        <p:nvSpPr>
-          <p:cNvPr id="8" name="TextBox 7"/>
+          <p:cNvPr id="7" name="TextBox 6"/>
           <p:cNvSpPr txBox="1"/>
           <p:nvPr/>
         </p:nvSpPr>
         <p:spPr>
           <a:xfrm>
-            <a:off x="640080" y="5669280"/>
-            <a:ext cx="10972800" cy="822960"/>
+            <a:off x="822960" y="2468880"/>
+            <a:ext cx="10607040" cy="2377440"/>
           </a:xfrm>
           <a:prstGeom prst="rect">
             <a:avLst/>
@@ -9203,6 +9032,141 @@
               </a:spcAft>
             </a:pPr>
             <a:r>
+              <a:rPr sz="1600" b="0">
+                <a:solidFill>
+                  <a:srgbClr val="333333"/>
+                </a:solidFill>
+                <a:latin typeface="Calibri"/>
+              </a:rPr>
+              <a:t>[A] A. De Marcellis, G. Ferri ve ark., "Uncalibrated op-amp-based sensor interface</a:t>
+            </a:r>
+          </a:p>
+          <a:p>
+            <a:pPr algn="l">
+              <a:spcAft>
+                <a:spcPts val="500"/>
+              </a:spcAft>
+            </a:pPr>
+            <a:r>
+              <a:rPr sz="1600" b="0">
+                <a:solidFill>
+                  <a:srgbClr val="333333"/>
+                </a:solidFill>
+                <a:latin typeface="Calibri"/>
+              </a:rPr>
+              <a:t>       for capacitive/resistive sensors," IET Circuits, Devices &amp; Syst., 2015.</a:t>
+            </a:r>
+          </a:p>
+          <a:p>
+            <a:pPr algn="l">
+              <a:spcAft>
+                <a:spcPts val="500"/>
+              </a:spcAft>
+            </a:pPr>
+            <a:r>
+              <a:rPr sz="1600" b="0">
+                <a:solidFill>
+                  <a:srgbClr val="333333"/>
+                </a:solidFill>
+                <a:latin typeface="Calibri"/>
+              </a:rPr>
+              <a:t>       → empedansı PERİYODA çevirir (frekans-tabanlı, kalibrasyonsuz okuma).</a:t>
+            </a:r>
+          </a:p>
+          <a:p>
+            <a:pPr algn="l">
+              <a:spcAft>
+                <a:spcPts val="500"/>
+              </a:spcAft>
+            </a:pPr>
+            <a:r>
+              <a:rPr sz="1600" b="0">
+                <a:solidFill>
+                  <a:srgbClr val="333333"/>
+                </a:solidFill>
+                <a:latin typeface="Calibri"/>
+              </a:rPr>
+              <a:t/>
+            </a:r>
+          </a:p>
+          <a:p>
+            <a:pPr algn="l">
+              <a:spcAft>
+                <a:spcPts val="500"/>
+              </a:spcAft>
+            </a:pPr>
+            <a:r>
+              <a:rPr sz="1600" b="0">
+                <a:solidFill>
+                  <a:srgbClr val="333333"/>
+                </a:solidFill>
+                <a:latin typeface="Calibri"/>
+              </a:rPr>
+              <a:t>[B] V. Stornelli, G. Ferri ve ark., "A VCII-Based Stray Insensitive Analog Interface</a:t>
+            </a:r>
+          </a:p>
+          <a:p>
+            <a:pPr algn="l">
+              <a:spcAft>
+                <a:spcPts val="500"/>
+              </a:spcAft>
+            </a:pPr>
+            <a:r>
+              <a:rPr sz="1600" b="0">
+                <a:solidFill>
+                  <a:srgbClr val="333333"/>
+                </a:solidFill>
+                <a:latin typeface="Calibri"/>
+              </a:rPr>
+              <a:t>       for Differential Capacitance Sensors," Sensors, 19(16):3545, 2019.</a:t>
+            </a:r>
+          </a:p>
+          <a:p>
+            <a:pPr algn="l">
+              <a:spcAft>
+                <a:spcPts val="500"/>
+              </a:spcAft>
+            </a:pPr>
+            <a:r>
+              <a:rPr sz="1600" b="0">
+                <a:solidFill>
+                  <a:srgbClr val="333333"/>
+                </a:solidFill>
+                <a:latin typeface="Calibri"/>
+              </a:rPr>
+              <a:t>       → VCII ile kaçak-bağışık, sade ve hassas sensör arayüzü.</a:t>
+            </a:r>
+          </a:p>
+        </p:txBody>
+      </p:sp>
+      <p:sp>
+        <p:nvSpPr>
+          <p:cNvPr id="8" name="TextBox 7"/>
+          <p:cNvSpPr txBox="1"/>
+          <p:nvPr/>
+        </p:nvSpPr>
+        <p:spPr>
+          <a:xfrm>
+            <a:off x="640080" y="5669280"/>
+            <a:ext cx="10972800" cy="822960"/>
+          </a:xfrm>
+          <a:prstGeom prst="rect">
+            <a:avLst/>
+          </a:prstGeom>
+          <a:noFill/>
+        </p:spPr>
+        <p:txBody>
+          <a:bodyPr wrap="square" anchor="t">
+            <a:spAutoFit/>
+          </a:bodyPr>
+          <a:lstStyle/>
+          <a:p>
+            <a:pPr algn="l">
+              <a:spcAft>
+                <a:spcPts val="500"/>
+              </a:spcAft>
+            </a:pPr>
+            <a:r>
               <a:rPr sz="1500" b="1">
                 <a:solidFill>
                   <a:srgbClr val="1A1A6A"/>
@@ -9225,7 +9189,7 @@
                 </a:solidFill>
                 <a:latin typeface="Calibri"/>
               </a:rPr>
-              <a:t>sensörlerim, Ferri’nin akım-modu + frekans-okuma yaklaşımına birebir oturur.</a:t>
+              <a:t>sensörlerim Ferri’nin akım-modu + frekans-okuma yaklaşımına birebir oturur.</a:t>
             </a:r>
           </a:p>
         </p:txBody>
@@ -10901,7 +10865,7 @@
                 </a:solidFill>
                 <a:latin typeface="Calibri"/>
               </a:rPr>
-              <a:t>Seçilmiş Kaynaklar (IEEE)</a:t>
+              <a:t>Kaynaklar (1/2) — IEEE</a:t>
             </a:r>
           </a:p>
         </p:txBody>
@@ -10953,7 +10917,7 @@
         </p:nvSpPr>
         <p:spPr>
           <a:xfrm>
-            <a:off x="640080" y="1371600"/>
+            <a:off x="640080" y="1280160"/>
             <a:ext cx="10972800" cy="4846320"/>
           </a:xfrm>
           <a:prstGeom prst="rect">
@@ -10973,13 +10937,13 @@
               </a:spcAft>
             </a:pPr>
             <a:r>
-              <a:rPr sz="1400">
-                <a:solidFill>
-                  <a:srgbClr val="333333"/>
-                </a:solidFill>
-                <a:latin typeface="Calibri"/>
-              </a:rPr>
-              <a:t>•  R. Schaumann, H. Xiao, M. E. Van Valkenburg, Design of Analog Filters, 2nd ed., Oxford, 2010.</a:t>
+              <a:rPr sz="1350">
+                <a:solidFill>
+                  <a:srgbClr val="333333"/>
+                </a:solidFill>
+                <a:latin typeface="Calibri"/>
+              </a:rPr>
+              <a:t>•  [1] S. Butterworth, "On the theory of filter amplifiers," Exp. Wireless Wireless Eng., vol. 7, pp. 536–541, 1930.</a:t>
             </a:r>
           </a:p>
           <a:p>
@@ -10989,13 +10953,13 @@
               </a:spcAft>
             </a:pPr>
             <a:r>
-              <a:rPr sz="1400">
-                <a:solidFill>
-                  <a:srgbClr val="333333"/>
-                </a:solidFill>
-                <a:latin typeface="Calibri"/>
-              </a:rPr>
-              <a:t>•  A. B. Williams, F. J. Taylor, Electronic Filter Design Handbook, 4th ed., McGraw-Hill, 2006.</a:t>
+              <a:rPr sz="1350">
+                <a:solidFill>
+                  <a:srgbClr val="333333"/>
+                </a:solidFill>
+                <a:latin typeface="Calibri"/>
+              </a:rPr>
+              <a:t>•  [2] W. E. Thomson, "Delay networks having maximally flat frequency characteristics," Proc. IEE - Part III, vol. 96, no. 44, pp. 487–490, 1949.</a:t>
             </a:r>
           </a:p>
           <a:p>
@@ -11005,13 +10969,13 @@
               </a:spcAft>
             </a:pPr>
             <a:r>
-              <a:rPr sz="1400">
-                <a:solidFill>
-                  <a:srgbClr val="333333"/>
-                </a:solidFill>
-                <a:latin typeface="Calibri"/>
-              </a:rPr>
-              <a:t>•  A. De Marcellis, G. Ferri, Analog Circuits and Systems for ... Sensor Interfacing, Springer, 2011.</a:t>
+              <a:rPr sz="1350">
+                <a:solidFill>
+                  <a:srgbClr val="333333"/>
+                </a:solidFill>
+                <a:latin typeface="Calibri"/>
+              </a:rPr>
+              <a:t>•  [3] R. P. Sallen and E. L. Key, "A practical method of designing RC active filters," IRE Trans. Circuit Theory, vol. 2, no. 1, pp. 74–85, Mar. 1955.</a:t>
             </a:r>
           </a:p>
           <a:p>
@@ -11021,13 +10985,13 @@
               </a:spcAft>
             </a:pPr>
             <a:r>
-              <a:rPr sz="1400">
-                <a:solidFill>
-                  <a:srgbClr val="333333"/>
-                </a:solidFill>
-                <a:latin typeface="Calibri"/>
-              </a:rPr>
-              <a:t>•  A. De Marcellis, G. Ferri et al., "Uncalibrated op-amp-based sensor interface," IET CDS, 2015.</a:t>
+              <a:rPr sz="1350">
+                <a:solidFill>
+                  <a:srgbClr val="333333"/>
+                </a:solidFill>
+                <a:latin typeface="Calibri"/>
+              </a:rPr>
+              <a:t>•  [4] W. J. Kerwin, L. P. Huelsman, and R. W. Newcomb, "State-variable synthesis for insensitive integrated circuit transfer functions," IEEE J. Solid-State Circuits, vol. 2, no. 3, pp. 87–92, 1967.</a:t>
             </a:r>
           </a:p>
           <a:p>
@@ -11037,13 +11001,13 @@
               </a:spcAft>
             </a:pPr>
             <a:r>
-              <a:rPr sz="1400">
-                <a:solidFill>
-                  <a:srgbClr val="333333"/>
-                </a:solidFill>
-                <a:latin typeface="Calibri"/>
-              </a:rPr>
-              <a:t>•  V. Stornelli, G. Ferri et al., "VCII-based stray insensitive interface...," Sensors 19(16):3545, 2019.</a:t>
+              <a:rPr sz="1350">
+                <a:solidFill>
+                  <a:srgbClr val="333333"/>
+                </a:solidFill>
+                <a:latin typeface="Calibri"/>
+              </a:rPr>
+              <a:t>•  [5] A. B. Williams and F. J. Taylor, Electronic Filter Design Handbook, 4th ed. New York: McGraw-Hill, 2006.</a:t>
             </a:r>
           </a:p>
           <a:p>
@@ -11053,13 +11017,13 @@
               </a:spcAft>
             </a:pPr>
             <a:r>
-              <a:rPr sz="1400">
-                <a:solidFill>
-                  <a:srgbClr val="333333"/>
-                </a:solidFill>
-                <a:latin typeface="Calibri"/>
-              </a:rPr>
-              <a:t>•  A. G. Radwan, A. M. Soliman, A. S. Elwakil, "First-order filters generalized to the fractional domain," JCSC, 2008.</a:t>
+              <a:rPr sz="1350">
+                <a:solidFill>
+                  <a:srgbClr val="333333"/>
+                </a:solidFill>
+                <a:latin typeface="Calibri"/>
+              </a:rPr>
+              <a:t>•  [6] R. Schaumann, H. Xiao, and M. E. Van Valkenburg, Design of Analog Filters, 2nd ed. New York: Oxford Univ. Press, 2010.</a:t>
             </a:r>
           </a:p>
           <a:p>
@@ -11069,13 +11033,13 @@
               </a:spcAft>
             </a:pPr>
             <a:r>
-              <a:rPr sz="1400">
-                <a:solidFill>
-                  <a:srgbClr val="333333"/>
-                </a:solidFill>
-                <a:latin typeface="Calibri"/>
-              </a:rPr>
-              <a:t>•  G. Tsirimokou, C. Psychalinos, A. Elwakil, Design of CMOS ... Fractional-Order Circuits, Springer, 2017.</a:t>
+              <a:rPr sz="1350">
+                <a:solidFill>
+                  <a:srgbClr val="333333"/>
+                </a:solidFill>
+                <a:latin typeface="Calibri"/>
+              </a:rPr>
+              <a:t>•  [7] A. S. Sedra and K. C. Smith, Microelectronic Circuits, 7th ed. New York: Oxford Univ. Press, 2015.</a:t>
             </a:r>
           </a:p>
           <a:p>
@@ -11085,13 +11049,412 @@
               </a:spcAft>
             </a:pPr>
             <a:r>
-              <a:rPr sz="1400">
-                <a:solidFill>
-                  <a:srgbClr val="333333"/>
-                </a:solidFill>
-                <a:latin typeface="Calibri"/>
-              </a:rPr>
-              <a:t>•  Hamamatsu R6094/R6095 (TPMH1382E) &amp; H7711; CTC LP252; ISO 20816-1:2016.</a:t>
+              <a:rPr sz="1350">
+                <a:solidFill>
+                  <a:srgbClr val="333333"/>
+                </a:solidFill>
+                <a:latin typeface="Calibri"/>
+              </a:rPr>
+              <a:t>•  [8] B. Razavi, Design of Analog CMOS Integrated Circuits, 2nd ed. New York: McGraw-Hill, 2017.</a:t>
+            </a:r>
+          </a:p>
+          <a:p>
+            <a:pPr>
+              <a:spcAft>
+                <a:spcPts val="700"/>
+              </a:spcAft>
+            </a:pPr>
+            <a:r>
+              <a:rPr sz="1350">
+                <a:solidFill>
+                  <a:srgbClr val="333333"/>
+                </a:solidFill>
+                <a:latin typeface="Calibri"/>
+              </a:rPr>
+              <a:t>•  [9] I. Podlubny, Fractional Differential Equations. San Diego: Academic Press, 1999.</a:t>
+            </a:r>
+          </a:p>
+          <a:p>
+            <a:pPr>
+              <a:spcAft>
+                <a:spcPts val="700"/>
+              </a:spcAft>
+            </a:pPr>
+            <a:r>
+              <a:rPr sz="1350">
+                <a:solidFill>
+                  <a:srgbClr val="333333"/>
+                </a:solidFill>
+                <a:latin typeface="Calibri"/>
+              </a:rPr>
+              <a:t>•  [10] A. Oustaloup, F. Levron, B. Mathieu, and F. M. Nanot, "Frequency-band complex noninteger differentiator," IEEE Trans. Circuits Syst. I, vol. 47, no. 1, pp. 25–39, 2000.</a:t>
+            </a:r>
+          </a:p>
+        </p:txBody>
+      </p:sp>
+    </p:spTree>
+  </p:cSld>
+  <p:clrMapOvr>
+    <a:masterClrMapping/>
+  </p:clrMapOvr>
+</p:sld>
+</file>
+
+<file path=ppt/slides/slide28.xml><?xml version="1.0" encoding="utf-8"?>
+<p:sld xmlns:a="http://schemas.openxmlformats.org/drawingml/2006/main" xmlns:p="http://schemas.openxmlformats.org/presentationml/2006/main" xmlns:r="http://schemas.openxmlformats.org/officeDocument/2006/relationships">
+  <p:cSld>
+    <p:spTree>
+      <p:nvGrpSpPr>
+        <p:cNvPr id="1" name=""/>
+        <p:cNvGrpSpPr/>
+        <p:nvPr/>
+      </p:nvGrpSpPr>
+      <p:grpSpPr/>
+      <p:sp>
+        <p:nvSpPr>
+          <p:cNvPr id="2" name="Rectangle 1"/>
+          <p:cNvSpPr/>
+          <p:nvPr/>
+        </p:nvSpPr>
+        <p:spPr>
+          <a:xfrm>
+            <a:off x="0" y="0"/>
+            <a:ext cx="12191695" cy="1005840"/>
+          </a:xfrm>
+          <a:prstGeom prst="rect">
+            <a:avLst/>
+          </a:prstGeom>
+          <a:solidFill>
+            <a:srgbClr val="1A1A6A"/>
+          </a:solidFill>
+          <a:ln>
+            <a:noFill/>
+          </a:ln>
+          <a:effectLst/>
+        </p:spPr>
+        <p:style>
+          <a:lnRef idx="1">
+            <a:schemeClr val="accent1"/>
+          </a:lnRef>
+          <a:fillRef idx="3">
+            <a:schemeClr val="accent1"/>
+          </a:fillRef>
+          <a:effectRef idx="2">
+            <a:schemeClr val="accent1"/>
+          </a:effectRef>
+          <a:fontRef idx="minor">
+            <a:schemeClr val="lt1"/>
+          </a:fontRef>
+        </p:style>
+        <p:txBody>
+          <a:bodyPr rtlCol="0" anchor="ctr"/>
+          <a:lstStyle/>
+          <a:p>
+            <a:pPr algn="ctr"/>
+          </a:p>
+        </p:txBody>
+      </p:sp>
+      <p:sp>
+        <p:nvSpPr>
+          <p:cNvPr id="3" name="Rectangle 2"/>
+          <p:cNvSpPr/>
+          <p:nvPr/>
+        </p:nvSpPr>
+        <p:spPr>
+          <a:xfrm>
+            <a:off x="0" y="1005840"/>
+            <a:ext cx="12191695" cy="50292"/>
+          </a:xfrm>
+          <a:prstGeom prst="rect">
+            <a:avLst/>
+          </a:prstGeom>
+          <a:solidFill>
+            <a:srgbClr val="2E5CB8"/>
+          </a:solidFill>
+          <a:ln>
+            <a:noFill/>
+          </a:ln>
+          <a:effectLst/>
+        </p:spPr>
+        <p:style>
+          <a:lnRef idx="1">
+            <a:schemeClr val="accent1"/>
+          </a:lnRef>
+          <a:fillRef idx="3">
+            <a:schemeClr val="accent1"/>
+          </a:fillRef>
+          <a:effectRef idx="2">
+            <a:schemeClr val="accent1"/>
+          </a:effectRef>
+          <a:fontRef idx="minor">
+            <a:schemeClr val="lt1"/>
+          </a:fontRef>
+        </p:style>
+        <p:txBody>
+          <a:bodyPr rtlCol="0" anchor="ctr"/>
+          <a:lstStyle/>
+          <a:p>
+            <a:pPr algn="ctr"/>
+          </a:p>
+        </p:txBody>
+      </p:sp>
+      <p:sp>
+        <p:nvSpPr>
+          <p:cNvPr id="4" name="TextBox 3"/>
+          <p:cNvSpPr txBox="1"/>
+          <p:nvPr/>
+        </p:nvSpPr>
+        <p:spPr>
+          <a:xfrm>
+            <a:off x="502920" y="118872"/>
+            <a:ext cx="10424160" cy="777240"/>
+          </a:xfrm>
+          <a:prstGeom prst="rect">
+            <a:avLst/>
+          </a:prstGeom>
+          <a:noFill/>
+        </p:spPr>
+        <p:txBody>
+          <a:bodyPr wrap="square" anchor="ctr">
+            <a:spAutoFit/>
+          </a:bodyPr>
+          <a:lstStyle/>
+          <a:p>
+            <a:pPr algn="l">
+              <a:spcAft>
+                <a:spcPts val="500"/>
+              </a:spcAft>
+            </a:pPr>
+            <a:r>
+              <a:rPr sz="2500" b="1">
+                <a:solidFill>
+                  <a:srgbClr val="FFFFFF"/>
+                </a:solidFill>
+                <a:latin typeface="Calibri"/>
+              </a:rPr>
+              <a:t>Kaynaklar (2/2) — IEEE</a:t>
+            </a:r>
+          </a:p>
+        </p:txBody>
+      </p:sp>
+      <p:sp>
+        <p:nvSpPr>
+          <p:cNvPr id="5" name="TextBox 4"/>
+          <p:cNvSpPr txBox="1"/>
+          <p:nvPr/>
+        </p:nvSpPr>
+        <p:spPr>
+          <a:xfrm>
+            <a:off x="11155680" y="118872"/>
+            <a:ext cx="822960" cy="777240"/>
+          </a:xfrm>
+          <a:prstGeom prst="rect">
+            <a:avLst/>
+          </a:prstGeom>
+          <a:noFill/>
+        </p:spPr>
+        <p:txBody>
+          <a:bodyPr wrap="square" anchor="ctr">
+            <a:spAutoFit/>
+          </a:bodyPr>
+          <a:lstStyle/>
+          <a:p>
+            <a:pPr algn="r">
+              <a:spcAft>
+                <a:spcPts val="500"/>
+              </a:spcAft>
+            </a:pPr>
+            <a:r>
+              <a:rPr sz="1500" b="1">
+                <a:solidFill>
+                  <a:srgbClr val="EEF4FF"/>
+                </a:solidFill>
+                <a:latin typeface="Calibri"/>
+              </a:rPr>
+              <a:t>28</a:t>
+            </a:r>
+          </a:p>
+        </p:txBody>
+      </p:sp>
+      <p:sp>
+        <p:nvSpPr>
+          <p:cNvPr id="6" name="TextBox 5"/>
+          <p:cNvSpPr txBox="1"/>
+          <p:nvPr/>
+        </p:nvSpPr>
+        <p:spPr>
+          <a:xfrm>
+            <a:off x="640080" y="1280160"/>
+            <a:ext cx="10972800" cy="4846320"/>
+          </a:xfrm>
+          <a:prstGeom prst="rect">
+            <a:avLst/>
+          </a:prstGeom>
+          <a:noFill/>
+        </p:spPr>
+        <p:txBody>
+          <a:bodyPr wrap="square">
+            <a:spAutoFit/>
+          </a:bodyPr>
+          <a:lstStyle/>
+          <a:p>
+            <a:pPr>
+              <a:spcAft>
+                <a:spcPts val="700"/>
+              </a:spcAft>
+            </a:pPr>
+            <a:r>
+              <a:rPr sz="1350">
+                <a:solidFill>
+                  <a:srgbClr val="333333"/>
+                </a:solidFill>
+                <a:latin typeface="Calibri"/>
+              </a:rPr>
+              <a:t>•  [11] A. G. Radwan, A. M. Soliman, and A. S. Elwakil, "First-order filters generalized to the fractional domain," J. Circuits Syst. Comput., vol. 17, no. 1, pp. 55–66, 2008.</a:t>
+            </a:r>
+          </a:p>
+          <a:p>
+            <a:pPr>
+              <a:spcAft>
+                <a:spcPts val="700"/>
+              </a:spcAft>
+            </a:pPr>
+            <a:r>
+              <a:rPr sz="1350">
+                <a:solidFill>
+                  <a:srgbClr val="333333"/>
+                </a:solidFill>
+                <a:latin typeface="Calibri"/>
+              </a:rPr>
+              <a:t>•  [12] T. J. Freeborn, "A survey of fractional-order circuit models for biology and biomedicine," IEEE J. Emerg. Sel. Topics Circuits Syst., vol. 3, no. 3, pp. 416–424, 2013.</a:t>
+            </a:r>
+          </a:p>
+          <a:p>
+            <a:pPr>
+              <a:spcAft>
+                <a:spcPts val="700"/>
+              </a:spcAft>
+            </a:pPr>
+            <a:r>
+              <a:rPr sz="1350">
+                <a:solidFill>
+                  <a:srgbClr val="333333"/>
+                </a:solidFill>
+                <a:latin typeface="Calibri"/>
+              </a:rPr>
+              <a:t>•  [13] G. Tsirimokou, C. Psychalinos, and A. Elwakil, Design of CMOS Analog Integrated Fractional-Order Circuits. Cham: Springer, 2017.</a:t>
+            </a:r>
+          </a:p>
+          <a:p>
+            <a:pPr>
+              <a:spcAft>
+                <a:spcPts val="700"/>
+              </a:spcAft>
+            </a:pPr>
+            <a:r>
+              <a:rPr sz="1350">
+                <a:solidFill>
+                  <a:srgbClr val="333333"/>
+                </a:solidFill>
+                <a:latin typeface="Calibri"/>
+              </a:rPr>
+              <a:t>•  [14] C. I. Muresan et al., "A review of recent advances in fractional-order sensing and filtering techniques," Sensors, vol. 21, no. 17, art. 5920, 2021.</a:t>
+            </a:r>
+          </a:p>
+          <a:p>
+            <a:pPr>
+              <a:spcAft>
+                <a:spcPts val="700"/>
+              </a:spcAft>
+            </a:pPr>
+            <a:r>
+              <a:rPr sz="1350">
+                <a:solidFill>
+                  <a:srgbClr val="333333"/>
+                </a:solidFill>
+                <a:latin typeface="Calibri"/>
+              </a:rPr>
+              <a:t>•  [15] A. De Marcellis and G. Ferri, Analog Circuits and Systems for Voltage-Mode and Current-Mode Sensor Interfacing Applications. Dordrecht: Springer, 2011.</a:t>
+            </a:r>
+          </a:p>
+          <a:p>
+            <a:pPr>
+              <a:spcAft>
+                <a:spcPts val="700"/>
+              </a:spcAft>
+            </a:pPr>
+            <a:r>
+              <a:rPr sz="1350">
+                <a:solidFill>
+                  <a:srgbClr val="333333"/>
+                </a:solidFill>
+                <a:latin typeface="Calibri"/>
+              </a:rPr>
+              <a:t>•  [16] A. De Marcellis, G. Ferri et al., "Uncalibrated operational amplifier-based sensor interface for capacitive/resistive sensor applications," IET Circuits, Devices &amp; Syst., vol. 9, no. 4, pp. 249–255, 2015.</a:t>
+            </a:r>
+          </a:p>
+          <a:p>
+            <a:pPr>
+              <a:spcAft>
+                <a:spcPts val="700"/>
+              </a:spcAft>
+            </a:pPr>
+            <a:r>
+              <a:rPr sz="1350">
+                <a:solidFill>
+                  <a:srgbClr val="333333"/>
+                </a:solidFill>
+                <a:latin typeface="Calibri"/>
+              </a:rPr>
+              <a:t>•  [17] V. Stornelli, G. Ferri et al., "A VCII-based stray insensitive analog interface for differential capacitance sensors," Sensors, vol. 19, no. 16, art. 3545, 2019.</a:t>
+            </a:r>
+          </a:p>
+          <a:p>
+            <a:pPr>
+              <a:spcAft>
+                <a:spcPts val="700"/>
+              </a:spcAft>
+            </a:pPr>
+            <a:r>
+              <a:rPr sz="1350">
+                <a:solidFill>
+                  <a:srgbClr val="333333"/>
+                </a:solidFill>
+                <a:latin typeface="Calibri"/>
+              </a:rPr>
+              <a:t>•  [18] G. F. Knoll, Radiation Detection and Measurement, 4th ed. Hoboken: Wiley, 2010.</a:t>
+            </a:r>
+          </a:p>
+          <a:p>
+            <a:pPr>
+              <a:spcAft>
+                <a:spcPts val="700"/>
+              </a:spcAft>
+            </a:pPr>
+            <a:r>
+              <a:rPr sz="1350">
+                <a:solidFill>
+                  <a:srgbClr val="333333"/>
+                </a:solidFill>
+                <a:latin typeface="Calibri"/>
+              </a:rPr>
+              <a:t>•  [19] Hamamatsu Photonics K.K., "Photomultiplier tubes R6094, R6095," datasheet TPMH1382E, 2020; "Photon counting head H7711 series," datasheet.</a:t>
+            </a:r>
+          </a:p>
+          <a:p>
+            <a:pPr>
+              <a:spcAft>
+                <a:spcPts val="700"/>
+              </a:spcAft>
+            </a:pPr>
+            <a:r>
+              <a:rPr sz="1350">
+                <a:solidFill>
+                  <a:srgbClr val="333333"/>
+                </a:solidFill>
+                <a:latin typeface="Calibri"/>
+              </a:rPr>
+              <a:t>•  [20] Connection Technology Center, "LP252 loop power velocity vibration sensor (4–20 mA)," datasheet; ISO 20816-1:2016.</a:t>
             </a:r>
           </a:p>
         </p:txBody>
@@ -11571,7 +11934,7 @@
                 </a:solidFill>
                 <a:latin typeface="Calibri"/>
               </a:rPr>
-              <a:t>2. Amaç ve Araştırma Sorusu</a:t>
+              <a:t>2. Amaç, Araştırma Sorusu ve Hipotez</a:t>
             </a:r>
           </a:p>
         </p:txBody>
@@ -11624,7 +11987,7 @@
         <p:spPr>
           <a:xfrm>
             <a:off x="640080" y="1234440"/>
-            <a:ext cx="10972800" cy="457200"/>
+            <a:ext cx="10972800" cy="411480"/>
           </a:xfrm>
           <a:prstGeom prst="rect">
             <a:avLst/>
@@ -11656,91 +12019,14 @@
       </p:sp>
       <p:sp>
         <p:nvSpPr>
-          <p:cNvPr id="7" name="Rectangle 6"/>
-          <p:cNvSpPr/>
-          <p:nvPr/>
-        </p:nvSpPr>
-        <p:spPr>
-          <a:xfrm>
-            <a:off x="731520" y="1783080"/>
-            <a:ext cx="10698480" cy="1463040"/>
-          </a:xfrm>
-          <a:prstGeom prst="rect">
-            <a:avLst/>
-          </a:prstGeom>
-          <a:solidFill>
-            <a:srgbClr val="F4F4F4"/>
-          </a:solidFill>
-          <a:ln w="9525">
-            <a:solidFill>
-              <a:srgbClr val="CCCCCC"/>
-            </a:solidFill>
-          </a:ln>
-          <a:effectLst/>
-        </p:spPr>
-        <p:style>
-          <a:lnRef idx="1">
-            <a:schemeClr val="accent1"/>
-          </a:lnRef>
-          <a:fillRef idx="3">
-            <a:schemeClr val="accent1"/>
-          </a:fillRef>
-          <a:effectRef idx="2">
-            <a:schemeClr val="accent1"/>
-          </a:effectRef>
-          <a:fontRef idx="minor">
-            <a:schemeClr val="lt1"/>
-          </a:fontRef>
-        </p:style>
-        <p:txBody>
-          <a:bodyPr rtlCol="0" anchor="ctr" wrap="square" lIns="182880" tIns="73152"/>
-          <a:lstStyle/>
-          <a:p>
-            <a:pPr algn="ctr"/>
-            <a:r>
-              <a:rPr sz="1700" b="1">
-                <a:solidFill>
-                  <a:srgbClr val="1A1A6A"/>
-                </a:solidFill>
-                <a:latin typeface="Consolas"/>
-              </a:rPr>
-              <a:t>Kesirli dereceden (1+a) bir analog filtre/sekillendirici;</a:t>
-            </a:r>
-          </a:p>
-          <a:p>
-            <a:r>
-              <a:rPr sz="1700" b="1">
-                <a:solidFill>
-                  <a:srgbClr val="1A1A6A"/>
-                </a:solidFill>
-                <a:latin typeface="Consolas"/>
-              </a:rPr>
-              <a:t>klasik (Bessel, CR-RC) tasarimlara gore sensor sinyalinde</a:t>
-            </a:r>
-          </a:p>
-          <a:p>
-            <a:r>
-              <a:rPr sz="1700" b="1">
-                <a:solidFill>
-                  <a:srgbClr val="1A1A6A"/>
-                </a:solidFill>
-                <a:latin typeface="Consolas"/>
-              </a:rPr>
-              <a:t>SNR, gecikme ve darbe ayrisimi acisindan kazanc saglar mi?</a:t>
-            </a:r>
-          </a:p>
-        </p:txBody>
-      </p:sp>
-      <p:sp>
-        <p:nvSpPr>
-          <p:cNvPr id="8" name="TextBox 7"/>
+          <p:cNvPr id="7" name="TextBox 6"/>
           <p:cNvSpPr txBox="1"/>
           <p:nvPr/>
         </p:nvSpPr>
         <p:spPr>
           <a:xfrm>
-            <a:off x="640080" y="3657600"/>
-            <a:ext cx="10972800" cy="457200"/>
+            <a:off x="822960" y="1691640"/>
+            <a:ext cx="10607040" cy="914400"/>
           </a:xfrm>
           <a:prstGeom prst="rect">
             <a:avLst/>
@@ -11759,13 +12045,84 @@
               </a:spcAft>
             </a:pPr>
             <a:r>
+              <a:rPr sz="1800" b="0">
+                <a:solidFill>
+                  <a:srgbClr val="333333"/>
+                </a:solidFill>
+                <a:latin typeface="Calibri"/>
+              </a:rPr>
+              <a:t>Bir sensör sinyalini temizlerken, kesirli dereceden bir analog filtre;</a:t>
+            </a:r>
+          </a:p>
+          <a:p>
+            <a:pPr algn="l">
+              <a:spcAft>
+                <a:spcPts val="500"/>
+              </a:spcAft>
+            </a:pPr>
+            <a:r>
+              <a:rPr sz="1800" b="0">
+                <a:solidFill>
+                  <a:srgbClr val="333333"/>
+                </a:solidFill>
+                <a:latin typeface="Calibri"/>
+              </a:rPr>
+              <a:t>klasik filtrelere kıyasla "gürültüyü temizleme" ile "sinyalin şeklini koruma"</a:t>
+            </a:r>
+          </a:p>
+          <a:p>
+            <a:pPr algn="l">
+              <a:spcAft>
+                <a:spcPts val="500"/>
+              </a:spcAft>
+            </a:pPr>
+            <a:r>
+              <a:rPr sz="1800" b="0">
+                <a:solidFill>
+                  <a:srgbClr val="333333"/>
+                </a:solidFill>
+                <a:latin typeface="Calibri"/>
+              </a:rPr>
+              <a:t>arasında daha iyi bir denge sağlar mı?</a:t>
+            </a:r>
+          </a:p>
+        </p:txBody>
+      </p:sp>
+      <p:sp>
+        <p:nvSpPr>
+          <p:cNvPr id="8" name="TextBox 7"/>
+          <p:cNvSpPr txBox="1"/>
+          <p:nvPr/>
+        </p:nvSpPr>
+        <p:spPr>
+          <a:xfrm>
+            <a:off x="640080" y="3063240"/>
+            <a:ext cx="10972800" cy="411480"/>
+          </a:xfrm>
+          <a:prstGeom prst="rect">
+            <a:avLst/>
+          </a:prstGeom>
+          <a:noFill/>
+        </p:spPr>
+        <p:txBody>
+          <a:bodyPr wrap="square" anchor="t">
+            <a:spAutoFit/>
+          </a:bodyPr>
+          <a:lstStyle/>
+          <a:p>
+            <a:pPr algn="l">
+              <a:spcAft>
+                <a:spcPts val="500"/>
+              </a:spcAft>
+            </a:pPr>
+            <a:r>
               <a:rPr sz="2000" b="1">
                 <a:solidFill>
                   <a:srgbClr val="1A1A6A"/>
                 </a:solidFill>
                 <a:latin typeface="Calibri"/>
               </a:rPr>
-              <a:t>Hipotez:</a:t>
+              <a:t>Hipotez (beklentim):</a:t>
             </a:r>
           </a:p>
         </p:txBody>
@@ -11778,8 +12135,8 @@
         </p:nvSpPr>
         <p:spPr>
           <a:xfrm>
-            <a:off x="640080" y="4114800"/>
-            <a:ext cx="10972800" cy="4846320"/>
+            <a:off x="822960" y="3520440"/>
+            <a:ext cx="10607040" cy="2194560"/>
           </a:xfrm>
           <a:prstGeom prst="rect">
             <a:avLst/>
@@ -11787,40 +12144,120 @@
           <a:noFill/>
         </p:spPr>
         <p:txBody>
-          <a:bodyPr wrap="square">
+          <a:bodyPr wrap="square" anchor="t">
             <a:spAutoFit/>
           </a:bodyPr>
           <a:lstStyle/>
           <a:p>
-            <a:pPr>
-              <a:spcAft>
-                <a:spcPts val="700"/>
-              </a:spcAft>
-            </a:pPr>
-            <a:r>
-              <a:rPr sz="1800">
-                <a:solidFill>
-                  <a:srgbClr val="333333"/>
-                </a:solidFill>
-                <a:latin typeface="Calibri"/>
-              </a:rPr>
-              <a:t>•  Derecenin sürekli ayarlanabilmesi, aynı gürültü bastırmasını daha düşük</a:t>
-            </a:r>
-          </a:p>
-          <a:p>
-            <a:pPr lvl="1">
-              <a:spcAft>
-                <a:spcPts val="700"/>
-              </a:spcAft>
-            </a:pPr>
-            <a:r>
-              <a:rPr sz="1600">
-                <a:solidFill>
-                  <a:srgbClr val="333333"/>
-                </a:solidFill>
-                <a:latin typeface="Calibri"/>
-              </a:rPr>
-              <a:t>–  gecikme ve/veya daha az devre elemanı ile sağlar.</a:t>
+            <a:pPr algn="l">
+              <a:spcAft>
+                <a:spcPts val="500"/>
+              </a:spcAft>
+            </a:pPr>
+            <a:r>
+              <a:rPr sz="1800" b="0">
+                <a:solidFill>
+                  <a:srgbClr val="333333"/>
+                </a:solidFill>
+                <a:latin typeface="Calibri"/>
+              </a:rPr>
+              <a:t>Kesirli filtrede süzme keskinliğini SÜREKLİ ayarlayabiliyorum</a:t>
+            </a:r>
+          </a:p>
+          <a:p>
+            <a:pPr algn="l">
+              <a:spcAft>
+                <a:spcPts val="500"/>
+              </a:spcAft>
+            </a:pPr>
+            <a:r>
+              <a:rPr sz="1800" b="0">
+                <a:solidFill>
+                  <a:srgbClr val="333333"/>
+                </a:solidFill>
+                <a:latin typeface="Calibri"/>
+              </a:rPr>
+              <a:t>(örn. 1.5. derece gibi ara değerler mümkün).</a:t>
+            </a:r>
+          </a:p>
+          <a:p>
+            <a:pPr algn="l">
+              <a:spcAft>
+                <a:spcPts val="500"/>
+              </a:spcAft>
+            </a:pPr>
+            <a:r>
+              <a:rPr sz="1800" b="0">
+                <a:solidFill>
+                  <a:srgbClr val="333333"/>
+                </a:solidFill>
+                <a:latin typeface="Calibri"/>
+              </a:rPr>
+              <a:t/>
+            </a:r>
+          </a:p>
+          <a:p>
+            <a:pPr algn="l">
+              <a:spcAft>
+                <a:spcPts val="500"/>
+              </a:spcAft>
+            </a:pPr>
+            <a:r>
+              <a:rPr sz="1800" b="0">
+                <a:solidFill>
+                  <a:srgbClr val="333333"/>
+                </a:solidFill>
+                <a:latin typeface="Calibri"/>
+              </a:rPr>
+              <a:t>Bu sayede, klasik bir filtreyle AYNI gürültü bastırmasını:</a:t>
+            </a:r>
+          </a:p>
+          <a:p>
+            <a:pPr algn="l">
+              <a:spcAft>
+                <a:spcPts val="500"/>
+              </a:spcAft>
+            </a:pPr>
+            <a:r>
+              <a:rPr sz="1800" b="0">
+                <a:solidFill>
+                  <a:srgbClr val="333333"/>
+                </a:solidFill>
+                <a:latin typeface="Calibri"/>
+              </a:rPr>
+              <a:t>   • daha AZ devre elemanıyla, ve</a:t>
+            </a:r>
+          </a:p>
+          <a:p>
+            <a:pPr algn="l">
+              <a:spcAft>
+                <a:spcPts val="500"/>
+              </a:spcAft>
+            </a:pPr>
+            <a:r>
+              <a:rPr sz="1800" b="0">
+                <a:solidFill>
+                  <a:srgbClr val="333333"/>
+                </a:solidFill>
+                <a:latin typeface="Calibri"/>
+              </a:rPr>
+              <a:t>   • sinyalin dalga şeklini daha az bozarak (daha düşük gecikme)</a:t>
+            </a:r>
+          </a:p>
+          <a:p>
+            <a:pPr algn="l">
+              <a:spcAft>
+                <a:spcPts val="500"/>
+              </a:spcAft>
+            </a:pPr>
+            <a:r>
+              <a:rPr sz="1800" b="0">
+                <a:solidFill>
+                  <a:srgbClr val="333333"/>
+                </a:solidFill>
+                <a:latin typeface="Calibri"/>
+              </a:rPr>
+              <a:t>elde edebileceğimi düşünüyorum. Tez bunu deneyle sınayacak.</a:t>
             </a:r>
           </a:p>
         </p:txBody>
@@ -12107,7 +12544,7 @@
                 </a:solidFill>
                 <a:latin typeface="Calibri"/>
               </a:rPr>
-              <a:t>•  Geçiş bölgesi (transition band): ikisi arasındaki eğimli kısım — dar olması istenir.</a:t>
+              <a:t>•  Geçiş bölgesi: ikisi arasındaki eğimli kısım — dar olması istenir.</a:t>
             </a:r>
           </a:p>
           <a:p>
@@ -12139,7 +12576,7 @@
                 </a:solidFill>
                 <a:latin typeface="Calibri"/>
               </a:rPr>
-              <a:t>•  Grup gecikmesi: farklı frekansların ne kadar geciktiği; düz olması dalga şeklini korur.</a:t>
+              <a:t>•  Grup gecikmesi: frekansların ne kadar geciktiği; düz olması dalga şeklini korur.</a:t>
             </a:r>
           </a:p>
         </p:txBody>
@@ -12410,7 +12847,7 @@
                 </a:solidFill>
                 <a:latin typeface="Calibri"/>
               </a:rPr>
-              <a:t>•  Bant söndüren / çentik (BSF / notch): dar bir bandı atar (örn. 50 Hz şebeke girişimi).</a:t>
+              <a:t>•  Bant söndüren / çentik (BSF): dar bir bandı atar (örn. 50 Hz şebeke girişimi).</a:t>
             </a:r>
           </a:p>
           <a:p>
@@ -12649,7 +13086,7 @@
                 </a:solidFill>
                 <a:latin typeface="Calibri"/>
               </a:rPr>
-              <a:t>•  İdeal filtre = "tuğla duvar": geçen bandı tam geçirir, geri kalanı anında keser.</a:t>
+              <a:t>•  İdeal filtre = "tuğla duvar": geçen bandı tam geçirir, gerisini anında keser.</a:t>
             </a:r>
           </a:p>
           <a:p>
@@ -12697,7 +13134,7 @@
                 </a:solidFill>
                 <a:latin typeface="Calibri"/>
               </a:rPr>
-              <a:t>•  Bunlara literatürde "yaklaşım fonksiyonları" denir:</a:t>
+              <a:t>•  Literatürdeki adı: "yaklaşım fonksiyonları" (filter approximation functions).</a:t>
             </a:r>
           </a:p>
           <a:p>
@@ -12713,23 +13150,7 @@
                 </a:solidFill>
                 <a:latin typeface="Calibri"/>
               </a:rPr>
-              <a:t>–  İngilizce: filter approximation functions / approximation methods</a:t>
-            </a:r>
-          </a:p>
-          <a:p>
-            <a:pPr lvl="1">
-              <a:spcAft>
-                <a:spcPts val="700"/>
-              </a:spcAft>
-            </a:pPr>
-            <a:r>
-              <a:rPr sz="1700">
-                <a:solidFill>
-                  <a:srgbClr val="333333"/>
-                </a:solidFill>
-                <a:latin typeface="Calibri"/>
-              </a:rPr>
-              <a:t>–  Her aile ideale FARKLI bir özelliği optimize ederek yaklaşır</a:t>
+              <a:t>–  Her aile ideale FARKLI bir özelliği optimize ederek yaklaşır.</a:t>
             </a:r>
           </a:p>
           <a:p>
@@ -12758,7 +13179,7 @@
         </p:nvSpPr>
         <p:spPr>
           <a:xfrm>
-            <a:off x="640080" y="5852160"/>
+            <a:off x="640080" y="5760720"/>
             <a:ext cx="10972800" cy="548640"/>
           </a:xfrm>
           <a:prstGeom prst="rect">
@@ -12981,8 +13402,8 @@
         </p:nvSpPr>
         <p:spPr>
           <a:xfrm>
-            <a:off x="640080" y="1325880"/>
-            <a:ext cx="10972800" cy="2377440"/>
+            <a:off x="640080" y="1234440"/>
+            <a:ext cx="10972800" cy="1097280"/>
           </a:xfrm>
           <a:prstGeom prst="rect">
             <a:avLst/>
@@ -13001,77 +13422,29 @@
               </a:spcAft>
             </a:pPr>
             <a:r>
-              <a:rPr sz="1900">
-                <a:solidFill>
-                  <a:srgbClr val="333333"/>
-                </a:solidFill>
-                <a:latin typeface="Calibri"/>
-              </a:rPr>
-              <a:t>•  Butterworth — "maksimum düz": geçirme bandı dümdüz, dalgasız.</a:t>
-            </a:r>
-          </a:p>
-          <a:p>
-            <a:pPr lvl="1">
+              <a:rPr sz="1800">
+                <a:solidFill>
+                  <a:srgbClr val="333333"/>
+                </a:solidFill>
+                <a:latin typeface="Calibri"/>
+              </a:rPr>
+              <a:t>•  Butterworth — "maksimum düz": geçirme bandı dümdüz; geçiş yavaş.</a:t>
+            </a:r>
+          </a:p>
+          <a:p>
+            <a:pPr>
               <a:spcAft>
                 <a:spcPts val="700"/>
               </a:spcAft>
             </a:pPr>
             <a:r>
-              <a:rPr sz="1700">
-                <a:solidFill>
-                  <a:srgbClr val="333333"/>
-                </a:solidFill>
-                <a:latin typeface="Calibri"/>
-              </a:rPr>
-              <a:t>–  Avantaj: düzgün genlik. Dezavantaj: geçiş yavaş (yumuşak).</a:t>
-            </a:r>
-          </a:p>
-          <a:p>
-            <a:pPr>
-              <a:spcAft>
-                <a:spcPts val="700"/>
-              </a:spcAft>
-            </a:pPr>
-            <a:r>
-              <a:rPr sz="1900">
-                <a:solidFill>
-                  <a:srgbClr val="333333"/>
-                </a:solidFill>
-                <a:latin typeface="Calibri"/>
-              </a:rPr>
-              <a:t>•  Chebyshev Tip I — geçiş daha keskin, ama geçirme bandında DALGA (ripple) var.</a:t>
-            </a:r>
-          </a:p>
-          <a:p>
-            <a:pPr lvl="1">
-              <a:spcAft>
-                <a:spcPts val="700"/>
-              </a:spcAft>
-            </a:pPr>
-            <a:r>
-              <a:rPr sz="1700">
-                <a:solidFill>
-                  <a:srgbClr val="333333"/>
-                </a:solidFill>
-                <a:latin typeface="Calibri"/>
-              </a:rPr>
-              <a:t>–  Tip II: dalgayı durdurma bandına taşır.</a:t>
-            </a:r>
-          </a:p>
-          <a:p>
-            <a:pPr lvl="1">
-              <a:spcAft>
-                <a:spcPts val="700"/>
-              </a:spcAft>
-            </a:pPr>
-            <a:r>
-              <a:rPr sz="1700">
-                <a:solidFill>
-                  <a:srgbClr val="333333"/>
-                </a:solidFill>
-                <a:latin typeface="Calibri"/>
-              </a:rPr>
-              <a:t>–  Avantaj: aynı derecede daha dik geçiş. Dezavantaj: dalga + kötü faz.</a:t>
+              <a:rPr sz="1800">
+                <a:solidFill>
+                  <a:srgbClr val="333333"/>
+                </a:solidFill>
+                <a:latin typeface="Calibri"/>
+              </a:rPr>
+              <a:t>•  Chebyshev I — daha keskin geçiş; ama geçirme bandında DALGA (ripple).</a:t>
             </a:r>
           </a:p>
         </p:txBody>
@@ -13084,18 +13457,18 @@
         </p:nvSpPr>
         <p:spPr>
           <a:xfrm>
-            <a:off x="731520" y="3840480"/>
-            <a:ext cx="10698480" cy="914400"/>
+            <a:off x="883767" y="2221992"/>
+            <a:ext cx="10424160" cy="3425135"/>
           </a:xfrm>
           <a:prstGeom prst="rect">
             <a:avLst/>
           </a:prstGeom>
           <a:solidFill>
-            <a:srgbClr val="F4F4F4"/>
+            <a:srgbClr val="F7F9FF"/>
           </a:solidFill>
-          <a:ln w="9525">
+          <a:ln w="12700">
             <a:solidFill>
-              <a:srgbClr val="CCCCCC"/>
+              <a:srgbClr val="D3DEF2"/>
             </a:solidFill>
           </a:ln>
           <a:effectLst/>
@@ -13115,43 +13488,47 @@
           </a:fontRef>
         </p:style>
         <p:txBody>
-          <a:bodyPr rtlCol="0" anchor="ctr" wrap="square" lIns="182880" tIns="73152"/>
+          <a:bodyPr rtlCol="0" anchor="ctr"/>
           <a:lstStyle/>
           <a:p>
             <a:pPr algn="ctr"/>
-            <a:r>
-              <a:rPr sz="1500" b="1">
-                <a:solidFill>
-                  <a:srgbClr val="1A1A6A"/>
-                </a:solidFill>
-                <a:latin typeface="Consolas"/>
-              </a:rPr>
-              <a:t>Butterworth: |H(jw)|^2 = 1 / ( 1 + (w/wc)^(2n) )</a:t>
-            </a:r>
-          </a:p>
-          <a:p>
-            <a:r>
-              <a:rPr sz="1500" b="1">
-                <a:solidFill>
-                  <a:srgbClr val="1A1A6A"/>
-                </a:solidFill>
-                <a:latin typeface="Consolas"/>
-              </a:rPr>
-              <a:t>Chebyshev I : |H(jw)|^2 = 1 / ( 1 + e^2 * Tn^2(w/wc) )</a:t>
-            </a:r>
-          </a:p>
-        </p:txBody>
-      </p:sp>
-      <p:sp>
-        <p:nvSpPr>
-          <p:cNvPr id="8" name="TextBox 7"/>
+          </a:p>
+        </p:txBody>
+      </p:sp>
+      <p:pic>
+        <p:nvPicPr>
+          <p:cNvPr id="8" name="Picture 7" descr="bw_cb.png"/>
+          <p:cNvPicPr>
+            <a:picLocks noChangeAspect="1"/>
+          </p:cNvPicPr>
+          <p:nvPr/>
+        </p:nvPicPr>
+        <p:blipFill>
+          <a:blip r:embed="rId2"/>
+          <a:stretch>
+            <a:fillRect/>
+          </a:stretch>
+        </p:blipFill>
+        <p:spPr>
+          <a:xfrm>
+            <a:off x="1066647" y="2331720"/>
+            <a:ext cx="10058400" cy="3205679"/>
+          </a:xfrm>
+          <a:prstGeom prst="rect">
+            <a:avLst/>
+          </a:prstGeom>
+        </p:spPr>
+      </p:pic>
+      <p:sp>
+        <p:nvSpPr>
+          <p:cNvPr id="9" name="TextBox 8"/>
           <p:cNvSpPr txBox="1"/>
           <p:nvPr/>
         </p:nvSpPr>
         <p:spPr>
           <a:xfrm>
-            <a:off x="731520" y="4846320"/>
-            <a:ext cx="10698480" cy="365760"/>
+            <a:off x="822960" y="5848295"/>
+            <a:ext cx="10515600" cy="365760"/>
           </a:xfrm>
           <a:prstGeom prst="rect">
             <a:avLst/>
@@ -13165,11 +13542,10 @@
           <a:lstStyle/>
           <a:p>
             <a:r>
-              <a:rPr b="1" sz="1400">
+              <a:rPr b="1" sz="1500">
                 <a:solidFill>
                   <a:srgbClr val="1A1A6A"/>
                 </a:solidFill>
-                <a:latin typeface="Calibri"/>
               </a:rPr>
               <a:t>Burada:</a:t>
             </a:r>
@@ -13178,14 +13554,14 @@
       </p:sp>
       <p:sp>
         <p:nvSpPr>
-          <p:cNvPr id="9" name="TextBox 8"/>
+          <p:cNvPr id="10" name="TextBox 9"/>
           <p:cNvSpPr txBox="1"/>
           <p:nvPr/>
         </p:nvSpPr>
         <p:spPr>
           <a:xfrm>
-            <a:off x="731520" y="5230368"/>
-            <a:ext cx="10698480" cy="2743200"/>
+            <a:off x="822960" y="6214055"/>
+            <a:ext cx="10515600" cy="2743200"/>
           </a:xfrm>
           <a:prstGeom prst="rect">
             <a:avLst/>
@@ -13204,16 +13580,16 @@
               </a:spcAft>
             </a:pPr>
             <a:r>
-              <a:rPr b="1" sz="1400">
+              <a:rPr b="1" sz="1500">
                 <a:solidFill>
                   <a:srgbClr val="1B6B3A"/>
                 </a:solidFill>
                 <a:latin typeface="Consolas"/>
               </a:rPr>
-              <a:t>w : </a:t>
-            </a:r>
-            <a:r>
-              <a:rPr sz="1400">
+              <a:t>ω  :  </a:t>
+            </a:r>
+            <a:r>
+              <a:rPr sz="1500">
                 <a:solidFill>
                   <a:srgbClr val="333333"/>
                 </a:solidFill>
@@ -13229,16 +13605,16 @@
               </a:spcAft>
             </a:pPr>
             <a:r>
-              <a:rPr b="1" sz="1400">
+              <a:rPr b="1" sz="1500">
                 <a:solidFill>
                   <a:srgbClr val="1B6B3A"/>
                 </a:solidFill>
                 <a:latin typeface="Consolas"/>
               </a:rPr>
-              <a:t>wc : </a:t>
-            </a:r>
-            <a:r>
-              <a:rPr sz="1400">
+              <a:t>ω_c  :  </a:t>
+            </a:r>
+            <a:r>
+              <a:rPr sz="1500">
                 <a:solidFill>
                   <a:srgbClr val="333333"/>
                 </a:solidFill>
@@ -13254,16 +13630,16 @@
               </a:spcAft>
             </a:pPr>
             <a:r>
-              <a:rPr b="1" sz="1400">
+              <a:rPr b="1" sz="1500">
                 <a:solidFill>
                   <a:srgbClr val="1B6B3A"/>
                 </a:solidFill>
                 <a:latin typeface="Consolas"/>
               </a:rPr>
-              <a:t>n : </a:t>
-            </a:r>
-            <a:r>
-              <a:rPr sz="1400">
+              <a:t>n  :  </a:t>
+            </a:r>
+            <a:r>
+              <a:rPr sz="1500">
                 <a:solidFill>
                   <a:srgbClr val="333333"/>
                 </a:solidFill>
@@ -13279,22 +13655,22 @@
               </a:spcAft>
             </a:pPr>
             <a:r>
-              <a:rPr b="1" sz="1400">
+              <a:rPr b="1" sz="1500">
                 <a:solidFill>
                   <a:srgbClr val="1B6B3A"/>
                 </a:solidFill>
                 <a:latin typeface="Consolas"/>
               </a:rPr>
-              <a:t>e : </a:t>
-            </a:r>
-            <a:r>
-              <a:rPr sz="1400">
-                <a:solidFill>
-                  <a:srgbClr val="333333"/>
-                </a:solidFill>
-                <a:latin typeface="Calibri"/>
-              </a:rPr>
-              <a:t>dalga (ripple) parametresi</a:t>
+              <a:t>ε  :  </a:t>
+            </a:r>
+            <a:r>
+              <a:rPr sz="1500">
+                <a:solidFill>
+                  <a:srgbClr val="333333"/>
+                </a:solidFill>
+                <a:latin typeface="Calibri"/>
+              </a:rPr>
+              <a:t>dalga/ripple parametresi</a:t>
             </a:r>
           </a:p>
           <a:p>
@@ -13304,16 +13680,16 @@
               </a:spcAft>
             </a:pPr>
             <a:r>
-              <a:rPr b="1" sz="1400">
+              <a:rPr b="1" sz="1500">
                 <a:solidFill>
                   <a:srgbClr val="1B6B3A"/>
                 </a:solidFill>
                 <a:latin typeface="Consolas"/>
               </a:rPr>
-              <a:t>Tn : </a:t>
-            </a:r>
-            <a:r>
-              <a:rPr sz="1400">
+              <a:t>T_n  :  </a:t>
+            </a:r>
+            <a:r>
+              <a:rPr sz="1500">
                 <a:solidFill>
                   <a:srgbClr val="333333"/>
                 </a:solidFill>
@@ -13542,7 +13918,7 @@
                 </a:solidFill>
                 <a:latin typeface="Calibri"/>
               </a:rPr>
-              <a:t>•  Bessel — "maksimum düz GECİKME": amaç dik geçiş değil, DALGA ŞEKLİNİ korumak.</a:t>
+              <a:t>•  Bessel — "maksimum düz GECİKME": amaç dik geçiş değil, dalga şeklini korumak.</a:t>
             </a:r>
           </a:p>
           <a:p>
@@ -13558,7 +13934,7 @@
                 </a:solidFill>
                 <a:latin typeface="Calibri"/>
               </a:rPr>
-              <a:t>–  Grup gecikmesi düzdür → darbeler bozulmadan, AŞMA (overshoot) olmadan geçer.</a:t>
+              <a:t>–  Grup gecikmesi düz → darbeler AŞMA (overshoot) olmadan geçer.</a:t>
             </a:r>
           </a:p>
           <a:p>
@@ -13574,7 +13950,7 @@
                 </a:solidFill>
                 <a:latin typeface="Calibri"/>
               </a:rPr>
-              <a:t>–  Bedeli: geçiş en yumuşak olanıdır. Darbe sensörleri (PMT) için idealdir.</a:t>
+              <a:t>–  Bedeli: en yumuşak geçiş. Darbe sensörleri (PMT) için idealdir.</a:t>
             </a:r>
           </a:p>
           <a:p>
@@ -13606,7 +13982,7 @@
                 </a:solidFill>
                 <a:latin typeface="Calibri"/>
               </a:rPr>
-              <a:t>–  Bedeli: HEM geçirme HEM durdurma bandında dalga + en kötü faz/gecikme.</a:t>
+              <a:t>–  Bedeli: HEM geçirme HEM durdurma bandında dalga + en kötü gecikme.</a:t>
             </a:r>
           </a:p>
           <a:p>
@@ -13622,7 +13998,7 @@
                 </a:solidFill>
                 <a:latin typeface="Calibri"/>
               </a:rPr>
-              <a:t>–  Çok dar geçiş gereken (örn. dar kanal ayırma) yerlerde tercih edilir.</a:t>
+              <a:t>–  Çok dar geçiş gereken (dar kanal ayırma) yerlerde tercih edilir.</a:t>
             </a:r>
           </a:p>
         </p:txBody>
@@ -13661,7 +14037,7 @@
                 </a:solidFill>
                 <a:latin typeface="Calibri"/>
               </a:rPr>
-              <a:t>Özet sezgi: Bessel = en iyi ZAMAN davranışı (dalga şekli) ;</a:t>
+              <a:t>Özet sezgi: Bessel = en iyi ZAMAN davranışı (dalga şekli);</a:t>
             </a:r>
           </a:p>
           <a:p>

</xml_diff>

<commit_message>
Sunum: uc sensorun sematik gorselleri eklendi (slayt 22)
LP252 (4-20 mA), R6094/R6095 PMT (akim darbesi), H7711-03 (TTL) icin
cikis tipi etiketli temiz sematik cizimler matplotlib ile uretildi.

https://claude.ai/code/session_012Z6u7LYkVNiDoU5RtS1RWf
</commit_message>
<xml_diff>
--- a/analog-filtre-tez/EEM537_Sunum_SelinACAR.pptx
+++ b/analog-filtre-tez/EEM537_Sunum_SelinACAR.pptx
@@ -9386,8 +9386,8 @@
         </p:nvSpPr>
         <p:spPr>
           <a:xfrm>
-            <a:off x="640080" y="1417320"/>
-            <a:ext cx="10972800" cy="4846320"/>
+            <a:off x="640080" y="1188720"/>
+            <a:ext cx="10972800" cy="1828800"/>
           </a:xfrm>
           <a:prstGeom prst="rect">
             <a:avLst/>
@@ -9406,29 +9406,29 @@
               </a:spcAft>
             </a:pPr>
             <a:r>
-              <a:rPr sz="2000">
-                <a:solidFill>
-                  <a:srgbClr val="333333"/>
-                </a:solidFill>
-                <a:latin typeface="Calibri"/>
-              </a:rPr>
-              <a:t>•  CTC LP252-1R1-1E — 4-20 mA döngü-beslemeli titreşim (hız) transmitteri</a:t>
-            </a:r>
-          </a:p>
-          <a:p>
-            <a:pPr lvl="1">
+              <a:rPr sz="1600">
+                <a:solidFill>
+                  <a:srgbClr val="333333"/>
+                </a:solidFill>
+                <a:latin typeface="Calibri"/>
+              </a:rPr>
+              <a:t>•  CTC LP252 — 4-20 mA titreşim (hız) transmitteri: 0–1.0 IPS RMS, 10–1000 Hz; ISO 20816.</a:t>
+            </a:r>
+          </a:p>
+          <a:p>
+            <a:pPr>
               <a:spcAft>
                 <a:spcPts val="700"/>
               </a:spcAft>
             </a:pPr>
             <a:r>
-              <a:rPr sz="1800">
-                <a:solidFill>
-                  <a:srgbClr val="333333"/>
-                </a:solidFill>
-                <a:latin typeface="Calibri"/>
-              </a:rPr>
-              <a:t>–  0–1.0 IPS RMS (~0–25.4 mm/s), 10–1000 Hz; ISO 20816 kestirimci bakım</a:t>
+              <a:rPr sz="1600">
+                <a:solidFill>
+                  <a:srgbClr val="333333"/>
+                </a:solidFill>
+                <a:latin typeface="Calibri"/>
+              </a:rPr>
+              <a:t>•  Hamamatsu R6094/R6095 — PMT: 28 mm, bialkali, 300–650 nm; anot AKIM darbeleri.</a:t>
             </a:r>
           </a:p>
           <a:p>
@@ -9438,61 +9438,379 @@
               </a:spcAft>
             </a:pPr>
             <a:r>
-              <a:rPr sz="2000">
-                <a:solidFill>
-                  <a:srgbClr val="333333"/>
-                </a:solidFill>
-                <a:latin typeface="Calibri"/>
-              </a:rPr>
-              <a:t>•  Hamamatsu R6094/R6095 — fotoçoğaltıcı tüp (PMT)</a:t>
-            </a:r>
-          </a:p>
-          <a:p>
-            <a:pPr lvl="1">
-              <a:spcAft>
-                <a:spcPts val="700"/>
-              </a:spcAft>
-            </a:pPr>
-            <a:r>
-              <a:rPr sz="1800">
-                <a:solidFill>
-                  <a:srgbClr val="333333"/>
-                </a:solidFill>
-                <a:latin typeface="Calibri"/>
-              </a:rPr>
-              <a:t>–  28 mm head-on, bialkali, 300–650 nm, ~2000 V; anot AKIM DARBELERİ</a:t>
-            </a:r>
-          </a:p>
-          <a:p>
-            <a:pPr>
-              <a:spcAft>
-                <a:spcPts val="700"/>
-              </a:spcAft>
-            </a:pPr>
-            <a:r>
-              <a:rPr sz="2000">
-                <a:solidFill>
-                  <a:srgbClr val="333333"/>
-                </a:solidFill>
-                <a:latin typeface="Calibri"/>
-              </a:rPr>
-              <a:t>•  Hamamatsu H7711-03 — foton sayma kafası</a:t>
-            </a:r>
-          </a:p>
-          <a:p>
-            <a:pPr lvl="1">
-              <a:spcAft>
-                <a:spcPts val="700"/>
-              </a:spcAft>
-            </a:pPr>
-            <a:r>
-              <a:rPr sz="1800">
-                <a:solidFill>
-                  <a:srgbClr val="333333"/>
-                </a:solidFill>
-                <a:latin typeface="Calibri"/>
-              </a:rPr>
-              <a:t>–  İçinde HV + amp + diskriminatör; TTL DARBE (frekans) çıkışı; referans modül</a:t>
+              <a:rPr sz="1600">
+                <a:solidFill>
+                  <a:srgbClr val="333333"/>
+                </a:solidFill>
+                <a:latin typeface="Calibri"/>
+              </a:rPr>
+              <a:t>•  Hamamatsu H7711-03 — foton sayma kafası: HV+amp+diskriminatör; TTL DARBE (frekans).</a:t>
+            </a:r>
+          </a:p>
+        </p:txBody>
+      </p:sp>
+      <p:sp>
+        <p:nvSpPr>
+          <p:cNvPr id="7" name="Rectangle 6"/>
+          <p:cNvSpPr/>
+          <p:nvPr/>
+        </p:nvSpPr>
+        <p:spPr>
+          <a:xfrm>
+            <a:off x="685800" y="3063240"/>
+            <a:ext cx="2651760" cy="2651760"/>
+          </a:xfrm>
+          <a:prstGeom prst="rect">
+            <a:avLst/>
+          </a:prstGeom>
+          <a:solidFill>
+            <a:srgbClr val="F7F9FF"/>
+          </a:solidFill>
+          <a:ln w="12700">
+            <a:solidFill>
+              <a:srgbClr val="D3DEF2"/>
+            </a:solidFill>
+          </a:ln>
+          <a:effectLst/>
+        </p:spPr>
+        <p:style>
+          <a:lnRef idx="1">
+            <a:schemeClr val="accent1"/>
+          </a:lnRef>
+          <a:fillRef idx="3">
+            <a:schemeClr val="accent1"/>
+          </a:fillRef>
+          <a:effectRef idx="2">
+            <a:schemeClr val="accent1"/>
+          </a:effectRef>
+          <a:fontRef idx="minor">
+            <a:schemeClr val="lt1"/>
+          </a:fontRef>
+        </p:style>
+        <p:txBody>
+          <a:bodyPr rtlCol="0" anchor="ctr"/>
+          <a:lstStyle/>
+          <a:p>
+            <a:pPr algn="ctr"/>
+          </a:p>
+        </p:txBody>
+      </p:sp>
+      <p:pic>
+        <p:nvPicPr>
+          <p:cNvPr id="8" name="Picture 7" descr="sx_lp252.png"/>
+          <p:cNvPicPr>
+            <a:picLocks noChangeAspect="1"/>
+          </p:cNvPicPr>
+          <p:nvPr/>
+        </p:nvPicPr>
+        <p:blipFill>
+          <a:blip r:embed="rId2"/>
+          <a:stretch>
+            <a:fillRect/>
+          </a:stretch>
+        </p:blipFill>
+        <p:spPr>
+          <a:xfrm>
+            <a:off x="731520" y="3108960"/>
+            <a:ext cx="2560320" cy="2560320"/>
+          </a:xfrm>
+          <a:prstGeom prst="rect">
+            <a:avLst/>
+          </a:prstGeom>
+        </p:spPr>
+      </p:pic>
+      <p:sp>
+        <p:nvSpPr>
+          <p:cNvPr id="9" name="TextBox 8"/>
+          <p:cNvSpPr txBox="1"/>
+          <p:nvPr/>
+        </p:nvSpPr>
+        <p:spPr>
+          <a:xfrm>
+            <a:off x="640080" y="5897880"/>
+            <a:ext cx="2743200" cy="457200"/>
+          </a:xfrm>
+          <a:prstGeom prst="rect">
+            <a:avLst/>
+          </a:prstGeom>
+          <a:noFill/>
+        </p:spPr>
+        <p:txBody>
+          <a:bodyPr wrap="square" anchor="t">
+            <a:spAutoFit/>
+          </a:bodyPr>
+          <a:lstStyle/>
+          <a:p>
+            <a:pPr algn="ctr">
+              <a:spcAft>
+                <a:spcPts val="500"/>
+              </a:spcAft>
+            </a:pPr>
+            <a:r>
+              <a:rPr sz="1300" b="1">
+                <a:solidFill>
+                  <a:srgbClr val="1A1A6A"/>
+                </a:solidFill>
+                <a:latin typeface="Calibri"/>
+              </a:rPr>
+              <a:t>CTC LP252  (4-20 mA, akım)</a:t>
+            </a:r>
+          </a:p>
+        </p:txBody>
+      </p:sp>
+      <p:sp>
+        <p:nvSpPr>
+          <p:cNvPr id="10" name="Rectangle 9"/>
+          <p:cNvSpPr/>
+          <p:nvPr/>
+        </p:nvSpPr>
+        <p:spPr>
+          <a:xfrm>
+            <a:off x="4773168" y="3063240"/>
+            <a:ext cx="2651760" cy="2651760"/>
+          </a:xfrm>
+          <a:prstGeom prst="rect">
+            <a:avLst/>
+          </a:prstGeom>
+          <a:solidFill>
+            <a:srgbClr val="F7F9FF"/>
+          </a:solidFill>
+          <a:ln w="12700">
+            <a:solidFill>
+              <a:srgbClr val="D3DEF2"/>
+            </a:solidFill>
+          </a:ln>
+          <a:effectLst/>
+        </p:spPr>
+        <p:style>
+          <a:lnRef idx="1">
+            <a:schemeClr val="accent1"/>
+          </a:lnRef>
+          <a:fillRef idx="3">
+            <a:schemeClr val="accent1"/>
+          </a:fillRef>
+          <a:effectRef idx="2">
+            <a:schemeClr val="accent1"/>
+          </a:effectRef>
+          <a:fontRef idx="minor">
+            <a:schemeClr val="lt1"/>
+          </a:fontRef>
+        </p:style>
+        <p:txBody>
+          <a:bodyPr rtlCol="0" anchor="ctr"/>
+          <a:lstStyle/>
+          <a:p>
+            <a:pPr algn="ctr"/>
+          </a:p>
+        </p:txBody>
+      </p:sp>
+      <p:pic>
+        <p:nvPicPr>
+          <p:cNvPr id="11" name="Picture 10" descr="sx_pmt.png"/>
+          <p:cNvPicPr>
+            <a:picLocks noChangeAspect="1"/>
+          </p:cNvPicPr>
+          <p:nvPr/>
+        </p:nvPicPr>
+        <p:blipFill>
+          <a:blip r:embed="rId3"/>
+          <a:stretch>
+            <a:fillRect/>
+          </a:stretch>
+        </p:blipFill>
+        <p:spPr>
+          <a:xfrm>
+            <a:off x="4818888" y="3108960"/>
+            <a:ext cx="2560320" cy="2560320"/>
+          </a:xfrm>
+          <a:prstGeom prst="rect">
+            <a:avLst/>
+          </a:prstGeom>
+        </p:spPr>
+      </p:pic>
+      <p:sp>
+        <p:nvSpPr>
+          <p:cNvPr id="12" name="TextBox 11"/>
+          <p:cNvSpPr txBox="1"/>
+          <p:nvPr/>
+        </p:nvSpPr>
+        <p:spPr>
+          <a:xfrm>
+            <a:off x="4727448" y="5897880"/>
+            <a:ext cx="2743200" cy="457200"/>
+          </a:xfrm>
+          <a:prstGeom prst="rect">
+            <a:avLst/>
+          </a:prstGeom>
+          <a:noFill/>
+        </p:spPr>
+        <p:txBody>
+          <a:bodyPr wrap="square" anchor="t">
+            <a:spAutoFit/>
+          </a:bodyPr>
+          <a:lstStyle/>
+          <a:p>
+            <a:pPr algn="ctr">
+              <a:spcAft>
+                <a:spcPts val="500"/>
+              </a:spcAft>
+            </a:pPr>
+            <a:r>
+              <a:rPr sz="1300" b="1">
+                <a:solidFill>
+                  <a:srgbClr val="1A1A6A"/>
+                </a:solidFill>
+                <a:latin typeface="Calibri"/>
+              </a:rPr>
+              <a:t>R6094/R6095  (PMT, akım darbesi)</a:t>
+            </a:r>
+          </a:p>
+        </p:txBody>
+      </p:sp>
+      <p:sp>
+        <p:nvSpPr>
+          <p:cNvPr id="13" name="Rectangle 12"/>
+          <p:cNvSpPr/>
+          <p:nvPr/>
+        </p:nvSpPr>
+        <p:spPr>
+          <a:xfrm>
+            <a:off x="8851392" y="3063240"/>
+            <a:ext cx="2651760" cy="2651760"/>
+          </a:xfrm>
+          <a:prstGeom prst="rect">
+            <a:avLst/>
+          </a:prstGeom>
+          <a:solidFill>
+            <a:srgbClr val="F7F9FF"/>
+          </a:solidFill>
+          <a:ln w="12700">
+            <a:solidFill>
+              <a:srgbClr val="D3DEF2"/>
+            </a:solidFill>
+          </a:ln>
+          <a:effectLst/>
+        </p:spPr>
+        <p:style>
+          <a:lnRef idx="1">
+            <a:schemeClr val="accent1"/>
+          </a:lnRef>
+          <a:fillRef idx="3">
+            <a:schemeClr val="accent1"/>
+          </a:fillRef>
+          <a:effectRef idx="2">
+            <a:schemeClr val="accent1"/>
+          </a:effectRef>
+          <a:fontRef idx="minor">
+            <a:schemeClr val="lt1"/>
+          </a:fontRef>
+        </p:style>
+        <p:txBody>
+          <a:bodyPr rtlCol="0" anchor="ctr"/>
+          <a:lstStyle/>
+          <a:p>
+            <a:pPr algn="ctr"/>
+          </a:p>
+        </p:txBody>
+      </p:sp>
+      <p:pic>
+        <p:nvPicPr>
+          <p:cNvPr id="14" name="Picture 13" descr="sx_h7711.png"/>
+          <p:cNvPicPr>
+            <a:picLocks noChangeAspect="1"/>
+          </p:cNvPicPr>
+          <p:nvPr/>
+        </p:nvPicPr>
+        <p:blipFill>
+          <a:blip r:embed="rId4"/>
+          <a:stretch>
+            <a:fillRect/>
+          </a:stretch>
+        </p:blipFill>
+        <p:spPr>
+          <a:xfrm>
+            <a:off x="8897112" y="3108960"/>
+            <a:ext cx="2560320" cy="2560320"/>
+          </a:xfrm>
+          <a:prstGeom prst="rect">
+            <a:avLst/>
+          </a:prstGeom>
+        </p:spPr>
+      </p:pic>
+      <p:sp>
+        <p:nvSpPr>
+          <p:cNvPr id="15" name="TextBox 14"/>
+          <p:cNvSpPr txBox="1"/>
+          <p:nvPr/>
+        </p:nvSpPr>
+        <p:spPr>
+          <a:xfrm>
+            <a:off x="8805672" y="5897880"/>
+            <a:ext cx="2743200" cy="457200"/>
+          </a:xfrm>
+          <a:prstGeom prst="rect">
+            <a:avLst/>
+          </a:prstGeom>
+          <a:noFill/>
+        </p:spPr>
+        <p:txBody>
+          <a:bodyPr wrap="square" anchor="t">
+            <a:spAutoFit/>
+          </a:bodyPr>
+          <a:lstStyle/>
+          <a:p>
+            <a:pPr algn="ctr">
+              <a:spcAft>
+                <a:spcPts val="500"/>
+              </a:spcAft>
+            </a:pPr>
+            <a:r>
+              <a:rPr sz="1300" b="1">
+                <a:solidFill>
+                  <a:srgbClr val="1A1A6A"/>
+                </a:solidFill>
+                <a:latin typeface="Calibri"/>
+              </a:rPr>
+              <a:t>H7711-03  (foton sayma, TTL)</a:t>
+            </a:r>
+          </a:p>
+        </p:txBody>
+      </p:sp>
+      <p:sp>
+        <p:nvSpPr>
+          <p:cNvPr id="16" name="TextBox 15"/>
+          <p:cNvSpPr txBox="1"/>
+          <p:nvPr/>
+        </p:nvSpPr>
+        <p:spPr>
+          <a:xfrm>
+            <a:off x="548640" y="6400800"/>
+            <a:ext cx="11064240" cy="365760"/>
+          </a:xfrm>
+          <a:prstGeom prst="rect">
+            <a:avLst/>
+          </a:prstGeom>
+          <a:noFill/>
+        </p:spPr>
+        <p:txBody>
+          <a:bodyPr wrap="square" anchor="t">
+            <a:spAutoFit/>
+          </a:bodyPr>
+          <a:lstStyle/>
+          <a:p>
+            <a:pPr algn="ctr">
+              <a:spcAft>
+                <a:spcPts val="500"/>
+              </a:spcAft>
+            </a:pPr>
+            <a:r>
+              <a:rPr sz="1100" b="0">
+                <a:solidFill>
+                  <a:srgbClr val="333333"/>
+                </a:solidFill>
+                <a:latin typeface="Calibri"/>
+              </a:rPr>
+              <a:t>(Görseller şematik temsildir; ürün fotoğrafları/datasheet için kaynakçaya bk.)</a:t>
             </a:r>
           </a:p>
         </p:txBody>

</xml_diff>

<commit_message>
Sunum: sensor bazinda temiz 'Deney Tasarimi' slayti eklendi (slayt 24)
Uc sensor icin ayri kartlar (ikon + Deney + Olcut), altta ortak yaklasim
notu. Sonraki slaytlarin numaralari kaydirildi (toplam 29 slayt).

https://claude.ai/code/session_012Z6u7LYkVNiDoU5RtS1RWf
</commit_message>
<xml_diff>
--- a/analog-filtre-tez/EEM537_Sunum_SelinACAR.pptx
+++ b/analog-filtre-tez/EEM537_Sunum_SelinACAR.pptx
@@ -33,6 +33,7 @@
     <p:sldId id="281" r:id="rId32"/>
     <p:sldId id="282" r:id="rId33"/>
     <p:sldId id="283" r:id="rId34"/>
+    <p:sldId id="284" r:id="rId35"/>
   </p:sldIdLst>
   <p:sldSz cx="12191695" cy="6858000" type="screen4x3"/>
   <p:notesSz cx="6858000" cy="9144000"/>
@@ -10258,7 +10259,7 @@
                 </a:solidFill>
                 <a:latin typeface="Calibri"/>
               </a:rPr>
-              <a:t>11. Çalışmanın Özgünlüğü</a:t>
+              <a:t>10. Deney Tasarımı — Sensör Bazında</a:t>
             </a:r>
           </a:p>
         </p:txBody>
@@ -10304,14 +10305,84 @@
       </p:sp>
       <p:sp>
         <p:nvSpPr>
-          <p:cNvPr id="6" name="TextBox 5"/>
+          <p:cNvPr id="6" name="Rounded Rectangle 5"/>
+          <p:cNvSpPr/>
+          <p:nvPr/>
+        </p:nvSpPr>
+        <p:spPr>
+          <a:xfrm>
+            <a:off x="457200" y="1298448"/>
+            <a:ext cx="11274552" cy="1572768"/>
+          </a:xfrm>
+          <a:prstGeom prst="roundRect">
+            <a:avLst/>
+          </a:prstGeom>
+          <a:solidFill>
+            <a:srgbClr val="EEF4FF"/>
+          </a:solidFill>
+          <a:ln w="12700">
+            <a:solidFill>
+              <a:srgbClr val="C3D2EC"/>
+            </a:solidFill>
+          </a:ln>
+          <a:effectLst/>
+        </p:spPr>
+        <p:style>
+          <a:lnRef idx="1">
+            <a:schemeClr val="accent1"/>
+          </a:lnRef>
+          <a:fillRef idx="3">
+            <a:schemeClr val="accent1"/>
+          </a:fillRef>
+          <a:effectRef idx="2">
+            <a:schemeClr val="accent1"/>
+          </a:effectRef>
+          <a:fontRef idx="minor">
+            <a:schemeClr val="lt1"/>
+          </a:fontRef>
+        </p:style>
+        <p:txBody>
+          <a:bodyPr rtlCol="0" anchor="ctr"/>
+          <a:lstStyle/>
+          <a:p>
+            <a:pPr algn="ctr"/>
+          </a:p>
+        </p:txBody>
+      </p:sp>
+      <p:pic>
+        <p:nvPicPr>
+          <p:cNvPr id="7" name="Picture 6" descr="sx_lp252.png"/>
+          <p:cNvPicPr>
+            <a:picLocks noChangeAspect="1"/>
+          </p:cNvPicPr>
+          <p:nvPr/>
+        </p:nvPicPr>
+        <p:blipFill>
+          <a:blip r:embed="rId2"/>
+          <a:stretch>
+            <a:fillRect/>
+          </a:stretch>
+        </p:blipFill>
+        <p:spPr>
+          <a:xfrm>
+            <a:off x="822960" y="1421892"/>
+            <a:ext cx="1325880" cy="1325880"/>
+          </a:xfrm>
+          <a:prstGeom prst="rect">
+            <a:avLst/>
+          </a:prstGeom>
+        </p:spPr>
+      </p:pic>
+      <p:sp>
+        <p:nvSpPr>
+          <p:cNvPr id="8" name="TextBox 7"/>
           <p:cNvSpPr txBox="1"/>
           <p:nvPr/>
         </p:nvSpPr>
         <p:spPr>
           <a:xfrm>
-            <a:off x="640080" y="1371600"/>
-            <a:ext cx="10972800" cy="4846320"/>
+            <a:off x="2377440" y="1417320"/>
+            <a:ext cx="9052560" cy="457200"/>
           </a:xfrm>
           <a:prstGeom prst="rect">
             <a:avLst/>
@@ -10319,120 +10390,515 @@
           <a:noFill/>
         </p:spPr>
         <p:txBody>
-          <a:bodyPr wrap="square">
+          <a:bodyPr wrap="square" anchor="t">
             <a:spAutoFit/>
           </a:bodyPr>
           <a:lstStyle/>
           <a:p>
-            <a:pPr>
-              <a:spcAft>
-                <a:spcPts val="700"/>
-              </a:spcAft>
-            </a:pPr>
-            <a:r>
-              <a:rPr sz="1900">
-                <a:solidFill>
-                  <a:srgbClr val="333333"/>
-                </a:solidFill>
-                <a:latin typeface="Calibri"/>
-              </a:rPr>
-              <a:t>•  Kesirli filtreler literatürde çoğunlukla biyomedikal/teorik bağlamda çalışılmış.</a:t>
-            </a:r>
-          </a:p>
-          <a:p>
-            <a:pPr>
-              <a:spcAft>
-                <a:spcPts val="700"/>
-              </a:spcAft>
-            </a:pPr>
-            <a:r>
-              <a:rPr sz="1900">
-                <a:solidFill>
-                  <a:srgbClr val="333333"/>
-                </a:solidFill>
-                <a:latin typeface="Calibri"/>
-              </a:rPr>
-              <a:t>•  Bu çalışmanın özgünlüğü:</a:t>
-            </a:r>
-          </a:p>
-          <a:p>
-            <a:pPr lvl="1">
-              <a:spcAft>
-                <a:spcPts val="700"/>
-              </a:spcAft>
-            </a:pPr>
-            <a:r>
-              <a:rPr sz="1700">
-                <a:solidFill>
-                  <a:srgbClr val="333333"/>
-                </a:solidFill>
-                <a:latin typeface="Calibri"/>
-              </a:rPr>
-              <a:t>–  Kesirli şekillendiriciyi FARKLI sensör sınıflarına (titreşim + foton) uygulamak</a:t>
-            </a:r>
-          </a:p>
-          <a:p>
-            <a:pPr lvl="1">
-              <a:spcAft>
-                <a:spcPts val="700"/>
-              </a:spcAft>
-            </a:pPr>
-            <a:r>
-              <a:rPr sz="1700">
-                <a:solidFill>
-                  <a:srgbClr val="333333"/>
-                </a:solidFill>
-                <a:latin typeface="Calibri"/>
-              </a:rPr>
-              <a:t>–  Ölçülebilir ölçütlerle (SNR, ENC, gecikme, pile-up, eleman sayısı) KARŞILAŞTIRMA</a:t>
-            </a:r>
-          </a:p>
-          <a:p>
-            <a:pPr lvl="1">
-              <a:spcAft>
-                <a:spcPts val="700"/>
-              </a:spcAft>
-            </a:pPr>
-            <a:r>
-              <a:rPr sz="1700">
-                <a:solidFill>
-                  <a:srgbClr val="333333"/>
-                </a:solidFill>
-                <a:latin typeface="Calibri"/>
-              </a:rPr>
-              <a:t>–  "Kesirli derece + PMT/foton sayma şekillendirme" kesişimi büyük ölçüde BOŞ</a:t>
-            </a:r>
-          </a:p>
-          <a:p>
-            <a:pPr lvl="1">
-              <a:spcAft>
-                <a:spcPts val="700"/>
-              </a:spcAft>
-            </a:pPr>
-            <a:r>
-              <a:rPr sz="1700">
-                <a:solidFill>
-                  <a:srgbClr val="333333"/>
-                </a:solidFill>
-                <a:latin typeface="Calibri"/>
-              </a:rPr>
-              <a:t>–  Ferri’nin akım/gerilim-modlu arayüzleriyle birleştirme — özgün köprü</a:t>
-            </a:r>
-          </a:p>
-          <a:p>
-            <a:pPr>
-              <a:spcAft>
-                <a:spcPts val="700"/>
-              </a:spcAft>
-            </a:pPr>
-            <a:r>
-              <a:rPr sz="1900">
-                <a:solidFill>
-                  <a:srgbClr val="333333"/>
-                </a:solidFill>
-                <a:latin typeface="Calibri"/>
-              </a:rPr>
-              <a:t>•  Ticari referansa (H7711-03) karşı adil kıyas → yayınlanabilir katkı.</a:t>
+            <a:pPr algn="l">
+              <a:spcAft>
+                <a:spcPts val="500"/>
+              </a:spcAft>
+            </a:pPr>
+            <a:r>
+              <a:rPr sz="1800" b="1">
+                <a:solidFill>
+                  <a:srgbClr val="1A1A6A"/>
+                </a:solidFill>
+                <a:latin typeface="Calibri"/>
+              </a:rPr>
+              <a:t>CTC LP252 — Titreşim (4-20 mA, akım)</a:t>
+            </a:r>
+          </a:p>
+        </p:txBody>
+      </p:sp>
+      <p:sp>
+        <p:nvSpPr>
+          <p:cNvPr id="9" name="TextBox 8"/>
+          <p:cNvSpPr txBox="1"/>
+          <p:nvPr/>
+        </p:nvSpPr>
+        <p:spPr>
+          <a:xfrm>
+            <a:off x="2377440" y="1901952"/>
+            <a:ext cx="9052560" cy="411480"/>
+          </a:xfrm>
+          <a:prstGeom prst="rect">
+            <a:avLst/>
+          </a:prstGeom>
+          <a:noFill/>
+        </p:spPr>
+        <p:txBody>
+          <a:bodyPr wrap="square" anchor="t">
+            <a:spAutoFit/>
+          </a:bodyPr>
+          <a:lstStyle/>
+          <a:p>
+            <a:pPr algn="l">
+              <a:spcAft>
+                <a:spcPts val="500"/>
+              </a:spcAft>
+            </a:pPr>
+            <a:r>
+              <a:rPr sz="1500" b="0">
+                <a:solidFill>
+                  <a:srgbClr val="333333"/>
+                </a:solidFill>
+                <a:latin typeface="Calibri"/>
+              </a:rPr>
+              <a:t>Deney: 4-20 mA RMS bandının dışına ek "zarf-analizi" (kHz) filtre kolu tasarla.</a:t>
+            </a:r>
+          </a:p>
+        </p:txBody>
+      </p:sp>
+      <p:sp>
+        <p:nvSpPr>
+          <p:cNvPr id="10" name="TextBox 9"/>
+          <p:cNvSpPr txBox="1"/>
+          <p:nvPr/>
+        </p:nvSpPr>
+        <p:spPr>
+          <a:xfrm>
+            <a:off x="2377440" y="2322576"/>
+            <a:ext cx="9052560" cy="411480"/>
+          </a:xfrm>
+          <a:prstGeom prst="rect">
+            <a:avLst/>
+          </a:prstGeom>
+          <a:noFill/>
+        </p:spPr>
+        <p:txBody>
+          <a:bodyPr wrap="square" anchor="t">
+            <a:spAutoFit/>
+          </a:bodyPr>
+          <a:lstStyle/>
+          <a:p>
+            <a:pPr algn="l">
+              <a:spcAft>
+                <a:spcPts val="500"/>
+              </a:spcAft>
+            </a:pPr>
+            <a:r>
+              <a:rPr sz="1500" b="0">
+                <a:solidFill>
+                  <a:srgbClr val="1B6B3A"/>
+                </a:solidFill>
+                <a:latin typeface="Calibri"/>
+              </a:rPr>
+              <a:t>Ölçüt: rulman/dişli arıza izinde SNR (işaret/gürültü) kazancı.</a:t>
+            </a:r>
+          </a:p>
+        </p:txBody>
+      </p:sp>
+      <p:sp>
+        <p:nvSpPr>
+          <p:cNvPr id="11" name="Rounded Rectangle 10"/>
+          <p:cNvSpPr/>
+          <p:nvPr/>
+        </p:nvSpPr>
+        <p:spPr>
+          <a:xfrm>
+            <a:off x="457200" y="2999232"/>
+            <a:ext cx="11274552" cy="1572768"/>
+          </a:xfrm>
+          <a:prstGeom prst="roundRect">
+            <a:avLst/>
+          </a:prstGeom>
+          <a:solidFill>
+            <a:srgbClr val="EEF4FF"/>
+          </a:solidFill>
+          <a:ln w="12700">
+            <a:solidFill>
+              <a:srgbClr val="C3D2EC"/>
+            </a:solidFill>
+          </a:ln>
+          <a:effectLst/>
+        </p:spPr>
+        <p:style>
+          <a:lnRef idx="1">
+            <a:schemeClr val="accent1"/>
+          </a:lnRef>
+          <a:fillRef idx="3">
+            <a:schemeClr val="accent1"/>
+          </a:fillRef>
+          <a:effectRef idx="2">
+            <a:schemeClr val="accent1"/>
+          </a:effectRef>
+          <a:fontRef idx="minor">
+            <a:schemeClr val="lt1"/>
+          </a:fontRef>
+        </p:style>
+        <p:txBody>
+          <a:bodyPr rtlCol="0" anchor="ctr"/>
+          <a:lstStyle/>
+          <a:p>
+            <a:pPr algn="ctr"/>
+          </a:p>
+        </p:txBody>
+      </p:sp>
+      <p:pic>
+        <p:nvPicPr>
+          <p:cNvPr id="12" name="Picture 11" descr="sx_pmt.png"/>
+          <p:cNvPicPr>
+            <a:picLocks noChangeAspect="1"/>
+          </p:cNvPicPr>
+          <p:nvPr/>
+        </p:nvPicPr>
+        <p:blipFill>
+          <a:blip r:embed="rId3"/>
+          <a:stretch>
+            <a:fillRect/>
+          </a:stretch>
+        </p:blipFill>
+        <p:spPr>
+          <a:xfrm>
+            <a:off x="822960" y="3122676"/>
+            <a:ext cx="1325880" cy="1325880"/>
+          </a:xfrm>
+          <a:prstGeom prst="rect">
+            <a:avLst/>
+          </a:prstGeom>
+        </p:spPr>
+      </p:pic>
+      <p:sp>
+        <p:nvSpPr>
+          <p:cNvPr id="13" name="TextBox 12"/>
+          <p:cNvSpPr txBox="1"/>
+          <p:nvPr/>
+        </p:nvSpPr>
+        <p:spPr>
+          <a:xfrm>
+            <a:off x="2377440" y="3118104"/>
+            <a:ext cx="9052560" cy="457200"/>
+          </a:xfrm>
+          <a:prstGeom prst="rect">
+            <a:avLst/>
+          </a:prstGeom>
+          <a:noFill/>
+        </p:spPr>
+        <p:txBody>
+          <a:bodyPr wrap="square" anchor="t">
+            <a:spAutoFit/>
+          </a:bodyPr>
+          <a:lstStyle/>
+          <a:p>
+            <a:pPr algn="l">
+              <a:spcAft>
+                <a:spcPts val="500"/>
+              </a:spcAft>
+            </a:pPr>
+            <a:r>
+              <a:rPr sz="1800" b="1">
+                <a:solidFill>
+                  <a:srgbClr val="1A1A6A"/>
+                </a:solidFill>
+                <a:latin typeface="Calibri"/>
+              </a:rPr>
+              <a:t>Hamamatsu R6094/R6095 — PMT (akım darbesi)</a:t>
+            </a:r>
+          </a:p>
+        </p:txBody>
+      </p:sp>
+      <p:sp>
+        <p:nvSpPr>
+          <p:cNvPr id="14" name="TextBox 13"/>
+          <p:cNvSpPr txBox="1"/>
+          <p:nvPr/>
+        </p:nvSpPr>
+        <p:spPr>
+          <a:xfrm>
+            <a:off x="2377440" y="3602736"/>
+            <a:ext cx="9052560" cy="411480"/>
+          </a:xfrm>
+          <a:prstGeom prst="rect">
+            <a:avLst/>
+          </a:prstGeom>
+          <a:noFill/>
+        </p:spPr>
+        <p:txBody>
+          <a:bodyPr wrap="square" anchor="t">
+            <a:spAutoFit/>
+          </a:bodyPr>
+          <a:lstStyle/>
+          <a:p>
+            <a:pPr algn="l">
+              <a:spcAft>
+                <a:spcPts val="500"/>
+              </a:spcAft>
+            </a:pPr>
+            <a:r>
+              <a:rPr sz="1500" b="0">
+                <a:solidFill>
+                  <a:srgbClr val="333333"/>
+                </a:solidFill>
+                <a:latin typeface="Calibri"/>
+              </a:rPr>
+              <a:t>Deney: klasik (Bessel/CR-RC) ile kesirli (1+α) şekillendiriciyi kur ve kıyasla.</a:t>
+            </a:r>
+          </a:p>
+        </p:txBody>
+      </p:sp>
+      <p:sp>
+        <p:nvSpPr>
+          <p:cNvPr id="15" name="TextBox 14"/>
+          <p:cNvSpPr txBox="1"/>
+          <p:nvPr/>
+        </p:nvSpPr>
+        <p:spPr>
+          <a:xfrm>
+            <a:off x="2377440" y="4023360"/>
+            <a:ext cx="9052560" cy="411480"/>
+          </a:xfrm>
+          <a:prstGeom prst="rect">
+            <a:avLst/>
+          </a:prstGeom>
+          <a:noFill/>
+        </p:spPr>
+        <p:txBody>
+          <a:bodyPr wrap="square" anchor="t">
+            <a:spAutoFit/>
+          </a:bodyPr>
+          <a:lstStyle/>
+          <a:p>
+            <a:pPr algn="l">
+              <a:spcAft>
+                <a:spcPts val="500"/>
+              </a:spcAft>
+            </a:pPr>
+            <a:r>
+              <a:rPr sz="1500" b="0">
+                <a:solidFill>
+                  <a:srgbClr val="1B6B3A"/>
+                </a:solidFill>
+                <a:latin typeface="Calibri"/>
+              </a:rPr>
+              <a:t>Ölçüt: gürültü-bant genişliği, grup gecikmesi, darbe yığılması (pile-up).</a:t>
+            </a:r>
+          </a:p>
+        </p:txBody>
+      </p:sp>
+      <p:sp>
+        <p:nvSpPr>
+          <p:cNvPr id="16" name="Rounded Rectangle 15"/>
+          <p:cNvSpPr/>
+          <p:nvPr/>
+        </p:nvSpPr>
+        <p:spPr>
+          <a:xfrm>
+            <a:off x="457200" y="4700016"/>
+            <a:ext cx="11274552" cy="1572768"/>
+          </a:xfrm>
+          <a:prstGeom prst="roundRect">
+            <a:avLst/>
+          </a:prstGeom>
+          <a:solidFill>
+            <a:srgbClr val="EEF4FF"/>
+          </a:solidFill>
+          <a:ln w="12700">
+            <a:solidFill>
+              <a:srgbClr val="C3D2EC"/>
+            </a:solidFill>
+          </a:ln>
+          <a:effectLst/>
+        </p:spPr>
+        <p:style>
+          <a:lnRef idx="1">
+            <a:schemeClr val="accent1"/>
+          </a:lnRef>
+          <a:fillRef idx="3">
+            <a:schemeClr val="accent1"/>
+          </a:fillRef>
+          <a:effectRef idx="2">
+            <a:schemeClr val="accent1"/>
+          </a:effectRef>
+          <a:fontRef idx="minor">
+            <a:schemeClr val="lt1"/>
+          </a:fontRef>
+        </p:style>
+        <p:txBody>
+          <a:bodyPr rtlCol="0" anchor="ctr"/>
+          <a:lstStyle/>
+          <a:p>
+            <a:pPr algn="ctr"/>
+          </a:p>
+        </p:txBody>
+      </p:sp>
+      <p:pic>
+        <p:nvPicPr>
+          <p:cNvPr id="17" name="Picture 16" descr="sx_h7711.png"/>
+          <p:cNvPicPr>
+            <a:picLocks noChangeAspect="1"/>
+          </p:cNvPicPr>
+          <p:nvPr/>
+        </p:nvPicPr>
+        <p:blipFill>
+          <a:blip r:embed="rId4"/>
+          <a:stretch>
+            <a:fillRect/>
+          </a:stretch>
+        </p:blipFill>
+        <p:spPr>
+          <a:xfrm>
+            <a:off x="822960" y="4823460"/>
+            <a:ext cx="1325880" cy="1325880"/>
+          </a:xfrm>
+          <a:prstGeom prst="rect">
+            <a:avLst/>
+          </a:prstGeom>
+        </p:spPr>
+      </p:pic>
+      <p:sp>
+        <p:nvSpPr>
+          <p:cNvPr id="18" name="TextBox 17"/>
+          <p:cNvSpPr txBox="1"/>
+          <p:nvPr/>
+        </p:nvSpPr>
+        <p:spPr>
+          <a:xfrm>
+            <a:off x="2377440" y="4818888"/>
+            <a:ext cx="9052560" cy="457200"/>
+          </a:xfrm>
+          <a:prstGeom prst="rect">
+            <a:avLst/>
+          </a:prstGeom>
+          <a:noFill/>
+        </p:spPr>
+        <p:txBody>
+          <a:bodyPr wrap="square" anchor="t">
+            <a:spAutoFit/>
+          </a:bodyPr>
+          <a:lstStyle/>
+          <a:p>
+            <a:pPr algn="l">
+              <a:spcAft>
+                <a:spcPts val="500"/>
+              </a:spcAft>
+            </a:pPr>
+            <a:r>
+              <a:rPr sz="1800" b="1">
+                <a:solidFill>
+                  <a:srgbClr val="1A1A6A"/>
+                </a:solidFill>
+                <a:latin typeface="Calibri"/>
+              </a:rPr>
+              <a:t>Hamamatsu H7711-03 — Foton sayma (TTL, frekans)</a:t>
+            </a:r>
+          </a:p>
+        </p:txBody>
+      </p:sp>
+      <p:sp>
+        <p:nvSpPr>
+          <p:cNvPr id="19" name="TextBox 18"/>
+          <p:cNvSpPr txBox="1"/>
+          <p:nvPr/>
+        </p:nvSpPr>
+        <p:spPr>
+          <a:xfrm>
+            <a:off x="2377440" y="5303520"/>
+            <a:ext cx="9052560" cy="411480"/>
+          </a:xfrm>
+          <a:prstGeom prst="rect">
+            <a:avLst/>
+          </a:prstGeom>
+          <a:noFill/>
+        </p:spPr>
+        <p:txBody>
+          <a:bodyPr wrap="square" anchor="t">
+            <a:spAutoFit/>
+          </a:bodyPr>
+          <a:lstStyle/>
+          <a:p>
+            <a:pPr algn="l">
+              <a:spcAft>
+                <a:spcPts val="500"/>
+              </a:spcAft>
+            </a:pPr>
+            <a:r>
+              <a:rPr sz="1500" b="0">
+                <a:solidFill>
+                  <a:srgbClr val="333333"/>
+                </a:solidFill>
+                <a:latin typeface="Calibri"/>
+              </a:rPr>
+              <a:t>Deney: bu hazır modülü "referans" alıp kendi şekillendiricinin sonucunu kıyasla.</a:t>
+            </a:r>
+          </a:p>
+        </p:txBody>
+      </p:sp>
+      <p:sp>
+        <p:nvSpPr>
+          <p:cNvPr id="20" name="TextBox 19"/>
+          <p:cNvSpPr txBox="1"/>
+          <p:nvPr/>
+        </p:nvSpPr>
+        <p:spPr>
+          <a:xfrm>
+            <a:off x="2377440" y="5724144"/>
+            <a:ext cx="9052560" cy="411480"/>
+          </a:xfrm>
+          <a:prstGeom prst="rect">
+            <a:avLst/>
+          </a:prstGeom>
+          <a:noFill/>
+        </p:spPr>
+        <p:txBody>
+          <a:bodyPr wrap="square" anchor="t">
+            <a:spAutoFit/>
+          </a:bodyPr>
+          <a:lstStyle/>
+          <a:p>
+            <a:pPr algn="l">
+              <a:spcAft>
+                <a:spcPts val="500"/>
+              </a:spcAft>
+            </a:pPr>
+            <a:r>
+              <a:rPr sz="1500" b="0">
+                <a:solidFill>
+                  <a:srgbClr val="1B6B3A"/>
+                </a:solidFill>
+                <a:latin typeface="Calibri"/>
+              </a:rPr>
+              <a:t>Ölçüt: foton sayım doğruluğu, ENC ve ölü zaman.</a:t>
+            </a:r>
+          </a:p>
+        </p:txBody>
+      </p:sp>
+      <p:sp>
+        <p:nvSpPr>
+          <p:cNvPr id="21" name="TextBox 20"/>
+          <p:cNvSpPr txBox="1"/>
+          <p:nvPr/>
+        </p:nvSpPr>
+        <p:spPr>
+          <a:xfrm>
+            <a:off x="548640" y="6364224"/>
+            <a:ext cx="11064240" cy="411480"/>
+          </a:xfrm>
+          <a:prstGeom prst="rect">
+            <a:avLst/>
+          </a:prstGeom>
+          <a:noFill/>
+        </p:spPr>
+        <p:txBody>
+          <a:bodyPr wrap="square" anchor="t">
+            <a:spAutoFit/>
+          </a:bodyPr>
+          <a:lstStyle/>
+          <a:p>
+            <a:pPr algn="ctr">
+              <a:spcAft>
+                <a:spcPts val="500"/>
+              </a:spcAft>
+            </a:pPr>
+            <a:r>
+              <a:rPr sz="1400" b="1">
+                <a:solidFill>
+                  <a:srgbClr val="1A1A6A"/>
+                </a:solidFill>
+                <a:latin typeface="Calibri"/>
+              </a:rPr>
+              <a:t>Ortak yaklaşım: CCII/VCII akım-modlu ön-uç + en az bir sensörde frekans/periyot (kalibrasyonsuz) okuma.</a:t>
             </a:r>
           </a:p>
         </p:txBody>
@@ -10577,7 +11043,7 @@
                 </a:solidFill>
                 <a:latin typeface="Calibri"/>
               </a:rPr>
-              <a:t>12. Plan — İş Paketleri ve Takvim</a:t>
+              <a:t>11. Çalışmanın Özgünlüğü</a:t>
             </a:r>
           </a:p>
         </p:txBody>
@@ -10655,7 +11121,7 @@
                 </a:solidFill>
                 <a:latin typeface="Calibri"/>
               </a:rPr>
-              <a:t>•  İP1 Kuram &amp; literatür  (Ay 1–3)</a:t>
+              <a:t>•  Kesirli filtreler literatürde çoğunlukla biyomedikal/teorik bağlamda çalışılmış.</a:t>
             </a:r>
           </a:p>
           <a:p>
@@ -10671,7 +11137,71 @@
                 </a:solidFill>
                 <a:latin typeface="Calibri"/>
               </a:rPr>
-              <a:t>•  İP2 Sensör karakterizasyonu: LP252 / R6094-R6095 / H7711-03  (Ay 3–5)</a:t>
+              <a:t>•  Bu çalışmanın özgünlüğü:</a:t>
+            </a:r>
+          </a:p>
+          <a:p>
+            <a:pPr lvl="1">
+              <a:spcAft>
+                <a:spcPts val="700"/>
+              </a:spcAft>
+            </a:pPr>
+            <a:r>
+              <a:rPr sz="1700">
+                <a:solidFill>
+                  <a:srgbClr val="333333"/>
+                </a:solidFill>
+                <a:latin typeface="Calibri"/>
+              </a:rPr>
+              <a:t>–  Kesirli şekillendiriciyi FARKLI sensör sınıflarına (titreşim + foton) uygulamak</a:t>
+            </a:r>
+          </a:p>
+          <a:p>
+            <a:pPr lvl="1">
+              <a:spcAft>
+                <a:spcPts val="700"/>
+              </a:spcAft>
+            </a:pPr>
+            <a:r>
+              <a:rPr sz="1700">
+                <a:solidFill>
+                  <a:srgbClr val="333333"/>
+                </a:solidFill>
+                <a:latin typeface="Calibri"/>
+              </a:rPr>
+              <a:t>–  Ölçülebilir ölçütlerle (SNR, ENC, gecikme, pile-up, eleman sayısı) KARŞILAŞTIRMA</a:t>
+            </a:r>
+          </a:p>
+          <a:p>
+            <a:pPr lvl="1">
+              <a:spcAft>
+                <a:spcPts val="700"/>
+              </a:spcAft>
+            </a:pPr>
+            <a:r>
+              <a:rPr sz="1700">
+                <a:solidFill>
+                  <a:srgbClr val="333333"/>
+                </a:solidFill>
+                <a:latin typeface="Calibri"/>
+              </a:rPr>
+              <a:t>–  "Kesirli derece + PMT/foton sayma şekillendirme" kesişimi büyük ölçüde BOŞ</a:t>
+            </a:r>
+          </a:p>
+          <a:p>
+            <a:pPr lvl="1">
+              <a:spcAft>
+                <a:spcPts val="700"/>
+              </a:spcAft>
+            </a:pPr>
+            <a:r>
+              <a:rPr sz="1700">
+                <a:solidFill>
+                  <a:srgbClr val="333333"/>
+                </a:solidFill>
+                <a:latin typeface="Calibri"/>
+              </a:rPr>
+              <a:t>–  Ferri’nin akım/gerilim-modlu arayüzleriyle birleştirme — özgün köprü</a:t>
             </a:r>
           </a:p>
           <a:p>
@@ -10687,71 +11217,7 @@
                 </a:solidFill>
                 <a:latin typeface="Calibri"/>
               </a:rPr>
-              <a:t>•  İP3 Tasarım: klasik referans + kesirli (1+α) şekillendirici (CCII/OTA/FPAA)  (Ay 4–8)</a:t>
-            </a:r>
-          </a:p>
-          <a:p>
-            <a:pPr>
-              <a:spcAft>
-                <a:spcPts val="700"/>
-              </a:spcAft>
-            </a:pPr>
-            <a:r>
-              <a:rPr sz="1900">
-                <a:solidFill>
-                  <a:srgbClr val="333333"/>
-                </a:solidFill>
-                <a:latin typeface="Calibri"/>
-              </a:rPr>
-              <a:t>•  İP4 Simülasyon: MATLAB (FOMCON)/Python + LTspice  (Ay 6–9)</a:t>
-            </a:r>
-          </a:p>
-          <a:p>
-            <a:pPr>
-              <a:spcAft>
-                <a:spcPts val="700"/>
-              </a:spcAft>
-            </a:pPr>
-            <a:r>
-              <a:rPr sz="1900">
-                <a:solidFill>
-                  <a:srgbClr val="333333"/>
-                </a:solidFill>
-                <a:latin typeface="Calibri"/>
-              </a:rPr>
-              <a:t>•  İP5 Donanım &amp; doğrulama: gerçek sensörle SNR/ENC kıyası  (Ay 9–12)</a:t>
-            </a:r>
-          </a:p>
-          <a:p>
-            <a:pPr>
-              <a:spcAft>
-                <a:spcPts val="700"/>
-              </a:spcAft>
-            </a:pPr>
-            <a:r>
-              <a:rPr sz="1900">
-                <a:solidFill>
-                  <a:srgbClr val="333333"/>
-                </a:solidFill>
-                <a:latin typeface="Calibri"/>
-              </a:rPr>
-              <a:t>•  İP6 Değerlendirme &amp; yazım: karşılaştırma matrisi, tez + makale  (Ay 11–14)</a:t>
-            </a:r>
-          </a:p>
-          <a:p>
-            <a:pPr>
-              <a:spcAft>
-                <a:spcPts val="700"/>
-              </a:spcAft>
-            </a:pPr>
-            <a:r>
-              <a:rPr sz="1900">
-                <a:solidFill>
-                  <a:srgbClr val="333333"/>
-                </a:solidFill>
-                <a:latin typeface="Calibri"/>
-              </a:rPr>
-              <a:t>•  TÜBİTAK: 1001 (bilim), 1501/1507 (sanayi), 1512 BiGG (girişim).</a:t>
+              <a:t>•  Ticari referansa (H7711-03) karşı adil kıyas → yayınlanabilir katkı.</a:t>
             </a:r>
           </a:p>
         </p:txBody>
@@ -10896,7 +11362,7 @@
                 </a:solidFill>
                 <a:latin typeface="Calibri"/>
               </a:rPr>
-              <a:t>13. Sonuç</a:t>
+              <a:t>12. Plan — İş Paketleri ve Takvim</a:t>
             </a:r>
           </a:p>
         </p:txBody>
@@ -10948,7 +11414,7 @@
         </p:nvSpPr>
         <p:spPr>
           <a:xfrm>
-            <a:off x="640080" y="1463040"/>
+            <a:off x="640080" y="1371600"/>
             <a:ext cx="10972800" cy="4846320"/>
           </a:xfrm>
           <a:prstGeom prst="rect">
@@ -10968,13 +11434,13 @@
               </a:spcAft>
             </a:pPr>
             <a:r>
-              <a:rPr sz="2000">
-                <a:solidFill>
-                  <a:srgbClr val="333333"/>
-                </a:solidFill>
-                <a:latin typeface="Calibri"/>
-              </a:rPr>
-              <a:t>•  Filtre temel kavramları, türleri, yaklaşımları ve formülasyonları açıklandı.</a:t>
+              <a:rPr sz="1900">
+                <a:solidFill>
+                  <a:srgbClr val="333333"/>
+                </a:solidFill>
+                <a:latin typeface="Calibri"/>
+              </a:rPr>
+              <a:t>•  İP1 Kuram &amp; literatür  (Ay 1–3)</a:t>
             </a:r>
           </a:p>
           <a:p>
@@ -10984,13 +11450,13 @@
               </a:spcAft>
             </a:pPr>
             <a:r>
-              <a:rPr sz="2000">
-                <a:solidFill>
-                  <a:srgbClr val="333333"/>
-                </a:solidFill>
-                <a:latin typeface="Calibri"/>
-              </a:rPr>
-              <a:t>•  1./2./3. ve kesirli dereceden yapılar, topolojiler, duyarlılık ve SNR ele alındı.</a:t>
+              <a:rPr sz="1900">
+                <a:solidFill>
+                  <a:srgbClr val="333333"/>
+                </a:solidFill>
+                <a:latin typeface="Calibri"/>
+              </a:rPr>
+              <a:t>•  İP2 Sensör karakterizasyonu: LP252 / R6094-R6095 / H7711-03  (Ay 3–5)</a:t>
             </a:r>
           </a:p>
           <a:p>
@@ -11000,13 +11466,13 @@
               </a:spcAft>
             </a:pPr>
             <a:r>
-              <a:rPr sz="2000">
-                <a:solidFill>
-                  <a:srgbClr val="333333"/>
-                </a:solidFill>
-                <a:latin typeface="Calibri"/>
-              </a:rPr>
-              <a:t>•  Filtre + sensör alanında güçlü isimler (Ferri, Psychalinos, Elwakil…) tanıtıldı.</a:t>
+              <a:rPr sz="1900">
+                <a:solidFill>
+                  <a:srgbClr val="333333"/>
+                </a:solidFill>
+                <a:latin typeface="Calibri"/>
+              </a:rPr>
+              <a:t>•  İP3 Tasarım: klasik referans + kesirli (1+α) şekillendirici (CCII/OTA/FPAA)  (Ay 4–8)</a:t>
             </a:r>
           </a:p>
           <a:p>
@@ -11016,13 +11482,13 @@
               </a:spcAft>
             </a:pPr>
             <a:r>
-              <a:rPr sz="2000">
-                <a:solidFill>
-                  <a:srgbClr val="333333"/>
-                </a:solidFill>
-                <a:latin typeface="Calibri"/>
-              </a:rPr>
-              <a:t>•  Üç sensör ve deneysel olanaklar, özgünlük ve plan ortaya kondu.</a:t>
+              <a:rPr sz="1900">
+                <a:solidFill>
+                  <a:srgbClr val="333333"/>
+                </a:solidFill>
+                <a:latin typeface="Calibri"/>
+              </a:rPr>
+              <a:t>•  İP4 Simülasyon: MATLAB (FOMCON)/Python + LTspice  (Ay 6–9)</a:t>
             </a:r>
           </a:p>
           <a:p>
@@ -11032,13 +11498,45 @@
               </a:spcAft>
             </a:pPr>
             <a:r>
-              <a:rPr sz="2000">
-                <a:solidFill>
-                  <a:srgbClr val="333333"/>
-                </a:solidFill>
-                <a:latin typeface="Calibri"/>
-              </a:rPr>
-              <a:t>•  Sonraki adım: İP1–İP2 (literatür matrisi + sensör karakterizasyonu).</a:t>
+              <a:rPr sz="1900">
+                <a:solidFill>
+                  <a:srgbClr val="333333"/>
+                </a:solidFill>
+                <a:latin typeface="Calibri"/>
+              </a:rPr>
+              <a:t>•  İP5 Donanım &amp; doğrulama: gerçek sensörle SNR/ENC kıyası  (Ay 9–12)</a:t>
+            </a:r>
+          </a:p>
+          <a:p>
+            <a:pPr>
+              <a:spcAft>
+                <a:spcPts val="700"/>
+              </a:spcAft>
+            </a:pPr>
+            <a:r>
+              <a:rPr sz="1900">
+                <a:solidFill>
+                  <a:srgbClr val="333333"/>
+                </a:solidFill>
+                <a:latin typeface="Calibri"/>
+              </a:rPr>
+              <a:t>•  İP6 Değerlendirme &amp; yazım: karşılaştırma matrisi, tez + makale  (Ay 11–14)</a:t>
+            </a:r>
+          </a:p>
+          <a:p>
+            <a:pPr>
+              <a:spcAft>
+                <a:spcPts val="700"/>
+              </a:spcAft>
+            </a:pPr>
+            <a:r>
+              <a:rPr sz="1900">
+                <a:solidFill>
+                  <a:srgbClr val="333333"/>
+                </a:solidFill>
+                <a:latin typeface="Calibri"/>
+              </a:rPr>
+              <a:t>•  TÜBİTAK: 1001 (bilim), 1501/1507 (sanayi), 1512 BiGG (girişim).</a:t>
             </a:r>
           </a:p>
         </p:txBody>
@@ -11183,7 +11681,7 @@
                 </a:solidFill>
                 <a:latin typeface="Calibri"/>
               </a:rPr>
-              <a:t>Kaynaklar (1/2) — IEEE</a:t>
+              <a:t>13. Sonuç</a:t>
             </a:r>
           </a:p>
         </p:txBody>
@@ -11235,7 +11733,7 @@
         </p:nvSpPr>
         <p:spPr>
           <a:xfrm>
-            <a:off x="640080" y="1280160"/>
+            <a:off x="640080" y="1463040"/>
             <a:ext cx="10972800" cy="4846320"/>
           </a:xfrm>
           <a:prstGeom prst="rect">
@@ -11255,13 +11753,13 @@
               </a:spcAft>
             </a:pPr>
             <a:r>
-              <a:rPr sz="1350">
-                <a:solidFill>
-                  <a:srgbClr val="333333"/>
-                </a:solidFill>
-                <a:latin typeface="Calibri"/>
-              </a:rPr>
-              <a:t>•  [1] S. Butterworth, "On the theory of filter amplifiers," Exp. Wireless Wireless Eng., vol. 7, pp. 536–541, 1930.</a:t>
+              <a:rPr sz="2000">
+                <a:solidFill>
+                  <a:srgbClr val="333333"/>
+                </a:solidFill>
+                <a:latin typeface="Calibri"/>
+              </a:rPr>
+              <a:t>•  Filtre temel kavramları, türleri, yaklaşımları ve formülasyonları açıklandı.</a:t>
             </a:r>
           </a:p>
           <a:p>
@@ -11271,13 +11769,13 @@
               </a:spcAft>
             </a:pPr>
             <a:r>
-              <a:rPr sz="1350">
-                <a:solidFill>
-                  <a:srgbClr val="333333"/>
-                </a:solidFill>
-                <a:latin typeface="Calibri"/>
-              </a:rPr>
-              <a:t>•  [2] W. E. Thomson, "Delay networks having maximally flat frequency characteristics," Proc. IEE - Part III, vol. 96, no. 44, pp. 487–490, 1949.</a:t>
+              <a:rPr sz="2000">
+                <a:solidFill>
+                  <a:srgbClr val="333333"/>
+                </a:solidFill>
+                <a:latin typeface="Calibri"/>
+              </a:rPr>
+              <a:t>•  1./2./3. ve kesirli dereceden yapılar, topolojiler, duyarlılık ve SNR ele alındı.</a:t>
             </a:r>
           </a:p>
           <a:p>
@@ -11287,13 +11785,13 @@
               </a:spcAft>
             </a:pPr>
             <a:r>
-              <a:rPr sz="1350">
-                <a:solidFill>
-                  <a:srgbClr val="333333"/>
-                </a:solidFill>
-                <a:latin typeface="Calibri"/>
-              </a:rPr>
-              <a:t>•  [3] R. P. Sallen and E. L. Key, "A practical method of designing RC active filters," IRE Trans. Circuit Theory, vol. 2, no. 1, pp. 74–85, Mar. 1955.</a:t>
+              <a:rPr sz="2000">
+                <a:solidFill>
+                  <a:srgbClr val="333333"/>
+                </a:solidFill>
+                <a:latin typeface="Calibri"/>
+              </a:rPr>
+              <a:t>•  Filtre + sensör alanında güçlü isimler (Ferri, Psychalinos, Elwakil…) tanıtıldı.</a:t>
             </a:r>
           </a:p>
           <a:p>
@@ -11303,13 +11801,13 @@
               </a:spcAft>
             </a:pPr>
             <a:r>
-              <a:rPr sz="1350">
-                <a:solidFill>
-                  <a:srgbClr val="333333"/>
-                </a:solidFill>
-                <a:latin typeface="Calibri"/>
-              </a:rPr>
-              <a:t>•  [4] W. J. Kerwin, L. P. Huelsman, and R. W. Newcomb, "State-variable synthesis for insensitive integrated circuit transfer functions," IEEE J. Solid-State Circuits, vol. 2, no. 3, pp. 87–92, 1967.</a:t>
+              <a:rPr sz="2000">
+                <a:solidFill>
+                  <a:srgbClr val="333333"/>
+                </a:solidFill>
+                <a:latin typeface="Calibri"/>
+              </a:rPr>
+              <a:t>•  Üç sensör ve deneysel olanaklar, özgünlük ve plan ortaya kondu.</a:t>
             </a:r>
           </a:p>
           <a:p>
@@ -11319,93 +11817,13 @@
               </a:spcAft>
             </a:pPr>
             <a:r>
-              <a:rPr sz="1350">
-                <a:solidFill>
-                  <a:srgbClr val="333333"/>
-                </a:solidFill>
-                <a:latin typeface="Calibri"/>
-              </a:rPr>
-              <a:t>•  [5] A. B. Williams and F. J. Taylor, Electronic Filter Design Handbook, 4th ed. New York: McGraw-Hill, 2006.</a:t>
-            </a:r>
-          </a:p>
-          <a:p>
-            <a:pPr>
-              <a:spcAft>
-                <a:spcPts val="700"/>
-              </a:spcAft>
-            </a:pPr>
-            <a:r>
-              <a:rPr sz="1350">
-                <a:solidFill>
-                  <a:srgbClr val="333333"/>
-                </a:solidFill>
-                <a:latin typeface="Calibri"/>
-              </a:rPr>
-              <a:t>•  [6] R. Schaumann, H. Xiao, and M. E. Van Valkenburg, Design of Analog Filters, 2nd ed. New York: Oxford Univ. Press, 2010.</a:t>
-            </a:r>
-          </a:p>
-          <a:p>
-            <a:pPr>
-              <a:spcAft>
-                <a:spcPts val="700"/>
-              </a:spcAft>
-            </a:pPr>
-            <a:r>
-              <a:rPr sz="1350">
-                <a:solidFill>
-                  <a:srgbClr val="333333"/>
-                </a:solidFill>
-                <a:latin typeface="Calibri"/>
-              </a:rPr>
-              <a:t>•  [7] A. S. Sedra and K. C. Smith, Microelectronic Circuits, 7th ed. New York: Oxford Univ. Press, 2015.</a:t>
-            </a:r>
-          </a:p>
-          <a:p>
-            <a:pPr>
-              <a:spcAft>
-                <a:spcPts val="700"/>
-              </a:spcAft>
-            </a:pPr>
-            <a:r>
-              <a:rPr sz="1350">
-                <a:solidFill>
-                  <a:srgbClr val="333333"/>
-                </a:solidFill>
-                <a:latin typeface="Calibri"/>
-              </a:rPr>
-              <a:t>•  [8] B. Razavi, Design of Analog CMOS Integrated Circuits, 2nd ed. New York: McGraw-Hill, 2017.</a:t>
-            </a:r>
-          </a:p>
-          <a:p>
-            <a:pPr>
-              <a:spcAft>
-                <a:spcPts val="700"/>
-              </a:spcAft>
-            </a:pPr>
-            <a:r>
-              <a:rPr sz="1350">
-                <a:solidFill>
-                  <a:srgbClr val="333333"/>
-                </a:solidFill>
-                <a:latin typeface="Calibri"/>
-              </a:rPr>
-              <a:t>•  [9] I. Podlubny, Fractional Differential Equations. San Diego: Academic Press, 1999.</a:t>
-            </a:r>
-          </a:p>
-          <a:p>
-            <a:pPr>
-              <a:spcAft>
-                <a:spcPts val="700"/>
-              </a:spcAft>
-            </a:pPr>
-            <a:r>
-              <a:rPr sz="1350">
-                <a:solidFill>
-                  <a:srgbClr val="333333"/>
-                </a:solidFill>
-                <a:latin typeface="Calibri"/>
-              </a:rPr>
-              <a:t>•  [10] A. Oustaloup, F. Levron, B. Mathieu, and F. M. Nanot, "Frequency-band complex noninteger differentiator," IEEE Trans. Circuits Syst. I, vol. 47, no. 1, pp. 25–39, 2000.</a:t>
+              <a:rPr sz="2000">
+                <a:solidFill>
+                  <a:srgbClr val="333333"/>
+                </a:solidFill>
+                <a:latin typeface="Calibri"/>
+              </a:rPr>
+              <a:t>•  Sonraki adım: İP1–İP2 (literatür matrisi + sensör karakterizasyonu).</a:t>
             </a:r>
           </a:p>
         </p:txBody>
@@ -11550,7 +11968,7 @@
                 </a:solidFill>
                 <a:latin typeface="Calibri"/>
               </a:rPr>
-              <a:t>Kaynaklar (2/2) — IEEE</a:t>
+              <a:t>Kaynaklar (1/2) — IEEE</a:t>
             </a:r>
           </a:p>
         </p:txBody>
@@ -11590,6 +12008,373 @@
                 <a:latin typeface="Calibri"/>
               </a:rPr>
               <a:t>28</a:t>
+            </a:r>
+          </a:p>
+        </p:txBody>
+      </p:sp>
+      <p:sp>
+        <p:nvSpPr>
+          <p:cNvPr id="6" name="TextBox 5"/>
+          <p:cNvSpPr txBox="1"/>
+          <p:nvPr/>
+        </p:nvSpPr>
+        <p:spPr>
+          <a:xfrm>
+            <a:off x="640080" y="1280160"/>
+            <a:ext cx="10972800" cy="4846320"/>
+          </a:xfrm>
+          <a:prstGeom prst="rect">
+            <a:avLst/>
+          </a:prstGeom>
+          <a:noFill/>
+        </p:spPr>
+        <p:txBody>
+          <a:bodyPr wrap="square">
+            <a:spAutoFit/>
+          </a:bodyPr>
+          <a:lstStyle/>
+          <a:p>
+            <a:pPr>
+              <a:spcAft>
+                <a:spcPts val="700"/>
+              </a:spcAft>
+            </a:pPr>
+            <a:r>
+              <a:rPr sz="1350">
+                <a:solidFill>
+                  <a:srgbClr val="333333"/>
+                </a:solidFill>
+                <a:latin typeface="Calibri"/>
+              </a:rPr>
+              <a:t>•  [1] S. Butterworth, "On the theory of filter amplifiers," Exp. Wireless Wireless Eng., vol. 7, pp. 536–541, 1930.</a:t>
+            </a:r>
+          </a:p>
+          <a:p>
+            <a:pPr>
+              <a:spcAft>
+                <a:spcPts val="700"/>
+              </a:spcAft>
+            </a:pPr>
+            <a:r>
+              <a:rPr sz="1350">
+                <a:solidFill>
+                  <a:srgbClr val="333333"/>
+                </a:solidFill>
+                <a:latin typeface="Calibri"/>
+              </a:rPr>
+              <a:t>•  [2] W. E. Thomson, "Delay networks having maximally flat frequency characteristics," Proc. IEE - Part III, vol. 96, no. 44, pp. 487–490, 1949.</a:t>
+            </a:r>
+          </a:p>
+          <a:p>
+            <a:pPr>
+              <a:spcAft>
+                <a:spcPts val="700"/>
+              </a:spcAft>
+            </a:pPr>
+            <a:r>
+              <a:rPr sz="1350">
+                <a:solidFill>
+                  <a:srgbClr val="333333"/>
+                </a:solidFill>
+                <a:latin typeface="Calibri"/>
+              </a:rPr>
+              <a:t>•  [3] R. P. Sallen and E. L. Key, "A practical method of designing RC active filters," IRE Trans. Circuit Theory, vol. 2, no. 1, pp. 74–85, Mar. 1955.</a:t>
+            </a:r>
+          </a:p>
+          <a:p>
+            <a:pPr>
+              <a:spcAft>
+                <a:spcPts val="700"/>
+              </a:spcAft>
+            </a:pPr>
+            <a:r>
+              <a:rPr sz="1350">
+                <a:solidFill>
+                  <a:srgbClr val="333333"/>
+                </a:solidFill>
+                <a:latin typeface="Calibri"/>
+              </a:rPr>
+              <a:t>•  [4] W. J. Kerwin, L. P. Huelsman, and R. W. Newcomb, "State-variable synthesis for insensitive integrated circuit transfer functions," IEEE J. Solid-State Circuits, vol. 2, no. 3, pp. 87–92, 1967.</a:t>
+            </a:r>
+          </a:p>
+          <a:p>
+            <a:pPr>
+              <a:spcAft>
+                <a:spcPts val="700"/>
+              </a:spcAft>
+            </a:pPr>
+            <a:r>
+              <a:rPr sz="1350">
+                <a:solidFill>
+                  <a:srgbClr val="333333"/>
+                </a:solidFill>
+                <a:latin typeface="Calibri"/>
+              </a:rPr>
+              <a:t>•  [5] A. B. Williams and F. J. Taylor, Electronic Filter Design Handbook, 4th ed. New York: McGraw-Hill, 2006.</a:t>
+            </a:r>
+          </a:p>
+          <a:p>
+            <a:pPr>
+              <a:spcAft>
+                <a:spcPts val="700"/>
+              </a:spcAft>
+            </a:pPr>
+            <a:r>
+              <a:rPr sz="1350">
+                <a:solidFill>
+                  <a:srgbClr val="333333"/>
+                </a:solidFill>
+                <a:latin typeface="Calibri"/>
+              </a:rPr>
+              <a:t>•  [6] R. Schaumann, H. Xiao, and M. E. Van Valkenburg, Design of Analog Filters, 2nd ed. New York: Oxford Univ. Press, 2010.</a:t>
+            </a:r>
+          </a:p>
+          <a:p>
+            <a:pPr>
+              <a:spcAft>
+                <a:spcPts val="700"/>
+              </a:spcAft>
+            </a:pPr>
+            <a:r>
+              <a:rPr sz="1350">
+                <a:solidFill>
+                  <a:srgbClr val="333333"/>
+                </a:solidFill>
+                <a:latin typeface="Calibri"/>
+              </a:rPr>
+              <a:t>•  [7] A. S. Sedra and K. C. Smith, Microelectronic Circuits, 7th ed. New York: Oxford Univ. Press, 2015.</a:t>
+            </a:r>
+          </a:p>
+          <a:p>
+            <a:pPr>
+              <a:spcAft>
+                <a:spcPts val="700"/>
+              </a:spcAft>
+            </a:pPr>
+            <a:r>
+              <a:rPr sz="1350">
+                <a:solidFill>
+                  <a:srgbClr val="333333"/>
+                </a:solidFill>
+                <a:latin typeface="Calibri"/>
+              </a:rPr>
+              <a:t>•  [8] B. Razavi, Design of Analog CMOS Integrated Circuits, 2nd ed. New York: McGraw-Hill, 2017.</a:t>
+            </a:r>
+          </a:p>
+          <a:p>
+            <a:pPr>
+              <a:spcAft>
+                <a:spcPts val="700"/>
+              </a:spcAft>
+            </a:pPr>
+            <a:r>
+              <a:rPr sz="1350">
+                <a:solidFill>
+                  <a:srgbClr val="333333"/>
+                </a:solidFill>
+                <a:latin typeface="Calibri"/>
+              </a:rPr>
+              <a:t>•  [9] I. Podlubny, Fractional Differential Equations. San Diego: Academic Press, 1999.</a:t>
+            </a:r>
+          </a:p>
+          <a:p>
+            <a:pPr>
+              <a:spcAft>
+                <a:spcPts val="700"/>
+              </a:spcAft>
+            </a:pPr>
+            <a:r>
+              <a:rPr sz="1350">
+                <a:solidFill>
+                  <a:srgbClr val="333333"/>
+                </a:solidFill>
+                <a:latin typeface="Calibri"/>
+              </a:rPr>
+              <a:t>•  [10] A. Oustaloup, F. Levron, B. Mathieu, and F. M. Nanot, "Frequency-band complex noninteger differentiator," IEEE Trans. Circuits Syst. I, vol. 47, no. 1, pp. 25–39, 2000.</a:t>
+            </a:r>
+          </a:p>
+        </p:txBody>
+      </p:sp>
+    </p:spTree>
+  </p:cSld>
+  <p:clrMapOvr>
+    <a:masterClrMapping/>
+  </p:clrMapOvr>
+</p:sld>
+</file>
+
+<file path=ppt/slides/slide29.xml><?xml version="1.0" encoding="utf-8"?>
+<p:sld xmlns:a="http://schemas.openxmlformats.org/drawingml/2006/main" xmlns:p="http://schemas.openxmlformats.org/presentationml/2006/main" xmlns:r="http://schemas.openxmlformats.org/officeDocument/2006/relationships">
+  <p:cSld>
+    <p:spTree>
+      <p:nvGrpSpPr>
+        <p:cNvPr id="1" name=""/>
+        <p:cNvGrpSpPr/>
+        <p:nvPr/>
+      </p:nvGrpSpPr>
+      <p:grpSpPr/>
+      <p:sp>
+        <p:nvSpPr>
+          <p:cNvPr id="2" name="Rectangle 1"/>
+          <p:cNvSpPr/>
+          <p:nvPr/>
+        </p:nvSpPr>
+        <p:spPr>
+          <a:xfrm>
+            <a:off x="0" y="0"/>
+            <a:ext cx="12191695" cy="1005840"/>
+          </a:xfrm>
+          <a:prstGeom prst="rect">
+            <a:avLst/>
+          </a:prstGeom>
+          <a:solidFill>
+            <a:srgbClr val="1A1A6A"/>
+          </a:solidFill>
+          <a:ln>
+            <a:noFill/>
+          </a:ln>
+          <a:effectLst/>
+        </p:spPr>
+        <p:style>
+          <a:lnRef idx="1">
+            <a:schemeClr val="accent1"/>
+          </a:lnRef>
+          <a:fillRef idx="3">
+            <a:schemeClr val="accent1"/>
+          </a:fillRef>
+          <a:effectRef idx="2">
+            <a:schemeClr val="accent1"/>
+          </a:effectRef>
+          <a:fontRef idx="minor">
+            <a:schemeClr val="lt1"/>
+          </a:fontRef>
+        </p:style>
+        <p:txBody>
+          <a:bodyPr rtlCol="0" anchor="ctr"/>
+          <a:lstStyle/>
+          <a:p>
+            <a:pPr algn="ctr"/>
+          </a:p>
+        </p:txBody>
+      </p:sp>
+      <p:sp>
+        <p:nvSpPr>
+          <p:cNvPr id="3" name="Rectangle 2"/>
+          <p:cNvSpPr/>
+          <p:nvPr/>
+        </p:nvSpPr>
+        <p:spPr>
+          <a:xfrm>
+            <a:off x="0" y="1005840"/>
+            <a:ext cx="12191695" cy="50292"/>
+          </a:xfrm>
+          <a:prstGeom prst="rect">
+            <a:avLst/>
+          </a:prstGeom>
+          <a:solidFill>
+            <a:srgbClr val="2E5CB8"/>
+          </a:solidFill>
+          <a:ln>
+            <a:noFill/>
+          </a:ln>
+          <a:effectLst/>
+        </p:spPr>
+        <p:style>
+          <a:lnRef idx="1">
+            <a:schemeClr val="accent1"/>
+          </a:lnRef>
+          <a:fillRef idx="3">
+            <a:schemeClr val="accent1"/>
+          </a:fillRef>
+          <a:effectRef idx="2">
+            <a:schemeClr val="accent1"/>
+          </a:effectRef>
+          <a:fontRef idx="minor">
+            <a:schemeClr val="lt1"/>
+          </a:fontRef>
+        </p:style>
+        <p:txBody>
+          <a:bodyPr rtlCol="0" anchor="ctr"/>
+          <a:lstStyle/>
+          <a:p>
+            <a:pPr algn="ctr"/>
+          </a:p>
+        </p:txBody>
+      </p:sp>
+      <p:sp>
+        <p:nvSpPr>
+          <p:cNvPr id="4" name="TextBox 3"/>
+          <p:cNvSpPr txBox="1"/>
+          <p:nvPr/>
+        </p:nvSpPr>
+        <p:spPr>
+          <a:xfrm>
+            <a:off x="502920" y="118872"/>
+            <a:ext cx="10424160" cy="777240"/>
+          </a:xfrm>
+          <a:prstGeom prst="rect">
+            <a:avLst/>
+          </a:prstGeom>
+          <a:noFill/>
+        </p:spPr>
+        <p:txBody>
+          <a:bodyPr wrap="square" anchor="ctr">
+            <a:spAutoFit/>
+          </a:bodyPr>
+          <a:lstStyle/>
+          <a:p>
+            <a:pPr algn="l">
+              <a:spcAft>
+                <a:spcPts val="500"/>
+              </a:spcAft>
+            </a:pPr>
+            <a:r>
+              <a:rPr sz="2500" b="1">
+                <a:solidFill>
+                  <a:srgbClr val="FFFFFF"/>
+                </a:solidFill>
+                <a:latin typeface="Calibri"/>
+              </a:rPr>
+              <a:t>Kaynaklar (2/2) — IEEE</a:t>
+            </a:r>
+          </a:p>
+        </p:txBody>
+      </p:sp>
+      <p:sp>
+        <p:nvSpPr>
+          <p:cNvPr id="5" name="TextBox 4"/>
+          <p:cNvSpPr txBox="1"/>
+          <p:nvPr/>
+        </p:nvSpPr>
+        <p:spPr>
+          <a:xfrm>
+            <a:off x="11155680" y="118872"/>
+            <a:ext cx="822960" cy="777240"/>
+          </a:xfrm>
+          <a:prstGeom prst="rect">
+            <a:avLst/>
+          </a:prstGeom>
+          <a:noFill/>
+        </p:spPr>
+        <p:txBody>
+          <a:bodyPr wrap="square" anchor="ctr">
+            <a:spAutoFit/>
+          </a:bodyPr>
+          <a:lstStyle/>
+          <a:p>
+            <a:pPr algn="r">
+              <a:spcAft>
+                <a:spcPts val="500"/>
+              </a:spcAft>
+            </a:pPr>
+            <a:r>
+              <a:rPr sz="1500" b="1">
+                <a:solidFill>
+                  <a:srgbClr val="EEF4FF"/>
+                </a:solidFill>
+                <a:latin typeface="Calibri"/>
+              </a:rPr>
+              <a:t>29</a:t>
             </a:r>
           </a:p>
         </p:txBody>

</xml_diff>